<commit_message>
Polish reviewer cockpit submission
</commit_message>
<xml_diff>
--- a/Cotiviti_Prompt2_Presentation_Mohammad_Saleh_Nikoopayan_Tak.pptx
+++ b/Cotiviti_Prompt2_Presentation_Mohammad_Saleh_Nikoopayan_Tak.pptx
@@ -2,21 +2,21 @@
 <file path=ppt/presentation.xml><?xml version="1.0" encoding="utf-8"?>
 <p:presentation xmlns:p="http://schemas.openxmlformats.org/presentationml/2006/main">
   <p:sldMasterIdLst>
-    <p:sldMasterId xmlns:r="http://schemas.openxmlformats.org/officeDocument/2006/relationships" id="2147483648" r:id="Ra6709113e2ae4e12"/>
+    <p:sldMasterId xmlns:r="http://schemas.openxmlformats.org/officeDocument/2006/relationships" id="2147483648" r:id="Re189d90aa3924070"/>
   </p:sldMasterIdLst>
   <p:notesMasterIdLst>
-    <p:notesMasterId xmlns:r="http://schemas.openxmlformats.org/officeDocument/2006/relationships" r:id="R7d53dde29a1f4345"/>
+    <p:notesMasterId xmlns:r="http://schemas.openxmlformats.org/officeDocument/2006/relationships" r:id="R85f6fa013b834528"/>
   </p:notesMasterIdLst>
   <p:sldIdLst>
-    <p:sldId xmlns:r="http://schemas.openxmlformats.org/officeDocument/2006/relationships" id="256" r:id="Ree87cfa1fd9444fc"/>
-    <p:sldId xmlns:r="http://schemas.openxmlformats.org/officeDocument/2006/relationships" id="257" r:id="Rb97bdbf693704684"/>
-    <p:sldId xmlns:r="http://schemas.openxmlformats.org/officeDocument/2006/relationships" id="258" r:id="R211b6fb151ad48ff"/>
-    <p:sldId xmlns:r="http://schemas.openxmlformats.org/officeDocument/2006/relationships" id="259" r:id="Rc7209f37e8e34fd6"/>
-    <p:sldId xmlns:r="http://schemas.openxmlformats.org/officeDocument/2006/relationships" id="260" r:id="Rb426190d9b9f4f33"/>
-    <p:sldId xmlns:r="http://schemas.openxmlformats.org/officeDocument/2006/relationships" id="261" r:id="R37952a4130e24388"/>
-    <p:sldId xmlns:r="http://schemas.openxmlformats.org/officeDocument/2006/relationships" id="262" r:id="Rcca7288abceb430d"/>
-    <p:sldId xmlns:r="http://schemas.openxmlformats.org/officeDocument/2006/relationships" id="263" r:id="R5ef46b10e53043b5"/>
-    <p:sldId xmlns:r="http://schemas.openxmlformats.org/officeDocument/2006/relationships" id="264" r:id="R6f6ab377b0fb4781"/>
+    <p:sldId xmlns:r="http://schemas.openxmlformats.org/officeDocument/2006/relationships" id="256" r:id="R7d16006511a84866"/>
+    <p:sldId xmlns:r="http://schemas.openxmlformats.org/officeDocument/2006/relationships" id="257" r:id="R6da1ba873724470d"/>
+    <p:sldId xmlns:r="http://schemas.openxmlformats.org/officeDocument/2006/relationships" id="258" r:id="Rc98ca5c2d3504f42"/>
+    <p:sldId xmlns:r="http://schemas.openxmlformats.org/officeDocument/2006/relationships" id="259" r:id="R786a0190230c42df"/>
+    <p:sldId xmlns:r="http://schemas.openxmlformats.org/officeDocument/2006/relationships" id="260" r:id="R1fccb6c23b354eb1"/>
+    <p:sldId xmlns:r="http://schemas.openxmlformats.org/officeDocument/2006/relationships" id="261" r:id="R7b9d93dd82224840"/>
+    <p:sldId xmlns:r="http://schemas.openxmlformats.org/officeDocument/2006/relationships" id="262" r:id="R164637e931a74842"/>
+    <p:sldId xmlns:r="http://schemas.openxmlformats.org/officeDocument/2006/relationships" id="263" r:id="R78c25a8b6e1f4cf7"/>
+    <p:sldId xmlns:r="http://schemas.openxmlformats.org/officeDocument/2006/relationships" id="264" r:id="R2512f892e8e14789"/>
   </p:sldIdLst>
   <p:sldSz cx="12192000" cy="6858000"/>
   <p:notesSz cx="6858000" cy="9144000"/>
@@ -261,9 +261,9 @@
 </file>
 
 <file path=ppt/notesMasters/theme/theme3.xml><?xml version="1.0" encoding="utf-8"?>
-<a:theme xmlns:a="http://schemas.openxmlformats.org/drawingml/2006/main" name="ChatGPT">
+<a:theme xmlns:a="http://schemas.openxmlformats.org/drawingml/2006/main" name="Cotiviti">
   <a:themeElements>
-    <a:clrScheme name="ChatGPT">
+    <a:clrScheme name="Cotiviti">
       <a:dk1>
         <a:srgbClr val="000000"/>
       </a:dk1>
@@ -313,7 +313,7 @@
         <a:cs typeface="Calibri"/>
       </a:minorFont>
     </a:fontScheme>
-    <a:fmtScheme name="ChatGPT">
+    <a:fmtScheme name="Cotiviti">
       <a:fillStyleLst>
         <a:solidFill>
           <a:schemeClr val="phClr"/>
@@ -550,7 +550,7 @@
           </a:p>
           <a:p xmlns:a="http://schemas.openxmlformats.org/drawingml/2006/main">
             <a:r>
-              <a:t>Say that the report and POC focus on graph pattern recognition, privacy-preserving collaboration, and explainable review queues.</a:t>
+              <a:t>Say that the report and POC focus on graph pattern recognition, privacy-preserving collaboration, and evidence cards for human reviewers.</a:t>
             </a:r>
           </a:p>
         </p:txBody>
@@ -1075,7 +1075,7 @@
           </a:p>
           <a:p xmlns:a="http://schemas.openxmlformats.org/drawingml/2006/main">
             <a:r>
-              <a:t>Keep the demo short: train, federate, click a claim, export packet.</a:t>
+              <a:t>Keep the demo short: train, federate, click a claim, export the evidence card.</a:t>
             </a:r>
           </a:p>
         </p:txBody>
@@ -1218,7 +1218,7 @@
   </p:cSld>
   <p:clrMap bg1="lt1" tx1="dk1" bg2="lt2" tx2="dk2" accent1="accent1" accent2="accent2" accent3="accent3" accent4="accent4" accent5="accent5" accent6="accent6" hlink="hlink" folHlink="folHlink"/>
   <p:sldLayoutIdLst>
-    <p:sldLayoutId xmlns:r="http://schemas.openxmlformats.org/officeDocument/2006/relationships" id="2147483649" r:id="Rfa44fffa67ac46c4"/>
+    <p:sldLayoutId xmlns:r="http://schemas.openxmlformats.org/officeDocument/2006/relationships" id="2147483649" r:id="Rfcb3f0d481234a6f"/>
   </p:sldLayoutIdLst>
   <p:txStyles>
     <p:titleStyle>
@@ -1501,9 +1501,9 @@
 </file>
 
 <file path=ppt/slideMasters/theme/theme2.xml><?xml version="1.0" encoding="utf-8"?>
-<a:theme xmlns:a="http://schemas.openxmlformats.org/drawingml/2006/main" name="ChatGPT">
+<a:theme xmlns:a="http://schemas.openxmlformats.org/drawingml/2006/main" name="Cotiviti">
   <a:themeElements>
-    <a:clrScheme name="ChatGPT">
+    <a:clrScheme name="Cotiviti">
       <a:dk1>
         <a:srgbClr val="000000"/>
       </a:dk1>
@@ -1553,7 +1553,7 @@
         <a:cs typeface="Calibri"/>
       </a:minorFont>
     </a:fontScheme>
-    <a:fmtScheme name="ChatGPT">
+    <a:fmtScheme name="Cotiviti">
       <a:fillStyleLst>
         <a:solidFill>
           <a:schemeClr val="phClr"/>
@@ -1955,7 +1955,7 @@
           <p:cNvPr id="1" name="">
             <a:extLst xmlns:a="http://schemas.openxmlformats.org/drawingml/2006/main">
               <a:ext uri="{FF2B5EF4-FFF2-40B4-BE49-F238E27FC236}">
-                <a16:creationId xmlns:a16="http://schemas.microsoft.com/office/drawing/2014/main" id="{6910844C-1404-44F3-BE66-DAE840BE32EF}"/>
+                <a16:creationId xmlns:a16="http://schemas.microsoft.com/office/drawing/2014/main" id="{333E4FB0-40DA-43F6-A2A1-E6CE8957D947}"/>
               </a:ext>
             </a:extLst>
           </p:cNvPr>
@@ -1986,7 +1986,7 @@
           <p:cNvPr id="2" name="">
             <a:extLst xmlns:a="http://schemas.openxmlformats.org/drawingml/2006/main">
               <a:ext uri="{FF2B5EF4-FFF2-40B4-BE49-F238E27FC236}">
-                <a16:creationId xmlns:a16="http://schemas.microsoft.com/office/drawing/2014/main" id="{4FBB1CE4-5BBF-45B8-BFDD-C87ADDCE0A85}"/>
+                <a16:creationId xmlns:a16="http://schemas.microsoft.com/office/drawing/2014/main" id="{D4B31324-7CE2-4A49-B54F-885206789811}"/>
               </a:ext>
             </a:extLst>
           </p:cNvPr>
@@ -2036,7 +2036,7 @@
           <p:cNvPr id="3" name="">
             <a:extLst xmlns:a="http://schemas.openxmlformats.org/drawingml/2006/main">
               <a:ext uri="{FF2B5EF4-FFF2-40B4-BE49-F238E27FC236}">
-                <a16:creationId xmlns:a16="http://schemas.microsoft.com/office/drawing/2014/main" id="{B2AD89D7-62FB-4507-B523-6120CA343C73}"/>
+                <a16:creationId xmlns:a16="http://schemas.microsoft.com/office/drawing/2014/main" id="{242579DC-6F7B-489D-8154-87BFEF6509CF}"/>
               </a:ext>
             </a:extLst>
           </p:cNvPr>
@@ -2086,7 +2086,7 @@
           <p:cNvPr id="4" name="">
             <a:extLst xmlns:a="http://schemas.openxmlformats.org/drawingml/2006/main">
               <a:ext uri="{FF2B5EF4-FFF2-40B4-BE49-F238E27FC236}">
-                <a16:creationId xmlns:a16="http://schemas.microsoft.com/office/drawing/2014/main" id="{01668B62-DFDD-404D-8056-24D2E2C9E608}"/>
+                <a16:creationId xmlns:a16="http://schemas.microsoft.com/office/drawing/2014/main" id="{C3B80134-27D8-49AF-9F3F-3E9CBC320C51}"/>
               </a:ext>
             </a:extLst>
           </p:cNvPr>
@@ -2126,7 +2126,7 @@
                   <a:srgbClr val="5F6975"/>
                 </a:solidFill>
               </a:rPr>
-              <a:t>Payment integrity with privacy-preserving pattern recognition and auditor-ready evidence chains</a:t>
+              <a:t>A reviewer cockpit for privacy-preserving pattern recognition and auditor-ready evidence cards</a:t>
             </a:r>
           </a:p>
         </p:txBody>
@@ -2136,7 +2136,7 @@
           <p:cNvPr id="5" name="">
             <a:extLst xmlns:a="http://schemas.openxmlformats.org/drawingml/2006/main">
               <a:ext uri="{FF2B5EF4-FFF2-40B4-BE49-F238E27FC236}">
-                <a16:creationId xmlns:a16="http://schemas.microsoft.com/office/drawing/2014/main" id="{4F965BE8-2D42-44D6-924B-2BBD4BE54572}"/>
+                <a16:creationId xmlns:a16="http://schemas.microsoft.com/office/drawing/2014/main" id="{57A6D522-921D-4F49-B289-2FD1E39B7FFD}"/>
               </a:ext>
             </a:extLst>
           </p:cNvPr>
@@ -2186,7 +2186,7 @@
           <p:cNvPr id="6" name="">
             <a:extLst xmlns:a="http://schemas.openxmlformats.org/drawingml/2006/main">
               <a:ext uri="{FF2B5EF4-FFF2-40B4-BE49-F238E27FC236}">
-                <a16:creationId xmlns:a16="http://schemas.microsoft.com/office/drawing/2014/main" id="{36EB1020-16E9-4B09-87B7-32782BC8D21D}"/>
+                <a16:creationId xmlns:a16="http://schemas.microsoft.com/office/drawing/2014/main" id="{758B0218-F352-498E-B625-1C936761EAD7}"/>
               </a:ext>
             </a:extLst>
           </p:cNvPr>
@@ -2236,7 +2236,7 @@
           <p:cNvPr id="7" name="">
             <a:extLst xmlns:a="http://schemas.openxmlformats.org/drawingml/2006/main">
               <a:ext uri="{FF2B5EF4-FFF2-40B4-BE49-F238E27FC236}">
-                <a16:creationId xmlns:a16="http://schemas.microsoft.com/office/drawing/2014/main" id="{F9ED18C3-B8B0-413F-AE00-D48008897091}"/>
+                <a16:creationId xmlns:a16="http://schemas.microsoft.com/office/drawing/2014/main" id="{588B3847-0894-4E7D-BA59-AE90C5347620}"/>
               </a:ext>
             </a:extLst>
           </p:cNvPr>
@@ -2269,7 +2269,7 @@
           <p:cNvPr id="8" name="">
             <a:extLst xmlns:a="http://schemas.openxmlformats.org/drawingml/2006/main">
               <a:ext uri="{FF2B5EF4-FFF2-40B4-BE49-F238E27FC236}">
-                <a16:creationId xmlns:a16="http://schemas.microsoft.com/office/drawing/2014/main" id="{C5569743-00FD-4B2B-B75C-0359239BCDC6}"/>
+                <a16:creationId xmlns:a16="http://schemas.microsoft.com/office/drawing/2014/main" id="{42D13F94-4940-4100-85C7-766EA269349B}"/>
               </a:ext>
             </a:extLst>
           </p:cNvPr>
@@ -2300,7 +2300,7 @@
           <p:cNvPr id="9" name="">
             <a:extLst xmlns:a="http://schemas.openxmlformats.org/drawingml/2006/main">
               <a:ext uri="{FF2B5EF4-FFF2-40B4-BE49-F238E27FC236}">
-                <a16:creationId xmlns:a16="http://schemas.microsoft.com/office/drawing/2014/main" id="{669FF410-8892-4C0E-B35B-6F7F15D50BDC}"/>
+                <a16:creationId xmlns:a16="http://schemas.microsoft.com/office/drawing/2014/main" id="{66197951-C453-46BE-BF02-F61669AD0958}"/>
               </a:ext>
             </a:extLst>
           </p:cNvPr>
@@ -2331,7 +2331,7 @@
           <p:cNvPr id="10" name="">
             <a:extLst xmlns:a="http://schemas.openxmlformats.org/drawingml/2006/main">
               <a:ext uri="{FF2B5EF4-FFF2-40B4-BE49-F238E27FC236}">
-                <a16:creationId xmlns:a16="http://schemas.microsoft.com/office/drawing/2014/main" id="{C2CBAFC4-2368-43F6-B2D3-F14ADF0648A9}"/>
+                <a16:creationId xmlns:a16="http://schemas.microsoft.com/office/drawing/2014/main" id="{75AC064E-56B6-4829-B9F5-91499CF040E0}"/>
               </a:ext>
             </a:extLst>
           </p:cNvPr>
@@ -2362,7 +2362,7 @@
           <p:cNvPr id="11" name="">
             <a:extLst xmlns:a="http://schemas.openxmlformats.org/drawingml/2006/main">
               <a:ext uri="{FF2B5EF4-FFF2-40B4-BE49-F238E27FC236}">
-                <a16:creationId xmlns:a16="http://schemas.microsoft.com/office/drawing/2014/main" id="{4A79217B-D6C7-466E-9DD9-B67C2099CFD7}"/>
+                <a16:creationId xmlns:a16="http://schemas.microsoft.com/office/drawing/2014/main" id="{06C924C0-AEB0-4C1D-94FA-D5E1C696511E}"/>
               </a:ext>
             </a:extLst>
           </p:cNvPr>
@@ -2393,7 +2393,7 @@
           <p:cNvPr id="12" name="">
             <a:extLst xmlns:a="http://schemas.openxmlformats.org/drawingml/2006/main">
               <a:ext uri="{FF2B5EF4-FFF2-40B4-BE49-F238E27FC236}">
-                <a16:creationId xmlns:a16="http://schemas.microsoft.com/office/drawing/2014/main" id="{1FE73771-2B63-4697-8B27-FAB0698B230D}"/>
+                <a16:creationId xmlns:a16="http://schemas.microsoft.com/office/drawing/2014/main" id="{E0C53AB9-8A1D-422D-98BB-646A4821CF1B}"/>
               </a:ext>
             </a:extLst>
           </p:cNvPr>
@@ -2426,7 +2426,7 @@
           <p:cNvPr id="13" name="">
             <a:extLst xmlns:a="http://schemas.openxmlformats.org/drawingml/2006/main">
               <a:ext uri="{FF2B5EF4-FFF2-40B4-BE49-F238E27FC236}">
-                <a16:creationId xmlns:a16="http://schemas.microsoft.com/office/drawing/2014/main" id="{B43A5F5F-851E-4F3F-951C-BBC604A74D30}"/>
+                <a16:creationId xmlns:a16="http://schemas.microsoft.com/office/drawing/2014/main" id="{1E7894F3-7F76-4ACC-BAFE-D07D84C82ECE}"/>
               </a:ext>
             </a:extLst>
           </p:cNvPr>
@@ -2476,7 +2476,7 @@
           <p:cNvPr id="14" name="">
             <a:extLst xmlns:a="http://schemas.openxmlformats.org/drawingml/2006/main">
               <a:ext uri="{FF2B5EF4-FFF2-40B4-BE49-F238E27FC236}">
-                <a16:creationId xmlns:a16="http://schemas.microsoft.com/office/drawing/2014/main" id="{9D2BC574-1547-4779-B679-737136D17B9A}"/>
+                <a16:creationId xmlns:a16="http://schemas.microsoft.com/office/drawing/2014/main" id="{37845CD2-93F7-4BFC-BCF6-211B69B9FB88}"/>
               </a:ext>
             </a:extLst>
           </p:cNvPr>
@@ -2509,7 +2509,7 @@
           <p:cNvPr id="15" name="">
             <a:extLst xmlns:a="http://schemas.openxmlformats.org/drawingml/2006/main">
               <a:ext uri="{FF2B5EF4-FFF2-40B4-BE49-F238E27FC236}">
-                <a16:creationId xmlns:a16="http://schemas.microsoft.com/office/drawing/2014/main" id="{D365D8EC-9B66-4A9F-A047-A5B521A36FA1}"/>
+                <a16:creationId xmlns:a16="http://schemas.microsoft.com/office/drawing/2014/main" id="{F2720D1D-A8E2-4250-8D9C-9A314584EDA5}"/>
               </a:ext>
             </a:extLst>
           </p:cNvPr>
@@ -2559,7 +2559,7 @@
           <p:cNvPr id="16" name="">
             <a:extLst xmlns:a="http://schemas.openxmlformats.org/drawingml/2006/main">
               <a:ext uri="{FF2B5EF4-FFF2-40B4-BE49-F238E27FC236}">
-                <a16:creationId xmlns:a16="http://schemas.microsoft.com/office/drawing/2014/main" id="{E542D20B-890F-443C-8195-89CF2E19BBEE}"/>
+                <a16:creationId xmlns:a16="http://schemas.microsoft.com/office/drawing/2014/main" id="{EE035EF8-D8B5-4FBB-9780-42FCBCC628FD}"/>
               </a:ext>
             </a:extLst>
           </p:cNvPr>
@@ -2592,7 +2592,7 @@
           <p:cNvPr id="17" name="">
             <a:extLst xmlns:a="http://schemas.openxmlformats.org/drawingml/2006/main">
               <a:ext uri="{FF2B5EF4-FFF2-40B4-BE49-F238E27FC236}">
-                <a16:creationId xmlns:a16="http://schemas.microsoft.com/office/drawing/2014/main" id="{F005E7AA-871E-4ADA-84EF-A4FAD01ED95F}"/>
+                <a16:creationId xmlns:a16="http://schemas.microsoft.com/office/drawing/2014/main" id="{D7B8D030-B42F-4AD6-A507-3887616F45F9}"/>
               </a:ext>
             </a:extLst>
           </p:cNvPr>
@@ -2642,7 +2642,7 @@
           <p:cNvPr id="18" name="">
             <a:extLst xmlns:a="http://schemas.openxmlformats.org/drawingml/2006/main">
               <a:ext uri="{FF2B5EF4-FFF2-40B4-BE49-F238E27FC236}">
-                <a16:creationId xmlns:a16="http://schemas.microsoft.com/office/drawing/2014/main" id="{EBBB55D7-B087-4E35-ACF0-0F3698BC2034}"/>
+                <a16:creationId xmlns:a16="http://schemas.microsoft.com/office/drawing/2014/main" id="{4603F448-AE60-4C8B-A4CD-9051F3F8E4AE}"/>
               </a:ext>
             </a:extLst>
           </p:cNvPr>
@@ -2675,7 +2675,7 @@
           <p:cNvPr id="19" name="">
             <a:extLst xmlns:a="http://schemas.openxmlformats.org/drawingml/2006/main">
               <a:ext uri="{FF2B5EF4-FFF2-40B4-BE49-F238E27FC236}">
-                <a16:creationId xmlns:a16="http://schemas.microsoft.com/office/drawing/2014/main" id="{40D271A3-6018-4B2B-AA1D-088C9E09EF75}"/>
+                <a16:creationId xmlns:a16="http://schemas.microsoft.com/office/drawing/2014/main" id="{EA5B4327-0255-45B4-BB51-23066F60DF18}"/>
               </a:ext>
             </a:extLst>
           </p:cNvPr>
@@ -2725,7 +2725,7 @@
           <p:cNvPr id="20" name="">
             <a:extLst xmlns:a="http://schemas.openxmlformats.org/drawingml/2006/main">
               <a:ext uri="{FF2B5EF4-FFF2-40B4-BE49-F238E27FC236}">
-                <a16:creationId xmlns:a16="http://schemas.microsoft.com/office/drawing/2014/main" id="{10957507-73A6-4D47-B50B-F6E892340C27}"/>
+                <a16:creationId xmlns:a16="http://schemas.microsoft.com/office/drawing/2014/main" id="{8BB20BC0-97C8-4360-A470-56EBAB03E07D}"/>
               </a:ext>
             </a:extLst>
           </p:cNvPr>
@@ -2758,7 +2758,7 @@
           <p:cNvPr id="21" name="">
             <a:extLst xmlns:a="http://schemas.openxmlformats.org/drawingml/2006/main">
               <a:ext uri="{FF2B5EF4-FFF2-40B4-BE49-F238E27FC236}">
-                <a16:creationId xmlns:a16="http://schemas.microsoft.com/office/drawing/2014/main" id="{C76BB40C-E9C4-4770-B294-5579FB4918FD}"/>
+                <a16:creationId xmlns:a16="http://schemas.microsoft.com/office/drawing/2014/main" id="{A80C8BC9-1208-4468-8F0B-BEF22BE52AD1}"/>
               </a:ext>
             </a:extLst>
           </p:cNvPr>
@@ -2808,7 +2808,7 @@
           <p:cNvPr id="22" name="">
             <a:extLst xmlns:a="http://schemas.openxmlformats.org/drawingml/2006/main">
               <a:ext uri="{FF2B5EF4-FFF2-40B4-BE49-F238E27FC236}">
-                <a16:creationId xmlns:a16="http://schemas.microsoft.com/office/drawing/2014/main" id="{9CB4C544-CD04-4293-97BF-DD2C477FB720}"/>
+                <a16:creationId xmlns:a16="http://schemas.microsoft.com/office/drawing/2014/main" id="{A2F14302-6F51-4EC9-9DF7-35EB968B2409}"/>
               </a:ext>
             </a:extLst>
           </p:cNvPr>
@@ -2846,7 +2846,7 @@
           <p:cNvPr id="23" name="">
             <a:extLst xmlns:a="http://schemas.openxmlformats.org/drawingml/2006/main">
               <a:ext uri="{FF2B5EF4-FFF2-40B4-BE49-F238E27FC236}">
-                <a16:creationId xmlns:a16="http://schemas.microsoft.com/office/drawing/2014/main" id="{ECBA5058-1B6D-476D-B2A4-4AA2FEB8F6C9}"/>
+                <a16:creationId xmlns:a16="http://schemas.microsoft.com/office/drawing/2014/main" id="{9C3E62E1-1309-4E54-A35F-C41600C9503C}"/>
               </a:ext>
             </a:extLst>
           </p:cNvPr>
@@ -2894,7 +2894,7 @@
     </p:spTree>
     <p:extLst>
       <p:ext uri="{BB962C8B-B14F-4D97-AF65-F5344CB8AC3E}">
-        <p14:creationId xmlns:p14="http://schemas.microsoft.com/office/powerpoint/2010/main" val="2088202205"/>
+        <p14:creationId xmlns:p14="http://schemas.microsoft.com/office/powerpoint/2010/main" val="500654687"/>
       </p:ext>
     </p:extLst>
   </p:cSld>
@@ -2925,7 +2925,7 @@
           <p:cNvPr id="1" name="">
             <a:extLst xmlns:a="http://schemas.openxmlformats.org/drawingml/2006/main">
               <a:ext uri="{FF2B5EF4-FFF2-40B4-BE49-F238E27FC236}">
-                <a16:creationId xmlns:a16="http://schemas.microsoft.com/office/drawing/2014/main" id="{CC354147-0807-47EB-995D-72BF685505D9}"/>
+                <a16:creationId xmlns:a16="http://schemas.microsoft.com/office/drawing/2014/main" id="{A2E7D38D-7D04-4085-AE23-C795193C26FC}"/>
               </a:ext>
             </a:extLst>
           </p:cNvPr>
@@ -2975,7 +2975,7 @@
           <p:cNvPr id="2" name="">
             <a:extLst xmlns:a="http://schemas.openxmlformats.org/drawingml/2006/main">
               <a:ext uri="{FF2B5EF4-FFF2-40B4-BE49-F238E27FC236}">
-                <a16:creationId xmlns:a16="http://schemas.microsoft.com/office/drawing/2014/main" id="{3F36A350-9A5F-427C-BD30-925833DCD3A4}"/>
+                <a16:creationId xmlns:a16="http://schemas.microsoft.com/office/drawing/2014/main" id="{7199FDF0-A8BE-48FD-9130-81F14437FD7F}"/>
               </a:ext>
             </a:extLst>
           </p:cNvPr>
@@ -3025,7 +3025,7 @@
           <p:cNvPr id="3" name="">
             <a:extLst xmlns:a="http://schemas.openxmlformats.org/drawingml/2006/main">
               <a:ext uri="{FF2B5EF4-FFF2-40B4-BE49-F238E27FC236}">
-                <a16:creationId xmlns:a16="http://schemas.microsoft.com/office/drawing/2014/main" id="{CD5FBB1E-BD65-4CF5-A743-141910352025}"/>
+                <a16:creationId xmlns:a16="http://schemas.microsoft.com/office/drawing/2014/main" id="{B6797796-C59C-447B-9AD3-A820650EB383}"/>
               </a:ext>
             </a:extLst>
           </p:cNvPr>
@@ -3075,7 +3075,7 @@
           <p:cNvPr id="4" name="">
             <a:extLst xmlns:a="http://schemas.openxmlformats.org/drawingml/2006/main">
               <a:ext uri="{FF2B5EF4-FFF2-40B4-BE49-F238E27FC236}">
-                <a16:creationId xmlns:a16="http://schemas.microsoft.com/office/drawing/2014/main" id="{75531089-950D-4779-9C79-9E0C50242989}"/>
+                <a16:creationId xmlns:a16="http://schemas.microsoft.com/office/drawing/2014/main" id="{75C8B4DA-7E15-4F14-AB86-C20C45B75927}"/>
               </a:ext>
             </a:extLst>
           </p:cNvPr>
@@ -3125,7 +3125,7 @@
           <p:cNvPr id="5" name="">
             <a:extLst xmlns:a="http://schemas.openxmlformats.org/drawingml/2006/main">
               <a:ext uri="{FF2B5EF4-FFF2-40B4-BE49-F238E27FC236}">
-                <a16:creationId xmlns:a16="http://schemas.microsoft.com/office/drawing/2014/main" id="{EE3E1182-3512-4E63-B2A2-838A73023ED2}"/>
+                <a16:creationId xmlns:a16="http://schemas.microsoft.com/office/drawing/2014/main" id="{6129794A-55E8-470C-A09B-A136897CB860}"/>
               </a:ext>
             </a:extLst>
           </p:cNvPr>
@@ -3175,7 +3175,7 @@
           <p:cNvPr id="6" name="">
             <a:extLst xmlns:a="http://schemas.openxmlformats.org/drawingml/2006/main">
               <a:ext uri="{FF2B5EF4-FFF2-40B4-BE49-F238E27FC236}">
-                <a16:creationId xmlns:a16="http://schemas.microsoft.com/office/drawing/2014/main" id="{4AAD0442-540E-4745-B12A-2325EBCB89B3}"/>
+                <a16:creationId xmlns:a16="http://schemas.microsoft.com/office/drawing/2014/main" id="{72195D31-45F5-4191-A40D-EA3A986656F9}"/>
               </a:ext>
             </a:extLst>
           </p:cNvPr>
@@ -3206,7 +3206,7 @@
           <p:cNvPr id="7" name="">
             <a:extLst xmlns:a="http://schemas.openxmlformats.org/drawingml/2006/main">
               <a:ext uri="{FF2B5EF4-FFF2-40B4-BE49-F238E27FC236}">
-                <a16:creationId xmlns:a16="http://schemas.microsoft.com/office/drawing/2014/main" id="{7CE318D9-69A0-4909-A1B4-88A3D87AE706}"/>
+                <a16:creationId xmlns:a16="http://schemas.microsoft.com/office/drawing/2014/main" id="{68D65F50-AC3C-4E90-9597-3B150634D5C0}"/>
               </a:ext>
             </a:extLst>
           </p:cNvPr>
@@ -3256,7 +3256,7 @@
           <p:cNvPr id="8" name="">
             <a:extLst xmlns:a="http://schemas.openxmlformats.org/drawingml/2006/main">
               <a:ext uri="{FF2B5EF4-FFF2-40B4-BE49-F238E27FC236}">
-                <a16:creationId xmlns:a16="http://schemas.microsoft.com/office/drawing/2014/main" id="{B961E97A-D154-4AD2-BACE-F1CAD820BC54}"/>
+                <a16:creationId xmlns:a16="http://schemas.microsoft.com/office/drawing/2014/main" id="{8F542300-9FAC-4D52-B890-6B2ACE1300F9}"/>
               </a:ext>
             </a:extLst>
           </p:cNvPr>
@@ -3287,7 +3287,7 @@
           <p:cNvPr id="9" name="">
             <a:extLst xmlns:a="http://schemas.openxmlformats.org/drawingml/2006/main">
               <a:ext uri="{FF2B5EF4-FFF2-40B4-BE49-F238E27FC236}">
-                <a16:creationId xmlns:a16="http://schemas.microsoft.com/office/drawing/2014/main" id="{F150B0F1-13F5-4816-8731-EE4B9652F29F}"/>
+                <a16:creationId xmlns:a16="http://schemas.microsoft.com/office/drawing/2014/main" id="{70D5804F-9F56-4EE4-AA46-A0199E30E607}"/>
               </a:ext>
             </a:extLst>
           </p:cNvPr>
@@ -3337,7 +3337,7 @@
           <p:cNvPr id="10" name="">
             <a:extLst xmlns:a="http://schemas.openxmlformats.org/drawingml/2006/main">
               <a:ext uri="{FF2B5EF4-FFF2-40B4-BE49-F238E27FC236}">
-                <a16:creationId xmlns:a16="http://schemas.microsoft.com/office/drawing/2014/main" id="{C8D4C664-686E-4522-ADBA-6AFCEDFE18AF}"/>
+                <a16:creationId xmlns:a16="http://schemas.microsoft.com/office/drawing/2014/main" id="{08EAD630-A18D-453D-B5C6-51151FD9C8C7}"/>
               </a:ext>
             </a:extLst>
           </p:cNvPr>
@@ -3368,7 +3368,7 @@
           <p:cNvPr id="11" name="">
             <a:extLst xmlns:a="http://schemas.openxmlformats.org/drawingml/2006/main">
               <a:ext uri="{FF2B5EF4-FFF2-40B4-BE49-F238E27FC236}">
-                <a16:creationId xmlns:a16="http://schemas.microsoft.com/office/drawing/2014/main" id="{9697CF07-19FB-4019-A73E-3F4F638E5CE1}"/>
+                <a16:creationId xmlns:a16="http://schemas.microsoft.com/office/drawing/2014/main" id="{CEB72645-7CB6-4F41-8803-1E69368B8D88}"/>
               </a:ext>
             </a:extLst>
           </p:cNvPr>
@@ -3418,7 +3418,7 @@
           <p:cNvPr id="12" name="">
             <a:extLst xmlns:a="http://schemas.openxmlformats.org/drawingml/2006/main">
               <a:ext uri="{FF2B5EF4-FFF2-40B4-BE49-F238E27FC236}">
-                <a16:creationId xmlns:a16="http://schemas.microsoft.com/office/drawing/2014/main" id="{777AB255-2E16-44B0-8522-AD893B13679E}"/>
+                <a16:creationId xmlns:a16="http://schemas.microsoft.com/office/drawing/2014/main" id="{28AB3E07-E011-4A6C-BFA8-DC6C9730A394}"/>
               </a:ext>
             </a:extLst>
           </p:cNvPr>
@@ -3449,7 +3449,7 @@
           <p:cNvPr id="13" name="">
             <a:extLst xmlns:a="http://schemas.openxmlformats.org/drawingml/2006/main">
               <a:ext uri="{FF2B5EF4-FFF2-40B4-BE49-F238E27FC236}">
-                <a16:creationId xmlns:a16="http://schemas.microsoft.com/office/drawing/2014/main" id="{C9D670BC-371F-4419-9EEF-AE58053E2B6F}"/>
+                <a16:creationId xmlns:a16="http://schemas.microsoft.com/office/drawing/2014/main" id="{526BCF11-EB27-4210-AD54-6A5818EC632B}"/>
               </a:ext>
             </a:extLst>
           </p:cNvPr>
@@ -3499,7 +3499,7 @@
           <p:cNvPr id="14" name="">
             <a:extLst xmlns:a="http://schemas.openxmlformats.org/drawingml/2006/main">
               <a:ext uri="{FF2B5EF4-FFF2-40B4-BE49-F238E27FC236}">
-                <a16:creationId xmlns:a16="http://schemas.microsoft.com/office/drawing/2014/main" id="{D13879E2-C497-49E5-8E3F-702E47A17C31}"/>
+                <a16:creationId xmlns:a16="http://schemas.microsoft.com/office/drawing/2014/main" id="{1496EDA2-88DB-4D35-A07A-7E138A85787A}"/>
               </a:ext>
             </a:extLst>
           </p:cNvPr>
@@ -3532,7 +3532,7 @@
           <p:cNvPr id="15" name="">
             <a:extLst xmlns:a="http://schemas.openxmlformats.org/drawingml/2006/main">
               <a:ext uri="{FF2B5EF4-FFF2-40B4-BE49-F238E27FC236}">
-                <a16:creationId xmlns:a16="http://schemas.microsoft.com/office/drawing/2014/main" id="{2BCFA775-6670-4D6A-A8C4-7399687F50CC}"/>
+                <a16:creationId xmlns:a16="http://schemas.microsoft.com/office/drawing/2014/main" id="{9513125A-9688-45E3-A10A-07A93F88084E}"/>
               </a:ext>
             </a:extLst>
           </p:cNvPr>
@@ -3563,7 +3563,7 @@
           <p:cNvPr id="16" name="">
             <a:extLst xmlns:a="http://schemas.openxmlformats.org/drawingml/2006/main">
               <a:ext uri="{FF2B5EF4-FFF2-40B4-BE49-F238E27FC236}">
-                <a16:creationId xmlns:a16="http://schemas.microsoft.com/office/drawing/2014/main" id="{2C7D7BFE-B11D-4DE6-9334-2CE5276CE122}"/>
+                <a16:creationId xmlns:a16="http://schemas.microsoft.com/office/drawing/2014/main" id="{22609A9F-23AB-4F2F-AA8F-59AB78C57B67}"/>
               </a:ext>
             </a:extLst>
           </p:cNvPr>
@@ -3594,7 +3594,7 @@
           <p:cNvPr id="17" name="">
             <a:extLst xmlns:a="http://schemas.openxmlformats.org/drawingml/2006/main">
               <a:ext uri="{FF2B5EF4-FFF2-40B4-BE49-F238E27FC236}">
-                <a16:creationId xmlns:a16="http://schemas.microsoft.com/office/drawing/2014/main" id="{0B362F61-577D-431F-9571-A2F76F477CD0}"/>
+                <a16:creationId xmlns:a16="http://schemas.microsoft.com/office/drawing/2014/main" id="{BF63DF53-D47B-48C0-8A7C-0FEE9D748EBB}"/>
               </a:ext>
             </a:extLst>
           </p:cNvPr>
@@ -3625,7 +3625,7 @@
           <p:cNvPr id="18" name="">
             <a:extLst xmlns:a="http://schemas.openxmlformats.org/drawingml/2006/main">
               <a:ext uri="{FF2B5EF4-FFF2-40B4-BE49-F238E27FC236}">
-                <a16:creationId xmlns:a16="http://schemas.microsoft.com/office/drawing/2014/main" id="{3091318B-146D-4A30-A455-B1DDF6B07080}"/>
+                <a16:creationId xmlns:a16="http://schemas.microsoft.com/office/drawing/2014/main" id="{AF776E2A-9766-4433-9A42-2D3989C4FFF4}"/>
               </a:ext>
             </a:extLst>
           </p:cNvPr>
@@ -3656,7 +3656,7 @@
           <p:cNvPr id="19" name="">
             <a:extLst xmlns:a="http://schemas.openxmlformats.org/drawingml/2006/main">
               <a:ext uri="{FF2B5EF4-FFF2-40B4-BE49-F238E27FC236}">
-                <a16:creationId xmlns:a16="http://schemas.microsoft.com/office/drawing/2014/main" id="{A4CD14FC-80B1-46FA-B83D-F3EB663F0611}"/>
+                <a16:creationId xmlns:a16="http://schemas.microsoft.com/office/drawing/2014/main" id="{C30223B0-CD73-4F1C-A1A0-CFA1683F6B0C}"/>
               </a:ext>
             </a:extLst>
           </p:cNvPr>
@@ -3687,7 +3687,7 @@
           <p:cNvPr id="20" name="">
             <a:extLst xmlns:a="http://schemas.openxmlformats.org/drawingml/2006/main">
               <a:ext uri="{FF2B5EF4-FFF2-40B4-BE49-F238E27FC236}">
-                <a16:creationId xmlns:a16="http://schemas.microsoft.com/office/drawing/2014/main" id="{62CCFDC6-AE61-4E5D-BA78-4273910AB20E}"/>
+                <a16:creationId xmlns:a16="http://schemas.microsoft.com/office/drawing/2014/main" id="{C976F17C-92A8-447A-AF5B-AAEAC6E5DD0B}"/>
               </a:ext>
             </a:extLst>
           </p:cNvPr>
@@ -3720,7 +3720,7 @@
           <p:cNvPr id="21" name="">
             <a:extLst xmlns:a="http://schemas.openxmlformats.org/drawingml/2006/main">
               <a:ext uri="{FF2B5EF4-FFF2-40B4-BE49-F238E27FC236}">
-                <a16:creationId xmlns:a16="http://schemas.microsoft.com/office/drawing/2014/main" id="{0CAA4920-BEDE-4486-80A9-380130341DD6}"/>
+                <a16:creationId xmlns:a16="http://schemas.microsoft.com/office/drawing/2014/main" id="{546A718E-7AA3-4AED-ABA5-D9E12421469C}"/>
               </a:ext>
             </a:extLst>
           </p:cNvPr>
@@ -3770,7 +3770,7 @@
           <p:cNvPr id="22" name="">
             <a:extLst xmlns:a="http://schemas.openxmlformats.org/drawingml/2006/main">
               <a:ext uri="{FF2B5EF4-FFF2-40B4-BE49-F238E27FC236}">
-                <a16:creationId xmlns:a16="http://schemas.microsoft.com/office/drawing/2014/main" id="{4DD4C572-DB12-44C0-A2EC-F7A6A6E21567}"/>
+                <a16:creationId xmlns:a16="http://schemas.microsoft.com/office/drawing/2014/main" id="{E8BCDD4A-4055-44BE-A09B-7A2A563313BE}"/>
               </a:ext>
             </a:extLst>
           </p:cNvPr>
@@ -3803,7 +3803,7 @@
           <p:cNvPr id="23" name="">
             <a:extLst xmlns:a="http://schemas.openxmlformats.org/drawingml/2006/main">
               <a:ext uri="{FF2B5EF4-FFF2-40B4-BE49-F238E27FC236}">
-                <a16:creationId xmlns:a16="http://schemas.microsoft.com/office/drawing/2014/main" id="{D12D7F19-5E6A-4737-894D-914FAA835A21}"/>
+                <a16:creationId xmlns:a16="http://schemas.microsoft.com/office/drawing/2014/main" id="{8F1D4DEA-CEC9-4A32-ADF6-63F57D2D2968}"/>
               </a:ext>
             </a:extLst>
           </p:cNvPr>
@@ -3853,7 +3853,7 @@
           <p:cNvPr id="24" name="">
             <a:extLst xmlns:a="http://schemas.openxmlformats.org/drawingml/2006/main">
               <a:ext uri="{FF2B5EF4-FFF2-40B4-BE49-F238E27FC236}">
-                <a16:creationId xmlns:a16="http://schemas.microsoft.com/office/drawing/2014/main" id="{B65B3847-0A8A-46CE-9B48-EEEF17334CA4}"/>
+                <a16:creationId xmlns:a16="http://schemas.microsoft.com/office/drawing/2014/main" id="{B22CEE54-A8EF-428D-A9FD-C72486213ED4}"/>
               </a:ext>
             </a:extLst>
           </p:cNvPr>
@@ -3886,7 +3886,7 @@
           <p:cNvPr id="25" name="">
             <a:extLst xmlns:a="http://schemas.openxmlformats.org/drawingml/2006/main">
               <a:ext uri="{FF2B5EF4-FFF2-40B4-BE49-F238E27FC236}">
-                <a16:creationId xmlns:a16="http://schemas.microsoft.com/office/drawing/2014/main" id="{DBB1C8B2-D8C1-468D-BC6C-2E913349DF1B}"/>
+                <a16:creationId xmlns:a16="http://schemas.microsoft.com/office/drawing/2014/main" id="{38A48051-1CC6-45BA-88A6-51DA9AF784C3}"/>
               </a:ext>
             </a:extLst>
           </p:cNvPr>
@@ -3936,7 +3936,7 @@
           <p:cNvPr id="26" name="">
             <a:extLst xmlns:a="http://schemas.openxmlformats.org/drawingml/2006/main">
               <a:ext uri="{FF2B5EF4-FFF2-40B4-BE49-F238E27FC236}">
-                <a16:creationId xmlns:a16="http://schemas.microsoft.com/office/drawing/2014/main" id="{5E40E5CD-BF0D-49AE-8CC5-70B571B3AACF}"/>
+                <a16:creationId xmlns:a16="http://schemas.microsoft.com/office/drawing/2014/main" id="{63AFD828-5AD5-4423-9BF4-42339A653887}"/>
               </a:ext>
             </a:extLst>
           </p:cNvPr>
@@ -3969,7 +3969,7 @@
           <p:cNvPr id="27" name="">
             <a:extLst xmlns:a="http://schemas.openxmlformats.org/drawingml/2006/main">
               <a:ext uri="{FF2B5EF4-FFF2-40B4-BE49-F238E27FC236}">
-                <a16:creationId xmlns:a16="http://schemas.microsoft.com/office/drawing/2014/main" id="{EDFFED3B-3D23-4EAE-9C81-BD30BACD0923}"/>
+                <a16:creationId xmlns:a16="http://schemas.microsoft.com/office/drawing/2014/main" id="{DBE07792-A1BD-4187-A69E-4295633447F8}"/>
               </a:ext>
             </a:extLst>
           </p:cNvPr>
@@ -4019,7 +4019,7 @@
           <p:cNvPr id="28" name="">
             <a:extLst xmlns:a="http://schemas.openxmlformats.org/drawingml/2006/main">
               <a:ext uri="{FF2B5EF4-FFF2-40B4-BE49-F238E27FC236}">
-                <a16:creationId xmlns:a16="http://schemas.microsoft.com/office/drawing/2014/main" id="{4872BB8E-F337-4CA0-9798-AE0B97C13B2C}"/>
+                <a16:creationId xmlns:a16="http://schemas.microsoft.com/office/drawing/2014/main" id="{25339674-7D58-478D-A967-4901F4CBCBE0}"/>
               </a:ext>
             </a:extLst>
           </p:cNvPr>
@@ -4052,7 +4052,7 @@
           <p:cNvPr id="29" name="">
             <a:extLst xmlns:a="http://schemas.openxmlformats.org/drawingml/2006/main">
               <a:ext uri="{FF2B5EF4-FFF2-40B4-BE49-F238E27FC236}">
-                <a16:creationId xmlns:a16="http://schemas.microsoft.com/office/drawing/2014/main" id="{ECEB4567-08D4-4209-9ACD-3D9BE0E94298}"/>
+                <a16:creationId xmlns:a16="http://schemas.microsoft.com/office/drawing/2014/main" id="{112B70A8-E859-428F-A5AD-F7715717D067}"/>
               </a:ext>
             </a:extLst>
           </p:cNvPr>
@@ -4102,7 +4102,7 @@
           <p:cNvPr id="30" name="">
             <a:extLst xmlns:a="http://schemas.openxmlformats.org/drawingml/2006/main">
               <a:ext uri="{FF2B5EF4-FFF2-40B4-BE49-F238E27FC236}">
-                <a16:creationId xmlns:a16="http://schemas.microsoft.com/office/drawing/2014/main" id="{AE0A94B2-AA2A-445F-AE56-904F2ED49D6D}"/>
+                <a16:creationId xmlns:a16="http://schemas.microsoft.com/office/drawing/2014/main" id="{EB4F543E-68C0-4AAB-8E8F-42CB70C6A77D}"/>
               </a:ext>
             </a:extLst>
           </p:cNvPr>
@@ -4135,7 +4135,7 @@
           <p:cNvPr id="31" name="">
             <a:extLst xmlns:a="http://schemas.openxmlformats.org/drawingml/2006/main">
               <a:ext uri="{FF2B5EF4-FFF2-40B4-BE49-F238E27FC236}">
-                <a16:creationId xmlns:a16="http://schemas.microsoft.com/office/drawing/2014/main" id="{D9DB5F80-EA5A-45B5-9F89-E27227219810}"/>
+                <a16:creationId xmlns:a16="http://schemas.microsoft.com/office/drawing/2014/main" id="{4A23FF03-A9BF-465E-A7B0-843E13068440}"/>
               </a:ext>
             </a:extLst>
           </p:cNvPr>
@@ -4185,19 +4185,19 @@
           <p:cNvPr id="32" name="">
             <a:extLst xmlns:a="http://schemas.openxmlformats.org/drawingml/2006/main">
               <a:ext uri="{FF2B5EF4-FFF2-40B4-BE49-F238E27FC236}">
-                <a16:creationId xmlns:a16="http://schemas.microsoft.com/office/drawing/2014/main" id="{57AC0EB3-EA31-4DAE-898C-4A0D035D8BD4}"/>
-              </a:ext>
-            </a:extLst>
-          </p:cNvPr>
-          <p:cNvSpPr>
-            <a:spLocks xmlns:a="http://schemas.openxmlformats.org/drawingml/2006/main" noGrp="1"/>
-          </p:cNvSpPr>
-          <p:nvPr/>
-        </p:nvSpPr>
-        <p:spPr>
-          <a:xfrm xmlns:a="http://schemas.openxmlformats.org/drawingml/2006/main">
-            <a:off x="6477000" y="5886450"/>
-            <a:ext cx="4762500" cy="342900"/>
+                <a16:creationId xmlns:a16="http://schemas.microsoft.com/office/drawing/2014/main" id="{0A13255E-9B9C-4B6B-9C04-27E8D7EA3226}"/>
+              </a:ext>
+            </a:extLst>
+          </p:cNvPr>
+          <p:cNvSpPr>
+            <a:spLocks xmlns:a="http://schemas.openxmlformats.org/drawingml/2006/main" noGrp="1"/>
+          </p:cNvSpPr>
+          <p:nvPr/>
+        </p:nvSpPr>
+        <p:spPr>
+          <a:xfrm xmlns:a="http://schemas.openxmlformats.org/drawingml/2006/main">
+            <a:off x="6477000" y="5772150"/>
+            <a:ext cx="4762500" cy="323850"/>
           </a:xfrm>
           <a:prstGeom xmlns:a="http://schemas.openxmlformats.org/drawingml/2006/main" prst="rect">
             <a:avLst/>
@@ -4235,7 +4235,57 @@
           <p:cNvPr id="33" name="">
             <a:extLst xmlns:a="http://schemas.openxmlformats.org/drawingml/2006/main">
               <a:ext uri="{FF2B5EF4-FFF2-40B4-BE49-F238E27FC236}">
-                <a16:creationId xmlns:a16="http://schemas.microsoft.com/office/drawing/2014/main" id="{22334F12-A060-4708-8B94-466C07F0E8A6}"/>
+                <a16:creationId xmlns:a16="http://schemas.microsoft.com/office/drawing/2014/main" id="{2EC262D6-3BF9-45E8-9A15-CB7A8B4F634C}"/>
+              </a:ext>
+            </a:extLst>
+          </p:cNvPr>
+          <p:cNvSpPr>
+            <a:spLocks xmlns:a="http://schemas.openxmlformats.org/drawingml/2006/main" noGrp="1"/>
+          </p:cNvSpPr>
+          <p:nvPr/>
+        </p:nvSpPr>
+        <p:spPr>
+          <a:xfrm xmlns:a="http://schemas.openxmlformats.org/drawingml/2006/main">
+            <a:off x="6477000" y="6076950"/>
+            <a:ext cx="4762500" cy="285750"/>
+          </a:xfrm>
+          <a:prstGeom xmlns:a="http://schemas.openxmlformats.org/drawingml/2006/main" prst="rect">
+            <a:avLst/>
+          </a:prstGeom>
+          <a:noFill xmlns:a="http://schemas.openxmlformats.org/drawingml/2006/main"/>
+          <a:ln xmlns:a="http://schemas.openxmlformats.org/drawingml/2006/main" w="0">
+            <a:noFill/>
+            <a:prstDash val="solid"/>
+          </a:ln>
+        </p:spPr>
+        <p:txBody>
+          <a:bodyPr xmlns:a="http://schemas.openxmlformats.org/drawingml/2006/main"/>
+          <a:lstStyle xmlns:a="http://schemas.openxmlformats.org/drawingml/2006/main"/>
+          <a:p xmlns:a="http://schemas.openxmlformats.org/drawingml/2006/main">
+            <a:pPr algn="l">
+              <a:defRPr sz="1350" b="1">
+                <a:solidFill>
+                  <a:srgbClr val="5F6975"/>
+                </a:solidFill>
+              </a:defRPr>
+            </a:pPr>
+            <a:r>
+              <a:rPr sz="1350" b="1">
+                <a:solidFill>
+                  <a:srgbClr val="5F6975"/>
+                </a:solidFill>
+              </a:rPr>
+              <a:t>No automated payment action without human review.</a:t>
+            </a:r>
+          </a:p>
+        </p:txBody>
+      </p:sp>
+      <p:sp>
+        <p:nvSpPr>
+          <p:cNvPr id="34" name="">
+            <a:extLst xmlns:a="http://schemas.openxmlformats.org/drawingml/2006/main">
+              <a:ext uri="{FF2B5EF4-FFF2-40B4-BE49-F238E27FC236}">
+                <a16:creationId xmlns:a16="http://schemas.microsoft.com/office/drawing/2014/main" id="{A447DFCB-B9F5-405C-9ABA-F20629F40B82}"/>
               </a:ext>
             </a:extLst>
           </p:cNvPr>
@@ -4270,10 +4320,10 @@
       </p:sp>
       <p:sp>
         <p:nvSpPr>
-          <p:cNvPr id="34" name="">
-            <a:extLst xmlns:a="http://schemas.openxmlformats.org/drawingml/2006/main">
-              <a:ext uri="{FF2B5EF4-FFF2-40B4-BE49-F238E27FC236}">
-                <a16:creationId xmlns:a16="http://schemas.microsoft.com/office/drawing/2014/main" id="{E41E840A-1884-4FFA-B8D2-346E643C07A6}"/>
+          <p:cNvPr id="35" name="">
+            <a:extLst xmlns:a="http://schemas.openxmlformats.org/drawingml/2006/main">
+              <a:ext uri="{FF2B5EF4-FFF2-40B4-BE49-F238E27FC236}">
+                <a16:creationId xmlns:a16="http://schemas.microsoft.com/office/drawing/2014/main" id="{AB67EF21-72C7-4DCD-87CF-615C20298700}"/>
               </a:ext>
             </a:extLst>
           </p:cNvPr>
@@ -4321,7 +4371,7 @@
     </p:spTree>
     <p:extLst>
       <p:ext uri="{BB962C8B-B14F-4D97-AF65-F5344CB8AC3E}">
-        <p14:creationId xmlns:p14="http://schemas.microsoft.com/office/powerpoint/2010/main" val="1248298565"/>
+        <p14:creationId xmlns:p14="http://schemas.microsoft.com/office/powerpoint/2010/main" val="1348988364"/>
       </p:ext>
     </p:extLst>
   </p:cSld>
@@ -4352,7 +4402,7 @@
           <p:cNvPr id="1" name="">
             <a:extLst xmlns:a="http://schemas.openxmlformats.org/drawingml/2006/main">
               <a:ext uri="{FF2B5EF4-FFF2-40B4-BE49-F238E27FC236}">
-                <a16:creationId xmlns:a16="http://schemas.microsoft.com/office/drawing/2014/main" id="{4AD0C335-CC31-4B78-B032-5D358D173F75}"/>
+                <a16:creationId xmlns:a16="http://schemas.microsoft.com/office/drawing/2014/main" id="{6990DCF5-A74A-4235-8A80-268AFAA25A19}"/>
               </a:ext>
             </a:extLst>
           </p:cNvPr>
@@ -4402,7 +4452,7 @@
           <p:cNvPr id="2" name="">
             <a:extLst xmlns:a="http://schemas.openxmlformats.org/drawingml/2006/main">
               <a:ext uri="{FF2B5EF4-FFF2-40B4-BE49-F238E27FC236}">
-                <a16:creationId xmlns:a16="http://schemas.microsoft.com/office/drawing/2014/main" id="{C5AE19B7-B150-4DEC-925C-3E13CBA018A3}"/>
+                <a16:creationId xmlns:a16="http://schemas.microsoft.com/office/drawing/2014/main" id="{7688F576-59DD-4698-8DAF-7DB9CCF9E779}"/>
               </a:ext>
             </a:extLst>
           </p:cNvPr>
@@ -4452,7 +4502,7 @@
           <p:cNvPr id="3" name="">
             <a:extLst xmlns:a="http://schemas.openxmlformats.org/drawingml/2006/main">
               <a:ext uri="{FF2B5EF4-FFF2-40B4-BE49-F238E27FC236}">
-                <a16:creationId xmlns:a16="http://schemas.microsoft.com/office/drawing/2014/main" id="{84A84EA6-8ABC-4937-AE40-C477CF397D5C}"/>
+                <a16:creationId xmlns:a16="http://schemas.microsoft.com/office/drawing/2014/main" id="{B51DD3C1-1A5D-445F-9F89-AA6F46107168}"/>
               </a:ext>
             </a:extLst>
           </p:cNvPr>
@@ -4502,7 +4552,7 @@
           <p:cNvPr id="4" name="">
             <a:extLst xmlns:a="http://schemas.openxmlformats.org/drawingml/2006/main">
               <a:ext uri="{FF2B5EF4-FFF2-40B4-BE49-F238E27FC236}">
-                <a16:creationId xmlns:a16="http://schemas.microsoft.com/office/drawing/2014/main" id="{55F487DD-2D19-478C-A538-92DEEE4693D3}"/>
+                <a16:creationId xmlns:a16="http://schemas.microsoft.com/office/drawing/2014/main" id="{53F108CE-FA2D-4FCB-99E2-C0538674EED1}"/>
               </a:ext>
             </a:extLst>
           </p:cNvPr>
@@ -4537,7 +4587,7 @@
           <p:cNvPr id="5" name="">
             <a:extLst xmlns:a="http://schemas.openxmlformats.org/drawingml/2006/main">
               <a:ext uri="{FF2B5EF4-FFF2-40B4-BE49-F238E27FC236}">
-                <a16:creationId xmlns:a16="http://schemas.microsoft.com/office/drawing/2014/main" id="{7CB3D84C-4915-4C6E-A81D-BDF27FC08485}"/>
+                <a16:creationId xmlns:a16="http://schemas.microsoft.com/office/drawing/2014/main" id="{533A5F15-9733-447A-BC82-F0504CD4818F}"/>
               </a:ext>
             </a:extLst>
           </p:cNvPr>
@@ -4587,7 +4637,7 @@
           <p:cNvPr id="6" name="">
             <a:extLst xmlns:a="http://schemas.openxmlformats.org/drawingml/2006/main">
               <a:ext uri="{FF2B5EF4-FFF2-40B4-BE49-F238E27FC236}">
-                <a16:creationId xmlns:a16="http://schemas.microsoft.com/office/drawing/2014/main" id="{37564068-D29E-4ED1-BEFA-E47DBA7F858F}"/>
+                <a16:creationId xmlns:a16="http://schemas.microsoft.com/office/drawing/2014/main" id="{87991C33-5F7C-4C62-BEB9-A02F5361587B}"/>
               </a:ext>
             </a:extLst>
           </p:cNvPr>
@@ -4637,7 +4687,7 @@
           <p:cNvPr id="7" name="">
             <a:extLst xmlns:a="http://schemas.openxmlformats.org/drawingml/2006/main">
               <a:ext uri="{FF2B5EF4-FFF2-40B4-BE49-F238E27FC236}">
-                <a16:creationId xmlns:a16="http://schemas.microsoft.com/office/drawing/2014/main" id="{F0C1C64E-F56F-42DC-BCFC-D73DA44CD5D5}"/>
+                <a16:creationId xmlns:a16="http://schemas.microsoft.com/office/drawing/2014/main" id="{B9A2E13A-8C38-4139-88A4-A104A2CBA9FF}"/>
               </a:ext>
             </a:extLst>
           </p:cNvPr>
@@ -4672,7 +4722,7 @@
           <p:cNvPr id="8" name="">
             <a:extLst xmlns:a="http://schemas.openxmlformats.org/drawingml/2006/main">
               <a:ext uri="{FF2B5EF4-FFF2-40B4-BE49-F238E27FC236}">
-                <a16:creationId xmlns:a16="http://schemas.microsoft.com/office/drawing/2014/main" id="{13E9E736-2CC9-47B2-9413-5DEE7D162835}"/>
+                <a16:creationId xmlns:a16="http://schemas.microsoft.com/office/drawing/2014/main" id="{F2DBAC5B-2976-4FDD-A602-A679193E8E0A}"/>
               </a:ext>
             </a:extLst>
           </p:cNvPr>
@@ -4722,7 +4772,7 @@
           <p:cNvPr id="9" name="">
             <a:extLst xmlns:a="http://schemas.openxmlformats.org/drawingml/2006/main">
               <a:ext uri="{FF2B5EF4-FFF2-40B4-BE49-F238E27FC236}">
-                <a16:creationId xmlns:a16="http://schemas.microsoft.com/office/drawing/2014/main" id="{0311B16F-129C-4A52-A886-1142DBCA4BBF}"/>
+                <a16:creationId xmlns:a16="http://schemas.microsoft.com/office/drawing/2014/main" id="{B2D557B0-BAD1-49A4-A2B4-07AB561E0A3B}"/>
               </a:ext>
             </a:extLst>
           </p:cNvPr>
@@ -4772,7 +4822,7 @@
           <p:cNvPr id="10" name="">
             <a:extLst xmlns:a="http://schemas.openxmlformats.org/drawingml/2006/main">
               <a:ext uri="{FF2B5EF4-FFF2-40B4-BE49-F238E27FC236}">
-                <a16:creationId xmlns:a16="http://schemas.microsoft.com/office/drawing/2014/main" id="{4E0EDD04-C3FD-4831-A729-08DA3385C767}"/>
+                <a16:creationId xmlns:a16="http://schemas.microsoft.com/office/drawing/2014/main" id="{4DD3A493-723B-4F38-8B7C-D430D1DC41B9}"/>
               </a:ext>
             </a:extLst>
           </p:cNvPr>
@@ -4807,7 +4857,7 @@
           <p:cNvPr id="11" name="">
             <a:extLst xmlns:a="http://schemas.openxmlformats.org/drawingml/2006/main">
               <a:ext uri="{FF2B5EF4-FFF2-40B4-BE49-F238E27FC236}">
-                <a16:creationId xmlns:a16="http://schemas.microsoft.com/office/drawing/2014/main" id="{4AED4670-136C-4D2C-861D-6EDC89934E98}"/>
+                <a16:creationId xmlns:a16="http://schemas.microsoft.com/office/drawing/2014/main" id="{CA13F74D-5C0A-4150-AA29-58B7CBDB1492}"/>
               </a:ext>
             </a:extLst>
           </p:cNvPr>
@@ -4857,7 +4907,7 @@
           <p:cNvPr id="12" name="">
             <a:extLst xmlns:a="http://schemas.openxmlformats.org/drawingml/2006/main">
               <a:ext uri="{FF2B5EF4-FFF2-40B4-BE49-F238E27FC236}">
-                <a16:creationId xmlns:a16="http://schemas.microsoft.com/office/drawing/2014/main" id="{292F8623-2376-4D8D-B3E4-7B9DD424AE75}"/>
+                <a16:creationId xmlns:a16="http://schemas.microsoft.com/office/drawing/2014/main" id="{396F9B1B-87EF-494C-BBEB-5AA23AA23C8F}"/>
               </a:ext>
             </a:extLst>
           </p:cNvPr>
@@ -4914,7 +4964,7 @@
         </p:xfrm>
         <a:graphic xmlns:a="http://schemas.openxmlformats.org/drawingml/2006/main">
           <a:graphicData uri="http://schemas.openxmlformats.org/drawingml/2006/chart">
-            <c:chart xmlns:r="http://schemas.openxmlformats.org/officeDocument/2006/relationships" xmlns:c="http://schemas.openxmlformats.org/drawingml/2006/chart" r:id="Rcaf1246683a4411b"/>
+            <c:chart xmlns:r="http://schemas.openxmlformats.org/officeDocument/2006/relationships" xmlns:c="http://schemas.openxmlformats.org/drawingml/2006/chart" r:id="R0d50252e614d4bec"/>
           </a:graphicData>
         </a:graphic>
       </p:graphicFrame>
@@ -4923,7 +4973,7 @@
           <p:cNvPr id="14" name="">
             <a:extLst xmlns:a="http://schemas.openxmlformats.org/drawingml/2006/main">
               <a:ext uri="{FF2B5EF4-FFF2-40B4-BE49-F238E27FC236}">
-                <a16:creationId xmlns:a16="http://schemas.microsoft.com/office/drawing/2014/main" id="{B8EE9370-84BC-4517-9F88-6A7B698A565B}"/>
+                <a16:creationId xmlns:a16="http://schemas.microsoft.com/office/drawing/2014/main" id="{DC33D5DB-07B5-48AC-AB3E-2695EB147798}"/>
               </a:ext>
             </a:extLst>
           </p:cNvPr>
@@ -4973,7 +5023,7 @@
           <p:cNvPr id="15" name="">
             <a:extLst xmlns:a="http://schemas.openxmlformats.org/drawingml/2006/main">
               <a:ext uri="{FF2B5EF4-FFF2-40B4-BE49-F238E27FC236}">
-                <a16:creationId xmlns:a16="http://schemas.microsoft.com/office/drawing/2014/main" id="{21FC4B60-3818-4B20-8755-63415EB58641}"/>
+                <a16:creationId xmlns:a16="http://schemas.microsoft.com/office/drawing/2014/main" id="{4F966245-1CDD-4142-AA6F-4ACA0DFC07C7}"/>
               </a:ext>
             </a:extLst>
           </p:cNvPr>
@@ -5004,7 +5054,7 @@
           <p:cNvPr id="16" name="">
             <a:extLst xmlns:a="http://schemas.openxmlformats.org/drawingml/2006/main">
               <a:ext uri="{FF2B5EF4-FFF2-40B4-BE49-F238E27FC236}">
-                <a16:creationId xmlns:a16="http://schemas.microsoft.com/office/drawing/2014/main" id="{64890C23-7306-4503-A325-5AD6E576FEAE}"/>
+                <a16:creationId xmlns:a16="http://schemas.microsoft.com/office/drawing/2014/main" id="{9594811F-1ACD-4C75-8AB2-78A778ABCEAC}"/>
               </a:ext>
             </a:extLst>
           </p:cNvPr>
@@ -5054,7 +5104,7 @@
           <p:cNvPr id="17" name="">
             <a:extLst xmlns:a="http://schemas.openxmlformats.org/drawingml/2006/main">
               <a:ext uri="{FF2B5EF4-FFF2-40B4-BE49-F238E27FC236}">
-                <a16:creationId xmlns:a16="http://schemas.microsoft.com/office/drawing/2014/main" id="{514436B5-8EE2-4B53-9811-19B458F833EF}"/>
+                <a16:creationId xmlns:a16="http://schemas.microsoft.com/office/drawing/2014/main" id="{045F888B-7807-4CEB-ABBA-1A7405DB2EC7}"/>
               </a:ext>
             </a:extLst>
           </p:cNvPr>
@@ -5085,7 +5135,7 @@
           <p:cNvPr id="18" name="">
             <a:extLst xmlns:a="http://schemas.openxmlformats.org/drawingml/2006/main">
               <a:ext uri="{FF2B5EF4-FFF2-40B4-BE49-F238E27FC236}">
-                <a16:creationId xmlns:a16="http://schemas.microsoft.com/office/drawing/2014/main" id="{559A7F8F-F660-45EF-B57D-3B4697FC1C47}"/>
+                <a16:creationId xmlns:a16="http://schemas.microsoft.com/office/drawing/2014/main" id="{F7910F4D-A4AD-408D-A6B6-AEAFF8E3D064}"/>
               </a:ext>
             </a:extLst>
           </p:cNvPr>
@@ -5135,7 +5185,7 @@
           <p:cNvPr id="19" name="">
             <a:extLst xmlns:a="http://schemas.openxmlformats.org/drawingml/2006/main">
               <a:ext uri="{FF2B5EF4-FFF2-40B4-BE49-F238E27FC236}">
-                <a16:creationId xmlns:a16="http://schemas.microsoft.com/office/drawing/2014/main" id="{DD0DD5EE-324F-43FF-AA76-2474702010EE}"/>
+                <a16:creationId xmlns:a16="http://schemas.microsoft.com/office/drawing/2014/main" id="{0F8F9980-0C64-4B4A-80B4-650EEDEE19F8}"/>
               </a:ext>
             </a:extLst>
           </p:cNvPr>
@@ -5166,7 +5216,7 @@
           <p:cNvPr id="20" name="">
             <a:extLst xmlns:a="http://schemas.openxmlformats.org/drawingml/2006/main">
               <a:ext uri="{FF2B5EF4-FFF2-40B4-BE49-F238E27FC236}">
-                <a16:creationId xmlns:a16="http://schemas.microsoft.com/office/drawing/2014/main" id="{B27F3D9D-539A-4424-BAB3-ACADED4A4C65}"/>
+                <a16:creationId xmlns:a16="http://schemas.microsoft.com/office/drawing/2014/main" id="{A74D9A3E-C8FF-4B06-AB34-671D7C5C9D84}"/>
               </a:ext>
             </a:extLst>
           </p:cNvPr>
@@ -5216,7 +5266,7 @@
           <p:cNvPr id="21" name="">
             <a:extLst xmlns:a="http://schemas.openxmlformats.org/drawingml/2006/main">
               <a:ext uri="{FF2B5EF4-FFF2-40B4-BE49-F238E27FC236}">
-                <a16:creationId xmlns:a16="http://schemas.microsoft.com/office/drawing/2014/main" id="{5D8AAD97-BBE3-4380-AA98-9B8B6554A1EC}"/>
+                <a16:creationId xmlns:a16="http://schemas.microsoft.com/office/drawing/2014/main" id="{753476EF-F038-41F4-B381-7B74A56B89CE}"/>
               </a:ext>
             </a:extLst>
           </p:cNvPr>
@@ -5266,7 +5316,7 @@
           <p:cNvPr id="22" name="">
             <a:extLst xmlns:a="http://schemas.openxmlformats.org/drawingml/2006/main">
               <a:ext uri="{FF2B5EF4-FFF2-40B4-BE49-F238E27FC236}">
-                <a16:creationId xmlns:a16="http://schemas.microsoft.com/office/drawing/2014/main" id="{F4563838-7889-4D7A-8B89-6DB695570AD3}"/>
+                <a16:creationId xmlns:a16="http://schemas.microsoft.com/office/drawing/2014/main" id="{49287977-659E-42D1-8EAA-8C28FE2A4913}"/>
               </a:ext>
             </a:extLst>
           </p:cNvPr>
@@ -5314,7 +5364,7 @@
     </p:spTree>
     <p:extLst>
       <p:ext uri="{BB962C8B-B14F-4D97-AF65-F5344CB8AC3E}">
-        <p14:creationId xmlns:p14="http://schemas.microsoft.com/office/powerpoint/2010/main" val="1497067741"/>
+        <p14:creationId xmlns:p14="http://schemas.microsoft.com/office/powerpoint/2010/main" val="1240630279"/>
       </p:ext>
     </p:extLst>
   </p:cSld>
@@ -5345,7 +5395,7 @@
           <p:cNvPr id="1" name="">
             <a:extLst xmlns:a="http://schemas.openxmlformats.org/drawingml/2006/main">
               <a:ext uri="{FF2B5EF4-FFF2-40B4-BE49-F238E27FC236}">
-                <a16:creationId xmlns:a16="http://schemas.microsoft.com/office/drawing/2014/main" id="{60085EFC-87E0-4FC8-9E3C-5578963FC5E2}"/>
+                <a16:creationId xmlns:a16="http://schemas.microsoft.com/office/drawing/2014/main" id="{6EA2BDB8-84BD-4B53-AAA6-0AE56D877D7C}"/>
               </a:ext>
             </a:extLst>
           </p:cNvPr>
@@ -5395,7 +5445,7 @@
           <p:cNvPr id="2" name="">
             <a:extLst xmlns:a="http://schemas.openxmlformats.org/drawingml/2006/main">
               <a:ext uri="{FF2B5EF4-FFF2-40B4-BE49-F238E27FC236}">
-                <a16:creationId xmlns:a16="http://schemas.microsoft.com/office/drawing/2014/main" id="{A58F07A8-B4C6-410C-997E-F003720A5555}"/>
+                <a16:creationId xmlns:a16="http://schemas.microsoft.com/office/drawing/2014/main" id="{140E2C74-3E23-43A1-A908-D5EA739F0D75}"/>
               </a:ext>
             </a:extLst>
           </p:cNvPr>
@@ -5445,7 +5495,7 @@
           <p:cNvPr id="3" name="">
             <a:extLst xmlns:a="http://schemas.openxmlformats.org/drawingml/2006/main">
               <a:ext uri="{FF2B5EF4-FFF2-40B4-BE49-F238E27FC236}">
-                <a16:creationId xmlns:a16="http://schemas.microsoft.com/office/drawing/2014/main" id="{EAA8A08A-727B-454D-93CD-9250BB479FCA}"/>
+                <a16:creationId xmlns:a16="http://schemas.microsoft.com/office/drawing/2014/main" id="{E782EFE5-6B36-4945-B986-B299229A4953}"/>
               </a:ext>
             </a:extLst>
           </p:cNvPr>
@@ -5495,7 +5545,7 @@
           <p:cNvPr id="4" name="">
             <a:extLst xmlns:a="http://schemas.openxmlformats.org/drawingml/2006/main">
               <a:ext uri="{FF2B5EF4-FFF2-40B4-BE49-F238E27FC236}">
-                <a16:creationId xmlns:a16="http://schemas.microsoft.com/office/drawing/2014/main" id="{E781DF4C-39D3-42AC-A1BB-735F63ED9256}"/>
+                <a16:creationId xmlns:a16="http://schemas.microsoft.com/office/drawing/2014/main" id="{0F792E95-4153-45F8-AEFD-E6076B55A8FA}"/>
               </a:ext>
             </a:extLst>
           </p:cNvPr>
@@ -5528,7 +5578,7 @@
           <p:cNvPr id="5" name="">
             <a:extLst xmlns:a="http://schemas.openxmlformats.org/drawingml/2006/main">
               <a:ext uri="{FF2B5EF4-FFF2-40B4-BE49-F238E27FC236}">
-                <a16:creationId xmlns:a16="http://schemas.microsoft.com/office/drawing/2014/main" id="{C65E0B0F-5C93-4DF3-B583-FEE6FFFDDF46}"/>
+                <a16:creationId xmlns:a16="http://schemas.microsoft.com/office/drawing/2014/main" id="{7735CDD1-6506-4F5C-BDC9-11E2D4D84AC6}"/>
               </a:ext>
             </a:extLst>
           </p:cNvPr>
@@ -5559,7 +5609,7 @@
           <p:cNvPr id="6" name="">
             <a:extLst xmlns:a="http://schemas.openxmlformats.org/drawingml/2006/main">
               <a:ext uri="{FF2B5EF4-FFF2-40B4-BE49-F238E27FC236}">
-                <a16:creationId xmlns:a16="http://schemas.microsoft.com/office/drawing/2014/main" id="{298ECAD3-58F6-4479-A2F9-226867F89F93}"/>
+                <a16:creationId xmlns:a16="http://schemas.microsoft.com/office/drawing/2014/main" id="{C8AA9130-5A95-4F83-88D1-74C3EEEE97A4}"/>
               </a:ext>
             </a:extLst>
           </p:cNvPr>
@@ -5609,7 +5659,7 @@
           <p:cNvPr id="7" name="">
             <a:extLst xmlns:a="http://schemas.openxmlformats.org/drawingml/2006/main">
               <a:ext uri="{FF2B5EF4-FFF2-40B4-BE49-F238E27FC236}">
-                <a16:creationId xmlns:a16="http://schemas.microsoft.com/office/drawing/2014/main" id="{EF983139-5164-4DDF-AAA7-9095AE38546E}"/>
+                <a16:creationId xmlns:a16="http://schemas.microsoft.com/office/drawing/2014/main" id="{9F6E010D-5AA2-420F-8363-E80E0624BEB4}"/>
               </a:ext>
             </a:extLst>
           </p:cNvPr>
@@ -5659,7 +5709,7 @@
           <p:cNvPr id="8" name="">
             <a:extLst xmlns:a="http://schemas.openxmlformats.org/drawingml/2006/main">
               <a:ext uri="{FF2B5EF4-FFF2-40B4-BE49-F238E27FC236}">
-                <a16:creationId xmlns:a16="http://schemas.microsoft.com/office/drawing/2014/main" id="{16CF92B3-BC7A-4324-8934-7E027F62F957}"/>
+                <a16:creationId xmlns:a16="http://schemas.microsoft.com/office/drawing/2014/main" id="{92B5F593-309F-43D9-8766-3A9435614DCB}"/>
               </a:ext>
             </a:extLst>
           </p:cNvPr>
@@ -5692,7 +5742,7 @@
           <p:cNvPr id="9" name="">
             <a:extLst xmlns:a="http://schemas.openxmlformats.org/drawingml/2006/main">
               <a:ext uri="{FF2B5EF4-FFF2-40B4-BE49-F238E27FC236}">
-                <a16:creationId xmlns:a16="http://schemas.microsoft.com/office/drawing/2014/main" id="{4985A7F5-91DC-43DE-A103-AE6927D3AC7A}"/>
+                <a16:creationId xmlns:a16="http://schemas.microsoft.com/office/drawing/2014/main" id="{A15E76CA-06AB-4F15-ADFB-7C29DC9ED371}"/>
               </a:ext>
             </a:extLst>
           </p:cNvPr>
@@ -5723,7 +5773,7 @@
           <p:cNvPr id="10" name="">
             <a:extLst xmlns:a="http://schemas.openxmlformats.org/drawingml/2006/main">
               <a:ext uri="{FF2B5EF4-FFF2-40B4-BE49-F238E27FC236}">
-                <a16:creationId xmlns:a16="http://schemas.microsoft.com/office/drawing/2014/main" id="{94CB5854-1FD8-494F-AB64-5F93E9C3578F}"/>
+                <a16:creationId xmlns:a16="http://schemas.microsoft.com/office/drawing/2014/main" id="{04E1A2CA-753D-4420-85A5-6160B7F5DE96}"/>
               </a:ext>
             </a:extLst>
           </p:cNvPr>
@@ -5773,7 +5823,7 @@
           <p:cNvPr id="11" name="">
             <a:extLst xmlns:a="http://schemas.openxmlformats.org/drawingml/2006/main">
               <a:ext uri="{FF2B5EF4-FFF2-40B4-BE49-F238E27FC236}">
-                <a16:creationId xmlns:a16="http://schemas.microsoft.com/office/drawing/2014/main" id="{2DE24F56-A83E-489B-97CF-C05ACB4901EE}"/>
+                <a16:creationId xmlns:a16="http://schemas.microsoft.com/office/drawing/2014/main" id="{50867862-1F77-4801-95C2-3C5203C2208F}"/>
               </a:ext>
             </a:extLst>
           </p:cNvPr>
@@ -5823,7 +5873,7 @@
           <p:cNvPr id="12" name="">
             <a:extLst xmlns:a="http://schemas.openxmlformats.org/drawingml/2006/main">
               <a:ext uri="{FF2B5EF4-FFF2-40B4-BE49-F238E27FC236}">
-                <a16:creationId xmlns:a16="http://schemas.microsoft.com/office/drawing/2014/main" id="{01453CA4-A5A6-43F7-A758-A4259246F8D3}"/>
+                <a16:creationId xmlns:a16="http://schemas.microsoft.com/office/drawing/2014/main" id="{FED70C72-4E07-4C56-8AD9-6EE54130B6DF}"/>
               </a:ext>
             </a:extLst>
           </p:cNvPr>
@@ -5856,7 +5906,7 @@
           <p:cNvPr id="13" name="">
             <a:extLst xmlns:a="http://schemas.openxmlformats.org/drawingml/2006/main">
               <a:ext uri="{FF2B5EF4-FFF2-40B4-BE49-F238E27FC236}">
-                <a16:creationId xmlns:a16="http://schemas.microsoft.com/office/drawing/2014/main" id="{D5EBD645-71D9-4BD9-A124-4AB52BDCE448}"/>
+                <a16:creationId xmlns:a16="http://schemas.microsoft.com/office/drawing/2014/main" id="{2B497141-B042-4094-8C5E-D40D088D0893}"/>
               </a:ext>
             </a:extLst>
           </p:cNvPr>
@@ -5887,7 +5937,7 @@
           <p:cNvPr id="14" name="">
             <a:extLst xmlns:a="http://schemas.openxmlformats.org/drawingml/2006/main">
               <a:ext uri="{FF2B5EF4-FFF2-40B4-BE49-F238E27FC236}">
-                <a16:creationId xmlns:a16="http://schemas.microsoft.com/office/drawing/2014/main" id="{34F4736E-7A02-4D50-A010-78638102B3EF}"/>
+                <a16:creationId xmlns:a16="http://schemas.microsoft.com/office/drawing/2014/main" id="{6E501295-B0F7-4D55-82BA-1382A6B3F925}"/>
               </a:ext>
             </a:extLst>
           </p:cNvPr>
@@ -5937,7 +5987,7 @@
           <p:cNvPr id="15" name="">
             <a:extLst xmlns:a="http://schemas.openxmlformats.org/drawingml/2006/main">
               <a:ext uri="{FF2B5EF4-FFF2-40B4-BE49-F238E27FC236}">
-                <a16:creationId xmlns:a16="http://schemas.microsoft.com/office/drawing/2014/main" id="{05BB5CA9-6ECD-4D47-AA54-1B487A916E2C}"/>
+                <a16:creationId xmlns:a16="http://schemas.microsoft.com/office/drawing/2014/main" id="{616F2C3A-3D1B-405F-AA86-50AC7ABD6937}"/>
               </a:ext>
             </a:extLst>
           </p:cNvPr>
@@ -5977,7 +6027,7 @@
                   <a:srgbClr val="101820"/>
                 </a:solidFill>
               </a:rPr>
-              <a:t>Cotiviti can package the evidence chain with specialist review, case tracking, client governance, and provider-facing defensibility.</a:t>
+              <a:t>Cotiviti can package evidence cards with specialist review, case tracking, client governance, and provider-facing defensibility.</a:t>
             </a:r>
           </a:p>
         </p:txBody>
@@ -5987,7 +6037,7 @@
           <p:cNvPr id="16" name="">
             <a:extLst xmlns:a="http://schemas.openxmlformats.org/drawingml/2006/main">
               <a:ext uri="{FF2B5EF4-FFF2-40B4-BE49-F238E27FC236}">
-                <a16:creationId xmlns:a16="http://schemas.microsoft.com/office/drawing/2014/main" id="{B1D7F73F-9BEF-44E2-AE28-5FB87497A99E}"/>
+                <a16:creationId xmlns:a16="http://schemas.microsoft.com/office/drawing/2014/main" id="{5406C670-AAE7-43ED-92A6-EF5FB2C8DB5D}"/>
               </a:ext>
             </a:extLst>
           </p:cNvPr>
@@ -6037,7 +6087,7 @@
           <p:cNvPr id="17" name="">
             <a:extLst xmlns:a="http://schemas.openxmlformats.org/drawingml/2006/main">
               <a:ext uri="{FF2B5EF4-FFF2-40B4-BE49-F238E27FC236}">
-                <a16:creationId xmlns:a16="http://schemas.microsoft.com/office/drawing/2014/main" id="{093AE89A-FC2B-4389-A177-32BE1C9770F6}"/>
+                <a16:creationId xmlns:a16="http://schemas.microsoft.com/office/drawing/2014/main" id="{0714AF8D-283C-458F-8AC2-04469C221948}"/>
               </a:ext>
             </a:extLst>
           </p:cNvPr>
@@ -6087,7 +6137,7 @@
           <p:cNvPr id="18" name="">
             <a:extLst xmlns:a="http://schemas.openxmlformats.org/drawingml/2006/main">
               <a:ext uri="{FF2B5EF4-FFF2-40B4-BE49-F238E27FC236}">
-                <a16:creationId xmlns:a16="http://schemas.microsoft.com/office/drawing/2014/main" id="{66856129-C450-4437-B80C-39A9FD769171}"/>
+                <a16:creationId xmlns:a16="http://schemas.microsoft.com/office/drawing/2014/main" id="{551D902E-C83C-4CAE-BB28-82C9980F45E6}"/>
               </a:ext>
             </a:extLst>
           </p:cNvPr>
@@ -6135,7 +6185,7 @@
     </p:spTree>
     <p:extLst>
       <p:ext uri="{BB962C8B-B14F-4D97-AF65-F5344CB8AC3E}">
-        <p14:creationId xmlns:p14="http://schemas.microsoft.com/office/powerpoint/2010/main" val="1555504799"/>
+        <p14:creationId xmlns:p14="http://schemas.microsoft.com/office/powerpoint/2010/main" val="1161811640"/>
       </p:ext>
     </p:extLst>
   </p:cSld>
@@ -6166,7 +6216,7 @@
           <p:cNvPr id="1" name="">
             <a:extLst xmlns:a="http://schemas.openxmlformats.org/drawingml/2006/main">
               <a:ext uri="{FF2B5EF4-FFF2-40B4-BE49-F238E27FC236}">
-                <a16:creationId xmlns:a16="http://schemas.microsoft.com/office/drawing/2014/main" id="{1EF89BF5-4DCF-4F45-B4D3-15FAF286EB02}"/>
+                <a16:creationId xmlns:a16="http://schemas.microsoft.com/office/drawing/2014/main" id="{A67C83A0-5812-4824-AB3D-81F36618CEF2}"/>
               </a:ext>
             </a:extLst>
           </p:cNvPr>
@@ -6216,7 +6266,7 @@
           <p:cNvPr id="2" name="">
             <a:extLst xmlns:a="http://schemas.openxmlformats.org/drawingml/2006/main">
               <a:ext uri="{FF2B5EF4-FFF2-40B4-BE49-F238E27FC236}">
-                <a16:creationId xmlns:a16="http://schemas.microsoft.com/office/drawing/2014/main" id="{DE5FB249-C284-49C1-ACB5-9FD87537DF7B}"/>
+                <a16:creationId xmlns:a16="http://schemas.microsoft.com/office/drawing/2014/main" id="{CAF17D80-2A25-41D1-ABC0-1ADE29FB543D}"/>
               </a:ext>
             </a:extLst>
           </p:cNvPr>
@@ -6266,7 +6316,7 @@
           <p:cNvPr id="3" name="">
             <a:extLst xmlns:a="http://schemas.openxmlformats.org/drawingml/2006/main">
               <a:ext uri="{FF2B5EF4-FFF2-40B4-BE49-F238E27FC236}">
-                <a16:creationId xmlns:a16="http://schemas.microsoft.com/office/drawing/2014/main" id="{68AA2A0C-B1AC-4D57-AB50-03B525D20DA0}"/>
+                <a16:creationId xmlns:a16="http://schemas.microsoft.com/office/drawing/2014/main" id="{CD4BB3C6-0F42-4AA0-A1BB-CF2B71311E2B}"/>
               </a:ext>
             </a:extLst>
           </p:cNvPr>
@@ -6316,7 +6366,7 @@
           <p:cNvPr id="4" name="">
             <a:extLst xmlns:a="http://schemas.openxmlformats.org/drawingml/2006/main">
               <a:ext uri="{FF2B5EF4-FFF2-40B4-BE49-F238E27FC236}">
-                <a16:creationId xmlns:a16="http://schemas.microsoft.com/office/drawing/2014/main" id="{A5426916-C511-4DBF-A50A-46A21904B934}"/>
+                <a16:creationId xmlns:a16="http://schemas.microsoft.com/office/drawing/2014/main" id="{B41853C7-9DD8-428C-9E31-1D55DBE2CFCC}"/>
               </a:ext>
             </a:extLst>
           </p:cNvPr>
@@ -6347,7 +6397,7 @@
           <p:cNvPr id="5" name="">
             <a:extLst xmlns:a="http://schemas.openxmlformats.org/drawingml/2006/main">
               <a:ext uri="{FF2B5EF4-FFF2-40B4-BE49-F238E27FC236}">
-                <a16:creationId xmlns:a16="http://schemas.microsoft.com/office/drawing/2014/main" id="{E44794E8-7FAD-4B67-8A9C-D0753879DFF8}"/>
+                <a16:creationId xmlns:a16="http://schemas.microsoft.com/office/drawing/2014/main" id="{24C47E2E-E584-4E6F-BC75-2B793DD7F35E}"/>
               </a:ext>
             </a:extLst>
           </p:cNvPr>
@@ -6397,7 +6447,7 @@
           <p:cNvPr id="6" name="">
             <a:extLst xmlns:a="http://schemas.openxmlformats.org/drawingml/2006/main">
               <a:ext uri="{FF2B5EF4-FFF2-40B4-BE49-F238E27FC236}">
-                <a16:creationId xmlns:a16="http://schemas.microsoft.com/office/drawing/2014/main" id="{CFD06C93-55C9-4530-A97D-ED029EFB56B4}"/>
+                <a16:creationId xmlns:a16="http://schemas.microsoft.com/office/drawing/2014/main" id="{ED53ABB7-4C7D-4B92-9AF0-8161AFFF61D2}"/>
               </a:ext>
             </a:extLst>
           </p:cNvPr>
@@ -6447,7 +6497,7 @@
           <p:cNvPr id="7" name="">
             <a:extLst xmlns:a="http://schemas.openxmlformats.org/drawingml/2006/main">
               <a:ext uri="{FF2B5EF4-FFF2-40B4-BE49-F238E27FC236}">
-                <a16:creationId xmlns:a16="http://schemas.microsoft.com/office/drawing/2014/main" id="{F3277984-E0B2-4BA8-892D-EBC238B436AF}"/>
+                <a16:creationId xmlns:a16="http://schemas.microsoft.com/office/drawing/2014/main" id="{3DEA1FA5-83F2-485D-9E0A-44200669596C}"/>
               </a:ext>
             </a:extLst>
           </p:cNvPr>
@@ -6480,7 +6530,7 @@
           <p:cNvPr id="8" name="">
             <a:extLst xmlns:a="http://schemas.openxmlformats.org/drawingml/2006/main">
               <a:ext uri="{FF2B5EF4-FFF2-40B4-BE49-F238E27FC236}">
-                <a16:creationId xmlns:a16="http://schemas.microsoft.com/office/drawing/2014/main" id="{7B15E669-2E8A-4AF5-AA59-477A59479B0E}"/>
+                <a16:creationId xmlns:a16="http://schemas.microsoft.com/office/drawing/2014/main" id="{F090BEA0-AB24-4065-A6B7-B8B608FAF29D}"/>
               </a:ext>
             </a:extLst>
           </p:cNvPr>
@@ -6530,7 +6580,7 @@
           <p:cNvPr id="9" name="">
             <a:extLst xmlns:a="http://schemas.openxmlformats.org/drawingml/2006/main">
               <a:ext uri="{FF2B5EF4-FFF2-40B4-BE49-F238E27FC236}">
-                <a16:creationId xmlns:a16="http://schemas.microsoft.com/office/drawing/2014/main" id="{FEECA9B0-977E-4CF2-9D41-2FB321857567}"/>
+                <a16:creationId xmlns:a16="http://schemas.microsoft.com/office/drawing/2014/main" id="{AE7D1D90-D3ED-4131-8FC3-808A039299EA}"/>
               </a:ext>
             </a:extLst>
           </p:cNvPr>
@@ -6561,7 +6611,7 @@
           <p:cNvPr id="10" name="">
             <a:extLst xmlns:a="http://schemas.openxmlformats.org/drawingml/2006/main">
               <a:ext uri="{FF2B5EF4-FFF2-40B4-BE49-F238E27FC236}">
-                <a16:creationId xmlns:a16="http://schemas.microsoft.com/office/drawing/2014/main" id="{61A51CF5-A5CD-4694-80C7-6358691F4126}"/>
+                <a16:creationId xmlns:a16="http://schemas.microsoft.com/office/drawing/2014/main" id="{6E5BB178-32E8-48D1-A588-DD82A40CAF50}"/>
               </a:ext>
             </a:extLst>
           </p:cNvPr>
@@ -6611,7 +6661,7 @@
           <p:cNvPr id="11" name="">
             <a:extLst xmlns:a="http://schemas.openxmlformats.org/drawingml/2006/main">
               <a:ext uri="{FF2B5EF4-FFF2-40B4-BE49-F238E27FC236}">
-                <a16:creationId xmlns:a16="http://schemas.microsoft.com/office/drawing/2014/main" id="{35A68A76-8C27-4C29-8C1B-D894760D6724}"/>
+                <a16:creationId xmlns:a16="http://schemas.microsoft.com/office/drawing/2014/main" id="{F8E77C92-C6A8-4205-9B12-83EE3AFA4BD0}"/>
               </a:ext>
             </a:extLst>
           </p:cNvPr>
@@ -6661,7 +6711,7 @@
           <p:cNvPr id="12" name="">
             <a:extLst xmlns:a="http://schemas.openxmlformats.org/drawingml/2006/main">
               <a:ext uri="{FF2B5EF4-FFF2-40B4-BE49-F238E27FC236}">
-                <a16:creationId xmlns:a16="http://schemas.microsoft.com/office/drawing/2014/main" id="{A0EE8451-6E0B-48B9-97E9-D75640501D23}"/>
+                <a16:creationId xmlns:a16="http://schemas.microsoft.com/office/drawing/2014/main" id="{DAAF3165-131A-4E48-AD48-9DECDE70B833}"/>
               </a:ext>
             </a:extLst>
           </p:cNvPr>
@@ -6694,7 +6744,7 @@
           <p:cNvPr id="13" name="">
             <a:extLst xmlns:a="http://schemas.openxmlformats.org/drawingml/2006/main">
               <a:ext uri="{FF2B5EF4-FFF2-40B4-BE49-F238E27FC236}">
-                <a16:creationId xmlns:a16="http://schemas.microsoft.com/office/drawing/2014/main" id="{61C79BA1-4618-4D55-BDFF-3074404B8036}"/>
+                <a16:creationId xmlns:a16="http://schemas.microsoft.com/office/drawing/2014/main" id="{970A5DD2-6669-4945-8675-66CFA87D958B}"/>
               </a:ext>
             </a:extLst>
           </p:cNvPr>
@@ -6744,7 +6794,7 @@
           <p:cNvPr id="14" name="">
             <a:extLst xmlns:a="http://schemas.openxmlformats.org/drawingml/2006/main">
               <a:ext uri="{FF2B5EF4-FFF2-40B4-BE49-F238E27FC236}">
-                <a16:creationId xmlns:a16="http://schemas.microsoft.com/office/drawing/2014/main" id="{39D3A4D3-22C4-4C97-A097-455AA2A6FE12}"/>
+                <a16:creationId xmlns:a16="http://schemas.microsoft.com/office/drawing/2014/main" id="{6842C580-5A61-4492-8345-4F379D158149}"/>
               </a:ext>
             </a:extLst>
           </p:cNvPr>
@@ -6775,7 +6825,7 @@
           <p:cNvPr id="15" name="">
             <a:extLst xmlns:a="http://schemas.openxmlformats.org/drawingml/2006/main">
               <a:ext uri="{FF2B5EF4-FFF2-40B4-BE49-F238E27FC236}">
-                <a16:creationId xmlns:a16="http://schemas.microsoft.com/office/drawing/2014/main" id="{32B49108-DA57-4FBD-A3D1-704D4808873E}"/>
+                <a16:creationId xmlns:a16="http://schemas.microsoft.com/office/drawing/2014/main" id="{52966E6D-5067-40D6-A907-547000FA9A20}"/>
               </a:ext>
             </a:extLst>
           </p:cNvPr>
@@ -6825,7 +6875,7 @@
           <p:cNvPr id="16" name="">
             <a:extLst xmlns:a="http://schemas.openxmlformats.org/drawingml/2006/main">
               <a:ext uri="{FF2B5EF4-FFF2-40B4-BE49-F238E27FC236}">
-                <a16:creationId xmlns:a16="http://schemas.microsoft.com/office/drawing/2014/main" id="{37DE37B1-D094-4F40-B431-22D331359344}"/>
+                <a16:creationId xmlns:a16="http://schemas.microsoft.com/office/drawing/2014/main" id="{6125A88D-ED28-49BC-B4A1-2C91C2630743}"/>
               </a:ext>
             </a:extLst>
           </p:cNvPr>
@@ -6875,7 +6925,7 @@
           <p:cNvPr id="17" name="">
             <a:extLst xmlns:a="http://schemas.openxmlformats.org/drawingml/2006/main">
               <a:ext uri="{FF2B5EF4-FFF2-40B4-BE49-F238E27FC236}">
-                <a16:creationId xmlns:a16="http://schemas.microsoft.com/office/drawing/2014/main" id="{BF1D8560-DF4A-4F7D-8007-EC7DC1FE3C53}"/>
+                <a16:creationId xmlns:a16="http://schemas.microsoft.com/office/drawing/2014/main" id="{C403E0A3-35F7-4B8C-BAF1-3C472DD975DB}"/>
               </a:ext>
             </a:extLst>
           </p:cNvPr>
@@ -6908,7 +6958,7 @@
           <p:cNvPr id="18" name="">
             <a:extLst xmlns:a="http://schemas.openxmlformats.org/drawingml/2006/main">
               <a:ext uri="{FF2B5EF4-FFF2-40B4-BE49-F238E27FC236}">
-                <a16:creationId xmlns:a16="http://schemas.microsoft.com/office/drawing/2014/main" id="{EB92760E-C32E-4E7C-96A2-8F3D336C466B}"/>
+                <a16:creationId xmlns:a16="http://schemas.microsoft.com/office/drawing/2014/main" id="{E2E4FF86-5A21-4DB2-90C1-5E936C8DDA6E}"/>
               </a:ext>
             </a:extLst>
           </p:cNvPr>
@@ -6958,7 +7008,7 @@
           <p:cNvPr id="19" name="">
             <a:extLst xmlns:a="http://schemas.openxmlformats.org/drawingml/2006/main">
               <a:ext uri="{FF2B5EF4-FFF2-40B4-BE49-F238E27FC236}">
-                <a16:creationId xmlns:a16="http://schemas.microsoft.com/office/drawing/2014/main" id="{037E7131-8930-4DE4-B947-06E21B2AF56D}"/>
+                <a16:creationId xmlns:a16="http://schemas.microsoft.com/office/drawing/2014/main" id="{D73454B9-1B69-4DD9-88C3-2F2B55CA02E0}"/>
               </a:ext>
             </a:extLst>
           </p:cNvPr>
@@ -6989,7 +7039,7 @@
           <p:cNvPr id="20" name="">
             <a:extLst xmlns:a="http://schemas.openxmlformats.org/drawingml/2006/main">
               <a:ext uri="{FF2B5EF4-FFF2-40B4-BE49-F238E27FC236}">
-                <a16:creationId xmlns:a16="http://schemas.microsoft.com/office/drawing/2014/main" id="{17C5F83E-3034-44A9-883C-80D77996B006}"/>
+                <a16:creationId xmlns:a16="http://schemas.microsoft.com/office/drawing/2014/main" id="{5D7C45E6-316E-45F0-B7B6-DD5718000645}"/>
               </a:ext>
             </a:extLst>
           </p:cNvPr>
@@ -7039,7 +7089,7 @@
           <p:cNvPr id="21" name="">
             <a:extLst xmlns:a="http://schemas.openxmlformats.org/drawingml/2006/main">
               <a:ext uri="{FF2B5EF4-FFF2-40B4-BE49-F238E27FC236}">
-                <a16:creationId xmlns:a16="http://schemas.microsoft.com/office/drawing/2014/main" id="{B28CBA9A-075C-46B6-A9AC-39F5D0154C87}"/>
+                <a16:creationId xmlns:a16="http://schemas.microsoft.com/office/drawing/2014/main" id="{956051B5-B8CF-410B-87FA-537B86C47035}"/>
               </a:ext>
             </a:extLst>
           </p:cNvPr>
@@ -7089,7 +7139,7 @@
           <p:cNvPr id="22" name="">
             <a:extLst xmlns:a="http://schemas.openxmlformats.org/drawingml/2006/main">
               <a:ext uri="{FF2B5EF4-FFF2-40B4-BE49-F238E27FC236}">
-                <a16:creationId xmlns:a16="http://schemas.microsoft.com/office/drawing/2014/main" id="{FC2C6A19-A3C3-4F88-BBF9-7DB4431F1756}"/>
+                <a16:creationId xmlns:a16="http://schemas.microsoft.com/office/drawing/2014/main" id="{AFDC4C1F-3DE9-453A-B5A9-9B56D2212195}"/>
               </a:ext>
             </a:extLst>
           </p:cNvPr>
@@ -7122,7 +7172,7 @@
           <p:cNvPr id="23" name="">
             <a:extLst xmlns:a="http://schemas.openxmlformats.org/drawingml/2006/main">
               <a:ext uri="{FF2B5EF4-FFF2-40B4-BE49-F238E27FC236}">
-                <a16:creationId xmlns:a16="http://schemas.microsoft.com/office/drawing/2014/main" id="{C6F12498-64CB-47B5-AE44-9FED79DECFD9}"/>
+                <a16:creationId xmlns:a16="http://schemas.microsoft.com/office/drawing/2014/main" id="{CAE84B2B-BDD7-4FDF-881E-3E8A8D3F2B92}"/>
               </a:ext>
             </a:extLst>
           </p:cNvPr>
@@ -7172,7 +7222,7 @@
           <p:cNvPr id="24" name="">
             <a:extLst xmlns:a="http://schemas.openxmlformats.org/drawingml/2006/main">
               <a:ext uri="{FF2B5EF4-FFF2-40B4-BE49-F238E27FC236}">
-                <a16:creationId xmlns:a16="http://schemas.microsoft.com/office/drawing/2014/main" id="{03C4682E-A308-4A7F-96F8-EF471541A279}"/>
+                <a16:creationId xmlns:a16="http://schemas.microsoft.com/office/drawing/2014/main" id="{3C1CFC43-622A-4716-BDB9-77087A660C76}"/>
               </a:ext>
             </a:extLst>
           </p:cNvPr>
@@ -7222,7 +7272,7 @@
           <p:cNvPr id="25" name="">
             <a:extLst xmlns:a="http://schemas.openxmlformats.org/drawingml/2006/main">
               <a:ext uri="{FF2B5EF4-FFF2-40B4-BE49-F238E27FC236}">
-                <a16:creationId xmlns:a16="http://schemas.microsoft.com/office/drawing/2014/main" id="{5110D63C-23B2-4B19-ACD3-B41F9F0A77C7}"/>
+                <a16:creationId xmlns:a16="http://schemas.microsoft.com/office/drawing/2014/main" id="{C8207292-FAA0-4D94-ABED-1B3CC4C96477}"/>
               </a:ext>
             </a:extLst>
           </p:cNvPr>
@@ -7270,7 +7320,7 @@
     </p:spTree>
     <p:extLst>
       <p:ext uri="{BB962C8B-B14F-4D97-AF65-F5344CB8AC3E}">
-        <p14:creationId xmlns:p14="http://schemas.microsoft.com/office/powerpoint/2010/main" val="1186375813"/>
+        <p14:creationId xmlns:p14="http://schemas.microsoft.com/office/powerpoint/2010/main" val="1000087918"/>
       </p:ext>
     </p:extLst>
   </p:cSld>
@@ -7301,7 +7351,7 @@
           <p:cNvPr id="1" name="">
             <a:extLst xmlns:a="http://schemas.openxmlformats.org/drawingml/2006/main">
               <a:ext uri="{FF2B5EF4-FFF2-40B4-BE49-F238E27FC236}">
-                <a16:creationId xmlns:a16="http://schemas.microsoft.com/office/drawing/2014/main" id="{2070B4D0-1354-4634-991C-1B754239534B}"/>
+                <a16:creationId xmlns:a16="http://schemas.microsoft.com/office/drawing/2014/main" id="{7543C49D-AAFD-49CC-A285-912B8F2765FD}"/>
               </a:ext>
             </a:extLst>
           </p:cNvPr>
@@ -7351,7 +7401,7 @@
           <p:cNvPr id="2" name="">
             <a:extLst xmlns:a="http://schemas.openxmlformats.org/drawingml/2006/main">
               <a:ext uri="{FF2B5EF4-FFF2-40B4-BE49-F238E27FC236}">
-                <a16:creationId xmlns:a16="http://schemas.microsoft.com/office/drawing/2014/main" id="{369E7611-93B0-42E6-9D05-1129621D5E8F}"/>
+                <a16:creationId xmlns:a16="http://schemas.microsoft.com/office/drawing/2014/main" id="{903E602B-2921-4E41-AC4B-E40B285A41A1}"/>
               </a:ext>
             </a:extLst>
           </p:cNvPr>
@@ -7401,7 +7451,7 @@
           <p:cNvPr id="3" name="">
             <a:extLst xmlns:a="http://schemas.openxmlformats.org/drawingml/2006/main">
               <a:ext uri="{FF2B5EF4-FFF2-40B4-BE49-F238E27FC236}">
-                <a16:creationId xmlns:a16="http://schemas.microsoft.com/office/drawing/2014/main" id="{1C01F3D1-D976-4AF9-8130-F6AEE2DB290F}"/>
+                <a16:creationId xmlns:a16="http://schemas.microsoft.com/office/drawing/2014/main" id="{703FC2D3-5787-4872-A6FB-38482CF275EA}"/>
               </a:ext>
             </a:extLst>
           </p:cNvPr>
@@ -7441,7 +7491,7 @@
                   <a:srgbClr val="5F6975"/>
                 </a:solidFill>
               </a:rPr>
-              <a:t>The recommendation is to start narrow, prove lift, then turn the evidence chain into a reusable product layer.</a:t>
+              <a:t>The recommendation is to start narrow, prove lift, then turn the evidence card into a reusable product layer.</a:t>
             </a:r>
           </a:p>
         </p:txBody>
@@ -7451,7 +7501,7 @@
           <p:cNvPr id="4" name="">
             <a:extLst xmlns:a="http://schemas.openxmlformats.org/drawingml/2006/main">
               <a:ext uri="{FF2B5EF4-FFF2-40B4-BE49-F238E27FC236}">
-                <a16:creationId xmlns:a16="http://schemas.microsoft.com/office/drawing/2014/main" id="{518BEC19-1E92-4A11-8BBC-6A311A5C7330}"/>
+                <a16:creationId xmlns:a16="http://schemas.microsoft.com/office/drawing/2014/main" id="{2ECF879E-6EEA-47A1-97B0-AF6D00FC7DF1}"/>
               </a:ext>
             </a:extLst>
           </p:cNvPr>
@@ -7486,7 +7536,7 @@
           <p:cNvPr id="5" name="">
             <a:extLst xmlns:a="http://schemas.openxmlformats.org/drawingml/2006/main">
               <a:ext uri="{FF2B5EF4-FFF2-40B4-BE49-F238E27FC236}">
-                <a16:creationId xmlns:a16="http://schemas.microsoft.com/office/drawing/2014/main" id="{B79B0F78-41A5-4B7B-ACC6-C5F7FD095D29}"/>
+                <a16:creationId xmlns:a16="http://schemas.microsoft.com/office/drawing/2014/main" id="{7FD6C74B-E9BA-4180-AD73-8FEAC3E904F1}"/>
               </a:ext>
             </a:extLst>
           </p:cNvPr>
@@ -7517,7 +7567,7 @@
           <p:cNvPr id="6" name="">
             <a:extLst xmlns:a="http://schemas.openxmlformats.org/drawingml/2006/main">
               <a:ext uri="{FF2B5EF4-FFF2-40B4-BE49-F238E27FC236}">
-                <a16:creationId xmlns:a16="http://schemas.microsoft.com/office/drawing/2014/main" id="{EE33040A-B4F6-40C6-AFA9-AC15775D369E}"/>
+                <a16:creationId xmlns:a16="http://schemas.microsoft.com/office/drawing/2014/main" id="{B0E08F5C-B7BD-4DF1-B169-5BA1B4746019}"/>
               </a:ext>
             </a:extLst>
           </p:cNvPr>
@@ -7567,7 +7617,7 @@
           <p:cNvPr id="7" name="">
             <a:extLst xmlns:a="http://schemas.openxmlformats.org/drawingml/2006/main">
               <a:ext uri="{FF2B5EF4-FFF2-40B4-BE49-F238E27FC236}">
-                <a16:creationId xmlns:a16="http://schemas.microsoft.com/office/drawing/2014/main" id="{14C91E11-AEE3-40B9-8BFE-1990A7A88C10}"/>
+                <a16:creationId xmlns:a16="http://schemas.microsoft.com/office/drawing/2014/main" id="{56837191-D0A0-4898-ABB3-A7155ED6BF68}"/>
               </a:ext>
             </a:extLst>
           </p:cNvPr>
@@ -7617,7 +7667,7 @@
           <p:cNvPr id="8" name="">
             <a:extLst xmlns:a="http://schemas.openxmlformats.org/drawingml/2006/main">
               <a:ext uri="{FF2B5EF4-FFF2-40B4-BE49-F238E27FC236}">
-                <a16:creationId xmlns:a16="http://schemas.microsoft.com/office/drawing/2014/main" id="{835F360A-BE51-4536-A8B3-A8B586B3DDB6}"/>
+                <a16:creationId xmlns:a16="http://schemas.microsoft.com/office/drawing/2014/main" id="{FC2CB8CB-FE37-42BA-AB1B-A17D4117A41F}"/>
               </a:ext>
             </a:extLst>
           </p:cNvPr>
@@ -7667,7 +7717,7 @@
           <p:cNvPr id="9" name="">
             <a:extLst xmlns:a="http://schemas.openxmlformats.org/drawingml/2006/main">
               <a:ext uri="{FF2B5EF4-FFF2-40B4-BE49-F238E27FC236}">
-                <a16:creationId xmlns:a16="http://schemas.microsoft.com/office/drawing/2014/main" id="{57372B19-3D54-40C4-B040-E2A250C12ED5}"/>
+                <a16:creationId xmlns:a16="http://schemas.microsoft.com/office/drawing/2014/main" id="{2582E57E-4F5A-46FB-8176-D1F913E7D0B6}"/>
               </a:ext>
             </a:extLst>
           </p:cNvPr>
@@ -7702,7 +7752,7 @@
           <p:cNvPr id="10" name="">
             <a:extLst xmlns:a="http://schemas.openxmlformats.org/drawingml/2006/main">
               <a:ext uri="{FF2B5EF4-FFF2-40B4-BE49-F238E27FC236}">
-                <a16:creationId xmlns:a16="http://schemas.microsoft.com/office/drawing/2014/main" id="{975EA848-EBE3-4B0F-AC73-0D483EEFFE14}"/>
+                <a16:creationId xmlns:a16="http://schemas.microsoft.com/office/drawing/2014/main" id="{E085903D-4131-4733-A723-65AAA2751EC7}"/>
               </a:ext>
             </a:extLst>
           </p:cNvPr>
@@ -7733,7 +7783,7 @@
           <p:cNvPr id="11" name="">
             <a:extLst xmlns:a="http://schemas.openxmlformats.org/drawingml/2006/main">
               <a:ext uri="{FF2B5EF4-FFF2-40B4-BE49-F238E27FC236}">
-                <a16:creationId xmlns:a16="http://schemas.microsoft.com/office/drawing/2014/main" id="{8061CD7F-4431-4130-A0BB-1BAB83021DA1}"/>
+                <a16:creationId xmlns:a16="http://schemas.microsoft.com/office/drawing/2014/main" id="{4DEC1A37-747D-4CC9-860C-BC991EEA192A}"/>
               </a:ext>
             </a:extLst>
           </p:cNvPr>
@@ -7783,7 +7833,7 @@
           <p:cNvPr id="12" name="">
             <a:extLst xmlns:a="http://schemas.openxmlformats.org/drawingml/2006/main">
               <a:ext uri="{FF2B5EF4-FFF2-40B4-BE49-F238E27FC236}">
-                <a16:creationId xmlns:a16="http://schemas.microsoft.com/office/drawing/2014/main" id="{23C11042-18C9-4B78-9538-6609B671E96C}"/>
+                <a16:creationId xmlns:a16="http://schemas.microsoft.com/office/drawing/2014/main" id="{4C0687AD-97FD-4B06-A5AC-D61BA8F1BED2}"/>
               </a:ext>
             </a:extLst>
           </p:cNvPr>
@@ -7833,7 +7883,7 @@
           <p:cNvPr id="13" name="">
             <a:extLst xmlns:a="http://schemas.openxmlformats.org/drawingml/2006/main">
               <a:ext uri="{FF2B5EF4-FFF2-40B4-BE49-F238E27FC236}">
-                <a16:creationId xmlns:a16="http://schemas.microsoft.com/office/drawing/2014/main" id="{39C7BB1D-B861-43BA-B8FB-43E9257BE308}"/>
+                <a16:creationId xmlns:a16="http://schemas.microsoft.com/office/drawing/2014/main" id="{E2592794-0B83-4198-9A69-BA20A85994EB}"/>
               </a:ext>
             </a:extLst>
           </p:cNvPr>
@@ -7883,7 +7933,7 @@
           <p:cNvPr id="14" name="">
             <a:extLst xmlns:a="http://schemas.openxmlformats.org/drawingml/2006/main">
               <a:ext uri="{FF2B5EF4-FFF2-40B4-BE49-F238E27FC236}">
-                <a16:creationId xmlns:a16="http://schemas.microsoft.com/office/drawing/2014/main" id="{333AC66E-00B7-476E-A6BF-25CCD7F1B2F6}"/>
+                <a16:creationId xmlns:a16="http://schemas.microsoft.com/office/drawing/2014/main" id="{7862EDFC-58AD-424C-9A45-3139C929EA85}"/>
               </a:ext>
             </a:extLst>
           </p:cNvPr>
@@ -7918,7 +7968,7 @@
           <p:cNvPr id="15" name="">
             <a:extLst xmlns:a="http://schemas.openxmlformats.org/drawingml/2006/main">
               <a:ext uri="{FF2B5EF4-FFF2-40B4-BE49-F238E27FC236}">
-                <a16:creationId xmlns:a16="http://schemas.microsoft.com/office/drawing/2014/main" id="{450D6D71-7637-4681-9CE1-149D7AFFCAD7}"/>
+                <a16:creationId xmlns:a16="http://schemas.microsoft.com/office/drawing/2014/main" id="{8C04B39F-82DD-4D33-8754-77A855961F04}"/>
               </a:ext>
             </a:extLst>
           </p:cNvPr>
@@ -7949,7 +7999,7 @@
           <p:cNvPr id="16" name="">
             <a:extLst xmlns:a="http://schemas.openxmlformats.org/drawingml/2006/main">
               <a:ext uri="{FF2B5EF4-FFF2-40B4-BE49-F238E27FC236}">
-                <a16:creationId xmlns:a16="http://schemas.microsoft.com/office/drawing/2014/main" id="{33E9D159-F7F3-4519-8BCF-417B85341671}"/>
+                <a16:creationId xmlns:a16="http://schemas.microsoft.com/office/drawing/2014/main" id="{26D82E97-FE7B-4CB8-8D31-D54A2869F617}"/>
               </a:ext>
             </a:extLst>
           </p:cNvPr>
@@ -7999,7 +8049,7 @@
           <p:cNvPr id="17" name="">
             <a:extLst xmlns:a="http://schemas.openxmlformats.org/drawingml/2006/main">
               <a:ext uri="{FF2B5EF4-FFF2-40B4-BE49-F238E27FC236}">
-                <a16:creationId xmlns:a16="http://schemas.microsoft.com/office/drawing/2014/main" id="{0C5701FE-9568-478E-BF0E-5F18144D0C1B}"/>
+                <a16:creationId xmlns:a16="http://schemas.microsoft.com/office/drawing/2014/main" id="{DAF86315-F5B9-4376-9F6F-93262FBDC0E5}"/>
               </a:ext>
             </a:extLst>
           </p:cNvPr>
@@ -8039,7 +8089,7 @@
                   <a:srgbClr val="101820"/>
                 </a:solidFill>
               </a:rPr>
-              <a:t>Evidence Chain Product</a:t>
+              <a:t>Evidence Card Product</a:t>
             </a:r>
           </a:p>
         </p:txBody>
@@ -8049,7 +8099,7 @@
           <p:cNvPr id="18" name="">
             <a:extLst xmlns:a="http://schemas.openxmlformats.org/drawingml/2006/main">
               <a:ext uri="{FF2B5EF4-FFF2-40B4-BE49-F238E27FC236}">
-                <a16:creationId xmlns:a16="http://schemas.microsoft.com/office/drawing/2014/main" id="{FDA718C2-A47E-43D3-8A30-9D2AB64338E8}"/>
+                <a16:creationId xmlns:a16="http://schemas.microsoft.com/office/drawing/2014/main" id="{671CA503-190C-41C2-BBB8-EF54020A1018}"/>
               </a:ext>
             </a:extLst>
           </p:cNvPr>
@@ -8089,7 +8139,7 @@
                   <a:srgbClr val="5F6975"/>
                 </a:solidFill>
               </a:rPr>
-              <a:t>Show graph path, peer comparison, time-series change, code-policy rationale, confidence, and next action.</a:t>
+              <a:t>Show graph path, peer comparison, time-series change, code-policy rationale, confidence, model-card note, reviewer override reason, and next action.</a:t>
             </a:r>
           </a:p>
         </p:txBody>
@@ -8099,7 +8149,7 @@
           <p:cNvPr id="19" name="">
             <a:extLst xmlns:a="http://schemas.openxmlformats.org/drawingml/2006/main">
               <a:ext uri="{FF2B5EF4-FFF2-40B4-BE49-F238E27FC236}">
-                <a16:creationId xmlns:a16="http://schemas.microsoft.com/office/drawing/2014/main" id="{1AD121F2-749D-4344-891E-B72B280DD16B}"/>
+                <a16:creationId xmlns:a16="http://schemas.microsoft.com/office/drawing/2014/main" id="{CAD37948-B5F8-49F9-B9EE-BA04634B7D7F}"/>
               </a:ext>
             </a:extLst>
           </p:cNvPr>
@@ -8132,7 +8182,7 @@
           <p:cNvPr id="20" name="">
             <a:extLst xmlns:a="http://schemas.openxmlformats.org/drawingml/2006/main">
               <a:ext uri="{FF2B5EF4-FFF2-40B4-BE49-F238E27FC236}">
-                <a16:creationId xmlns:a16="http://schemas.microsoft.com/office/drawing/2014/main" id="{B1ECE193-EEF7-4A96-9AE9-05C1ADDDE8C7}"/>
+                <a16:creationId xmlns:a16="http://schemas.microsoft.com/office/drawing/2014/main" id="{3C9A8569-C9F5-48D5-8D2C-E4EAC9F8DADD}"/>
               </a:ext>
             </a:extLst>
           </p:cNvPr>
@@ -8144,7 +8194,7 @@
         <p:spPr>
           <a:xfrm xmlns:a="http://schemas.openxmlformats.org/drawingml/2006/main">
             <a:off x="628650" y="5362575"/>
-            <a:ext cx="10382250" cy="400050"/>
+            <a:ext cx="10382250" cy="419100"/>
           </a:xfrm>
           <a:prstGeom xmlns:a="http://schemas.openxmlformats.org/drawingml/2006/main" prst="rect">
             <a:avLst/>
@@ -8160,19 +8210,19 @@
           <a:lstStyle xmlns:a="http://schemas.openxmlformats.org/drawingml/2006/main"/>
           <a:p xmlns:a="http://schemas.openxmlformats.org/drawingml/2006/main">
             <a:pPr algn="l">
-              <a:defRPr sz="1575" b="1">
+              <a:defRPr sz="1425" b="1">
                 <a:solidFill>
                   <a:srgbClr val="101820"/>
                 </a:solidFill>
               </a:defRPr>
             </a:pPr>
             <a:r>
-              <a:rPr sz="1575" b="1">
+              <a:rPr sz="1425" b="1">
                 <a:solidFill>
                   <a:srgbClr val="101820"/>
                 </a:solidFill>
               </a:rPr>
-              <a:t>Recommended starting point: pair Option 3 with a narrow Option 2 pilot in one domain such as wound care, DME, high-volume labs, or behavioral health.</a:t>
+              <a:t>Recommended starting point: pair Option 3 with a narrow Option 2 shadow-mode pilot in one domain such as wound care, DME, high-volume labs, or behavioral health.</a:t>
             </a:r>
           </a:p>
         </p:txBody>
@@ -8182,7 +8232,7 @@
           <p:cNvPr id="21" name="">
             <a:extLst xmlns:a="http://schemas.openxmlformats.org/drawingml/2006/main">
               <a:ext uri="{FF2B5EF4-FFF2-40B4-BE49-F238E27FC236}">
-                <a16:creationId xmlns:a16="http://schemas.microsoft.com/office/drawing/2014/main" id="{380FDF4B-09E4-412C-B9AB-C0AC93B0260A}"/>
+                <a16:creationId xmlns:a16="http://schemas.microsoft.com/office/drawing/2014/main" id="{4899B7B3-0696-4B97-9EE7-CA0DB86C7EB5}"/>
               </a:ext>
             </a:extLst>
           </p:cNvPr>
@@ -8220,7 +8270,7 @@
           <p:cNvPr id="22" name="">
             <a:extLst xmlns:a="http://schemas.openxmlformats.org/drawingml/2006/main">
               <a:ext uri="{FF2B5EF4-FFF2-40B4-BE49-F238E27FC236}">
-                <a16:creationId xmlns:a16="http://schemas.microsoft.com/office/drawing/2014/main" id="{CEE6634E-CFA6-42C8-8D1E-5A5E458E1529}"/>
+                <a16:creationId xmlns:a16="http://schemas.microsoft.com/office/drawing/2014/main" id="{75C1FF9A-8C78-4624-AC87-6FA5C6314EC9}"/>
               </a:ext>
             </a:extLst>
           </p:cNvPr>
@@ -8268,7 +8318,7 @@
     </p:spTree>
     <p:extLst>
       <p:ext uri="{BB962C8B-B14F-4D97-AF65-F5344CB8AC3E}">
-        <p14:creationId xmlns:p14="http://schemas.microsoft.com/office/powerpoint/2010/main" val="1487767940"/>
+        <p14:creationId xmlns:p14="http://schemas.microsoft.com/office/powerpoint/2010/main" val="887203988"/>
       </p:ext>
     </p:extLst>
   </p:cSld>
@@ -8299,7 +8349,7 @@
           <p:cNvPr id="1" name="">
             <a:extLst xmlns:a="http://schemas.openxmlformats.org/drawingml/2006/main">
               <a:ext uri="{FF2B5EF4-FFF2-40B4-BE49-F238E27FC236}">
-                <a16:creationId xmlns:a16="http://schemas.microsoft.com/office/drawing/2014/main" id="{CF50F5B1-F1C3-4735-B2A8-8884D78C0079}"/>
+                <a16:creationId xmlns:a16="http://schemas.microsoft.com/office/drawing/2014/main" id="{E00E07CD-A1C8-4029-8C77-01318F2B8747}"/>
               </a:ext>
             </a:extLst>
           </p:cNvPr>
@@ -8349,7 +8399,7 @@
           <p:cNvPr id="2" name="">
             <a:extLst xmlns:a="http://schemas.openxmlformats.org/drawingml/2006/main">
               <a:ext uri="{FF2B5EF4-FFF2-40B4-BE49-F238E27FC236}">
-                <a16:creationId xmlns:a16="http://schemas.microsoft.com/office/drawing/2014/main" id="{41A78670-1841-4E86-AD87-DB53BDD0DA36}"/>
+                <a16:creationId xmlns:a16="http://schemas.microsoft.com/office/drawing/2014/main" id="{734F0163-B2E9-4AF1-86F5-C56AC47697D3}"/>
               </a:ext>
             </a:extLst>
           </p:cNvPr>
@@ -8399,7 +8449,7 @@
           <p:cNvPr id="3" name="">
             <a:extLst xmlns:a="http://schemas.openxmlformats.org/drawingml/2006/main">
               <a:ext uri="{FF2B5EF4-FFF2-40B4-BE49-F238E27FC236}">
-                <a16:creationId xmlns:a16="http://schemas.microsoft.com/office/drawing/2014/main" id="{7C40A800-0ACB-456B-A66F-134D524F6121}"/>
+                <a16:creationId xmlns:a16="http://schemas.microsoft.com/office/drawing/2014/main" id="{FC575C50-FA35-4CF0-AB82-7ADB9FAA28D5}"/>
               </a:ext>
             </a:extLst>
           </p:cNvPr>
@@ -8449,7 +8499,7 @@
           <p:cNvPr id="4" name="">
             <a:extLst xmlns:a="http://schemas.openxmlformats.org/drawingml/2006/main">
               <a:ext uri="{FF2B5EF4-FFF2-40B4-BE49-F238E27FC236}">
-                <a16:creationId xmlns:a16="http://schemas.microsoft.com/office/drawing/2014/main" id="{20776F64-1E5F-4069-B11B-77E7812CFB40}"/>
+                <a16:creationId xmlns:a16="http://schemas.microsoft.com/office/drawing/2014/main" id="{EAD8F571-723B-4B86-955B-31EB31324FC1}"/>
               </a:ext>
             </a:extLst>
           </p:cNvPr>
@@ -8484,7 +8534,7 @@
           <p:cNvPr id="5" name="">
             <a:extLst xmlns:a="http://schemas.openxmlformats.org/drawingml/2006/main">
               <a:ext uri="{FF2B5EF4-FFF2-40B4-BE49-F238E27FC236}">
-                <a16:creationId xmlns:a16="http://schemas.microsoft.com/office/drawing/2014/main" id="{54D9F7AD-ECE2-49EB-A1C6-49F765B836CB}"/>
+                <a16:creationId xmlns:a16="http://schemas.microsoft.com/office/drawing/2014/main" id="{886C5256-CE02-41D5-B8A6-AF8BF6FACF8F}"/>
               </a:ext>
             </a:extLst>
           </p:cNvPr>
@@ -8534,7 +8584,7 @@
           <p:cNvPr id="6" name="">
             <a:extLst xmlns:a="http://schemas.openxmlformats.org/drawingml/2006/main">
               <a:ext uri="{FF2B5EF4-FFF2-40B4-BE49-F238E27FC236}">
-                <a16:creationId xmlns:a16="http://schemas.microsoft.com/office/drawing/2014/main" id="{D1E78A8D-B04D-4085-8B5C-576CED93A3B6}"/>
+                <a16:creationId xmlns:a16="http://schemas.microsoft.com/office/drawing/2014/main" id="{1163990A-4672-45D2-894D-D6E6CAEBDEDE}"/>
               </a:ext>
             </a:extLst>
           </p:cNvPr>
@@ -8584,7 +8634,7 @@
           <p:cNvPr id="7" name="">
             <a:extLst xmlns:a="http://schemas.openxmlformats.org/drawingml/2006/main">
               <a:ext uri="{FF2B5EF4-FFF2-40B4-BE49-F238E27FC236}">
-                <a16:creationId xmlns:a16="http://schemas.microsoft.com/office/drawing/2014/main" id="{B5913173-4F01-4AE7-8AB7-36CBD03A1058}"/>
+                <a16:creationId xmlns:a16="http://schemas.microsoft.com/office/drawing/2014/main" id="{5758E03D-0AD9-4920-B409-D9B558D75612}"/>
               </a:ext>
             </a:extLst>
           </p:cNvPr>
@@ -8634,7 +8684,7 @@
           <p:cNvPr id="8" name="">
             <a:extLst xmlns:a="http://schemas.openxmlformats.org/drawingml/2006/main">
               <a:ext uri="{FF2B5EF4-FFF2-40B4-BE49-F238E27FC236}">
-                <a16:creationId xmlns:a16="http://schemas.microsoft.com/office/drawing/2014/main" id="{0B0312E0-03F2-4DC3-93C5-6AD0FBC627FA}"/>
+                <a16:creationId xmlns:a16="http://schemas.microsoft.com/office/drawing/2014/main" id="{550D6DA7-A2C2-4FAF-8DAB-E7C6839F4CE9}"/>
               </a:ext>
             </a:extLst>
           </p:cNvPr>
@@ -8669,7 +8719,7 @@
           <p:cNvPr id="9" name="">
             <a:extLst xmlns:a="http://schemas.openxmlformats.org/drawingml/2006/main">
               <a:ext uri="{FF2B5EF4-FFF2-40B4-BE49-F238E27FC236}">
-                <a16:creationId xmlns:a16="http://schemas.microsoft.com/office/drawing/2014/main" id="{44CFA055-7E41-448E-B954-84A0BF8CB453}"/>
+                <a16:creationId xmlns:a16="http://schemas.microsoft.com/office/drawing/2014/main" id="{9C6414AA-E0F8-4B2C-905D-460519FD6F8B}"/>
               </a:ext>
             </a:extLst>
           </p:cNvPr>
@@ -8719,7 +8769,7 @@
           <p:cNvPr id="10" name="">
             <a:extLst xmlns:a="http://schemas.openxmlformats.org/drawingml/2006/main">
               <a:ext uri="{FF2B5EF4-FFF2-40B4-BE49-F238E27FC236}">
-                <a16:creationId xmlns:a16="http://schemas.microsoft.com/office/drawing/2014/main" id="{C5653576-46BE-4A13-9C2B-B5EABA15FCC9}"/>
+                <a16:creationId xmlns:a16="http://schemas.microsoft.com/office/drawing/2014/main" id="{5DC7647D-E162-4E11-9DE2-975665EEFFC0}"/>
               </a:ext>
             </a:extLst>
           </p:cNvPr>
@@ -8769,7 +8819,7 @@
           <p:cNvPr id="11" name="">
             <a:extLst xmlns:a="http://schemas.openxmlformats.org/drawingml/2006/main">
               <a:ext uri="{FF2B5EF4-FFF2-40B4-BE49-F238E27FC236}">
-                <a16:creationId xmlns:a16="http://schemas.microsoft.com/office/drawing/2014/main" id="{C207198E-EA49-4C51-A743-AE57410B2FC0}"/>
+                <a16:creationId xmlns:a16="http://schemas.microsoft.com/office/drawing/2014/main" id="{276E584A-C74E-43D2-9F94-0EFD538B093B}"/>
               </a:ext>
             </a:extLst>
           </p:cNvPr>
@@ -8819,7 +8869,7 @@
           <p:cNvPr id="12" name="">
             <a:extLst xmlns:a="http://schemas.openxmlformats.org/drawingml/2006/main">
               <a:ext uri="{FF2B5EF4-FFF2-40B4-BE49-F238E27FC236}">
-                <a16:creationId xmlns:a16="http://schemas.microsoft.com/office/drawing/2014/main" id="{E4F4104F-023B-41FB-BE54-A6D529B8E5B1}"/>
+                <a16:creationId xmlns:a16="http://schemas.microsoft.com/office/drawing/2014/main" id="{3A8E19F4-09E0-4EA9-BD30-82C0FB7CA8A3}"/>
               </a:ext>
             </a:extLst>
           </p:cNvPr>
@@ -8854,7 +8904,7 @@
           <p:cNvPr id="13" name="">
             <a:extLst xmlns:a="http://schemas.openxmlformats.org/drawingml/2006/main">
               <a:ext uri="{FF2B5EF4-FFF2-40B4-BE49-F238E27FC236}">
-                <a16:creationId xmlns:a16="http://schemas.microsoft.com/office/drawing/2014/main" id="{DED57EFB-C6BF-466E-B6B2-F8083F176344}"/>
+                <a16:creationId xmlns:a16="http://schemas.microsoft.com/office/drawing/2014/main" id="{5FEC8311-1F59-4293-B398-0D6DB7A38B40}"/>
               </a:ext>
             </a:extLst>
           </p:cNvPr>
@@ -8904,7 +8954,7 @@
           <p:cNvPr id="14" name="">
             <a:extLst xmlns:a="http://schemas.openxmlformats.org/drawingml/2006/main">
               <a:ext uri="{FF2B5EF4-FFF2-40B4-BE49-F238E27FC236}">
-                <a16:creationId xmlns:a16="http://schemas.microsoft.com/office/drawing/2014/main" id="{BC061A9D-F1ED-4A8B-BE8C-9962B600468F}"/>
+                <a16:creationId xmlns:a16="http://schemas.microsoft.com/office/drawing/2014/main" id="{6B35ADFE-0A0A-4A64-9E54-39AC94F698F8}"/>
               </a:ext>
             </a:extLst>
           </p:cNvPr>
@@ -8954,7 +9004,7 @@
           <p:cNvPr id="15" name="">
             <a:extLst xmlns:a="http://schemas.openxmlformats.org/drawingml/2006/main">
               <a:ext uri="{FF2B5EF4-FFF2-40B4-BE49-F238E27FC236}">
-                <a16:creationId xmlns:a16="http://schemas.microsoft.com/office/drawing/2014/main" id="{DBEEEDF0-70AE-4B36-ABAD-5FD81CCB61FC}"/>
+                <a16:creationId xmlns:a16="http://schemas.microsoft.com/office/drawing/2014/main" id="{092C30F8-65CF-4FE1-96FF-E299921186A4}"/>
               </a:ext>
             </a:extLst>
           </p:cNvPr>
@@ -9004,7 +9054,7 @@
           <p:cNvPr id="16" name="">
             <a:extLst xmlns:a="http://schemas.openxmlformats.org/drawingml/2006/main">
               <a:ext uri="{FF2B5EF4-FFF2-40B4-BE49-F238E27FC236}">
-                <a16:creationId xmlns:a16="http://schemas.microsoft.com/office/drawing/2014/main" id="{A8B3DE92-1DAB-4040-B0D1-915C759D5FAE}"/>
+                <a16:creationId xmlns:a16="http://schemas.microsoft.com/office/drawing/2014/main" id="{EDBE6C07-300C-4C65-BD5C-878997C11631}"/>
               </a:ext>
             </a:extLst>
           </p:cNvPr>
@@ -9039,7 +9089,7 @@
           <p:cNvPr id="17" name="">
             <a:extLst xmlns:a="http://schemas.openxmlformats.org/drawingml/2006/main">
               <a:ext uri="{FF2B5EF4-FFF2-40B4-BE49-F238E27FC236}">
-                <a16:creationId xmlns:a16="http://schemas.microsoft.com/office/drawing/2014/main" id="{914E3C3D-87D4-4F18-AB27-FDF7828258A7}"/>
+                <a16:creationId xmlns:a16="http://schemas.microsoft.com/office/drawing/2014/main" id="{2776274C-EDE1-42A4-87E4-34CB18F51FE8}"/>
               </a:ext>
             </a:extLst>
           </p:cNvPr>
@@ -9079,7 +9129,7 @@
                   <a:srgbClr val="101820"/>
                 </a:solidFill>
               </a:rPr>
-              <a:t>Evidence queue</a:t>
+              <a:t>Evidence card</a:t>
             </a:r>
           </a:p>
         </p:txBody>
@@ -9089,7 +9139,7 @@
           <p:cNvPr id="18" name="">
             <a:extLst xmlns:a="http://schemas.openxmlformats.org/drawingml/2006/main">
               <a:ext uri="{FF2B5EF4-FFF2-40B4-BE49-F238E27FC236}">
-                <a16:creationId xmlns:a16="http://schemas.microsoft.com/office/drawing/2014/main" id="{94146539-DA19-4712-A264-40345D36EC47}"/>
+                <a16:creationId xmlns:a16="http://schemas.microsoft.com/office/drawing/2014/main" id="{04873AE2-402F-45C9-9C9E-0FC3D60155A1}"/>
               </a:ext>
             </a:extLst>
           </p:cNvPr>
@@ -9129,7 +9179,7 @@
                   <a:srgbClr val="5F6975"/>
                 </a:solidFill>
               </a:rPr>
-              <a:t>Score anomalies, render graph paths, and recommend an action.</a:t>
+              <a:t>Score anomalies, render graph paths, and recommend a human review action.</a:t>
             </a:r>
           </a:p>
         </p:txBody>
@@ -9139,7 +9189,7 @@
           <p:cNvPr id="19" name="">
             <a:extLst xmlns:a="http://schemas.openxmlformats.org/drawingml/2006/main">
               <a:ext uri="{FF2B5EF4-FFF2-40B4-BE49-F238E27FC236}">
-                <a16:creationId xmlns:a16="http://schemas.microsoft.com/office/drawing/2014/main" id="{90853AA7-B5EF-4854-A7DD-BA0D38656BF6}"/>
+                <a16:creationId xmlns:a16="http://schemas.microsoft.com/office/drawing/2014/main" id="{67B8BF03-C80B-4AF5-8BEE-24BBD5936868}"/>
               </a:ext>
             </a:extLst>
           </p:cNvPr>
@@ -9172,7 +9222,7 @@
           <p:cNvPr id="20" name="">
             <a:extLst xmlns:a="http://schemas.openxmlformats.org/drawingml/2006/main">
               <a:ext uri="{FF2B5EF4-FFF2-40B4-BE49-F238E27FC236}">
-                <a16:creationId xmlns:a16="http://schemas.microsoft.com/office/drawing/2014/main" id="{31A48778-D7F4-4C34-8A15-16D5D126B168}"/>
+                <a16:creationId xmlns:a16="http://schemas.microsoft.com/office/drawing/2014/main" id="{5C5D30D7-90FA-4BC3-8EF8-B98FF34979E4}"/>
               </a:ext>
             </a:extLst>
           </p:cNvPr>
@@ -9212,7 +9262,7 @@
                   <a:srgbClr val="101820"/>
                 </a:solidFill>
               </a:rPr>
-              <a:t>Proof point: the demo can be shown in under three minutes, and every score has a human-readable reason trace.</a:t>
+              <a:t>Proof point: the demo can be shown in under three minutes, and every score has a reviewer-readable evidence card.</a:t>
             </a:r>
           </a:p>
         </p:txBody>
@@ -9222,7 +9272,7 @@
           <p:cNvPr id="21" name="">
             <a:extLst xmlns:a="http://schemas.openxmlformats.org/drawingml/2006/main">
               <a:ext uri="{FF2B5EF4-FFF2-40B4-BE49-F238E27FC236}">
-                <a16:creationId xmlns:a16="http://schemas.microsoft.com/office/drawing/2014/main" id="{D0588FA7-D620-4923-91E3-56A5FE41287F}"/>
+                <a16:creationId xmlns:a16="http://schemas.microsoft.com/office/drawing/2014/main" id="{F090EF52-A418-4188-9D01-FE092A8B9C99}"/>
               </a:ext>
             </a:extLst>
           </p:cNvPr>
@@ -9260,7 +9310,7 @@
           <p:cNvPr id="22" name="">
             <a:extLst xmlns:a="http://schemas.openxmlformats.org/drawingml/2006/main">
               <a:ext uri="{FF2B5EF4-FFF2-40B4-BE49-F238E27FC236}">
-                <a16:creationId xmlns:a16="http://schemas.microsoft.com/office/drawing/2014/main" id="{B90CFBFD-3C21-4445-8228-1221D4D8C0AC}"/>
+                <a16:creationId xmlns:a16="http://schemas.microsoft.com/office/drawing/2014/main" id="{B532F525-CD17-4213-8989-263077CBFAEC}"/>
               </a:ext>
             </a:extLst>
           </p:cNvPr>
@@ -9308,7 +9358,7 @@
     </p:spTree>
     <p:extLst>
       <p:ext uri="{BB962C8B-B14F-4D97-AF65-F5344CB8AC3E}">
-        <p14:creationId xmlns:p14="http://schemas.microsoft.com/office/powerpoint/2010/main" val="1434742678"/>
+        <p14:creationId xmlns:p14="http://schemas.microsoft.com/office/powerpoint/2010/main" val="1132919961"/>
       </p:ext>
     </p:extLst>
   </p:cSld>
@@ -9339,7 +9389,7 @@
           <p:cNvPr id="1" name="">
             <a:extLst xmlns:a="http://schemas.openxmlformats.org/drawingml/2006/main">
               <a:ext uri="{FF2B5EF4-FFF2-40B4-BE49-F238E27FC236}">
-                <a16:creationId xmlns:a16="http://schemas.microsoft.com/office/drawing/2014/main" id="{577FB0D1-F6D5-4561-A5FC-8BA8FE5EB6E5}"/>
+                <a16:creationId xmlns:a16="http://schemas.microsoft.com/office/drawing/2014/main" id="{807784DA-99FA-45A9-9C38-49171BD04434}"/>
               </a:ext>
             </a:extLst>
           </p:cNvPr>
@@ -9389,7 +9439,7 @@
           <p:cNvPr id="2" name="">
             <a:extLst xmlns:a="http://schemas.openxmlformats.org/drawingml/2006/main">
               <a:ext uri="{FF2B5EF4-FFF2-40B4-BE49-F238E27FC236}">
-                <a16:creationId xmlns:a16="http://schemas.microsoft.com/office/drawing/2014/main" id="{DF2FAEDD-A4F7-440B-82D7-F1C4059B5159}"/>
+                <a16:creationId xmlns:a16="http://schemas.microsoft.com/office/drawing/2014/main" id="{0185A7EB-3BE5-4399-B9A1-24538EF5A959}"/>
               </a:ext>
             </a:extLst>
           </p:cNvPr>
@@ -9439,7 +9489,7 @@
           <p:cNvPr id="3" name="">
             <a:extLst xmlns:a="http://schemas.openxmlformats.org/drawingml/2006/main">
               <a:ext uri="{FF2B5EF4-FFF2-40B4-BE49-F238E27FC236}">
-                <a16:creationId xmlns:a16="http://schemas.microsoft.com/office/drawing/2014/main" id="{8805443F-1502-4CA6-8DF4-4752B5216A5D}"/>
+                <a16:creationId xmlns:a16="http://schemas.microsoft.com/office/drawing/2014/main" id="{8D4B0371-9352-4D76-82E7-FA4FDE1D555B}"/>
               </a:ext>
             </a:extLst>
           </p:cNvPr>
@@ -9493,8 +9543,8 @@
           <p:nvPr/>
         </p:nvPicPr>
         <p:blipFill>
-          <a:blip xmlns:r="http://schemas.openxmlformats.org/officeDocument/2006/relationships" xmlns:a="http://schemas.openxmlformats.org/drawingml/2006/main" r:embed="R59e98dda420e4568"/>
-          <a:srcRect xmlns:a="http://schemas.openxmlformats.org/drawingml/2006/main" l="139" t="0" r="139" b="0"/>
+          <a:blip xmlns:r="http://schemas.openxmlformats.org/officeDocument/2006/relationships" xmlns:a="http://schemas.openxmlformats.org/drawingml/2006/main" r:embed="Ref6523f53b274b68"/>
+          <a:srcRect xmlns:a="http://schemas.openxmlformats.org/drawingml/2006/main" l="0" t="4875" r="0" b="4875"/>
           <a:stretch xmlns:a="http://schemas.openxmlformats.org/drawingml/2006/main">
             <a:fillRect l="0" t="0" r="0" b="0"/>
           </a:stretch>
@@ -9516,7 +9566,7 @@
           <p:cNvPr id="5" name="">
             <a:extLst xmlns:a="http://schemas.openxmlformats.org/drawingml/2006/main">
               <a:ext uri="{FF2B5EF4-FFF2-40B4-BE49-F238E27FC236}">
-                <a16:creationId xmlns:a16="http://schemas.microsoft.com/office/drawing/2014/main" id="{CFD6DB67-14B4-499C-A9B4-C9674E6A9441}"/>
+                <a16:creationId xmlns:a16="http://schemas.microsoft.com/office/drawing/2014/main" id="{53E6586D-D5E1-4AE3-9117-F447AB5916B2}"/>
               </a:ext>
             </a:extLst>
           </p:cNvPr>
@@ -9549,18 +9599,18 @@
           <p:cNvPr id="6" name="">
             <a:extLst xmlns:a="http://schemas.openxmlformats.org/drawingml/2006/main">
               <a:ext uri="{FF2B5EF4-FFF2-40B4-BE49-F238E27FC236}">
-                <a16:creationId xmlns:a16="http://schemas.microsoft.com/office/drawing/2014/main" id="{8CDD3220-2E45-4D35-B918-0AD0445228A1}"/>
-              </a:ext>
-            </a:extLst>
-          </p:cNvPr>
-          <p:cNvSpPr>
-            <a:spLocks xmlns:a="http://schemas.openxmlformats.org/drawingml/2006/main" noGrp="1"/>
-          </p:cNvSpPr>
-          <p:nvPr/>
-        </p:nvSpPr>
-        <p:spPr>
-          <a:xfrm xmlns:a="http://schemas.openxmlformats.org/drawingml/2006/main">
-            <a:off x="647700" y="2305050"/>
+                <a16:creationId xmlns:a16="http://schemas.microsoft.com/office/drawing/2014/main" id="{1D3FEE35-88B1-43D0-B397-82BF7DC38D80}"/>
+              </a:ext>
+            </a:extLst>
+          </p:cNvPr>
+          <p:cNvSpPr>
+            <a:spLocks xmlns:a="http://schemas.openxmlformats.org/drawingml/2006/main" noGrp="1"/>
+          </p:cNvSpPr>
+          <p:nvPr/>
+        </p:nvSpPr>
+        <p:spPr>
+          <a:xfrm xmlns:a="http://schemas.openxmlformats.org/drawingml/2006/main">
+            <a:off x="647700" y="2400300"/>
             <a:ext cx="95250" cy="95250"/>
           </a:xfrm>
           <a:prstGeom xmlns:a="http://schemas.openxmlformats.org/drawingml/2006/main" prst="rect">
@@ -9580,19 +9630,19 @@
           <p:cNvPr id="7" name="">
             <a:extLst xmlns:a="http://schemas.openxmlformats.org/drawingml/2006/main">
               <a:ext uri="{FF2B5EF4-FFF2-40B4-BE49-F238E27FC236}">
-                <a16:creationId xmlns:a16="http://schemas.microsoft.com/office/drawing/2014/main" id="{8651600C-9524-4BAB-ADF4-F04B9A8D3BE8}"/>
-              </a:ext>
-            </a:extLst>
-          </p:cNvPr>
-          <p:cNvSpPr>
-            <a:spLocks xmlns:a="http://schemas.openxmlformats.org/drawingml/2006/main" noGrp="1"/>
-          </p:cNvSpPr>
-          <p:nvPr/>
-        </p:nvSpPr>
-        <p:spPr>
-          <a:xfrm xmlns:a="http://schemas.openxmlformats.org/drawingml/2006/main">
-            <a:off x="876300" y="2228850"/>
-            <a:ext cx="2914650" cy="400050"/>
+                <a16:creationId xmlns:a16="http://schemas.microsoft.com/office/drawing/2014/main" id="{ECF8F987-159D-473C-91C1-EFD07DF031C7}"/>
+              </a:ext>
+            </a:extLst>
+          </p:cNvPr>
+          <p:cNvSpPr>
+            <a:spLocks xmlns:a="http://schemas.openxmlformats.org/drawingml/2006/main" noGrp="1"/>
+          </p:cNvSpPr>
+          <p:nvPr/>
+        </p:nvSpPr>
+        <p:spPr>
+          <a:xfrm xmlns:a="http://schemas.openxmlformats.org/drawingml/2006/main">
+            <a:off x="876300" y="2324100"/>
+            <a:ext cx="2914650" cy="342900"/>
           </a:xfrm>
           <a:prstGeom xmlns:a="http://schemas.openxmlformats.org/drawingml/2006/main" prst="rect">
             <a:avLst/>
@@ -9620,7 +9670,7 @@
                   <a:srgbClr val="101820"/>
                 </a:solidFill>
               </a:rPr>
-              <a:t>Click Train Local Baselines to show peer-group learning.</a:t>
+              <a:t>Train Local Baselines: peer-group learning.</a:t>
             </a:r>
           </a:p>
         </p:txBody>
@@ -9630,18 +9680,18 @@
           <p:cNvPr id="8" name="">
             <a:extLst xmlns:a="http://schemas.openxmlformats.org/drawingml/2006/main">
               <a:ext uri="{FF2B5EF4-FFF2-40B4-BE49-F238E27FC236}">
-                <a16:creationId xmlns:a16="http://schemas.microsoft.com/office/drawing/2014/main" id="{1FBA6B52-A71F-4F50-A20C-645E50B1F54A}"/>
-              </a:ext>
-            </a:extLst>
-          </p:cNvPr>
-          <p:cNvSpPr>
-            <a:spLocks xmlns:a="http://schemas.openxmlformats.org/drawingml/2006/main" noGrp="1"/>
-          </p:cNvSpPr>
-          <p:nvPr/>
-        </p:nvSpPr>
-        <p:spPr>
-          <a:xfrm xmlns:a="http://schemas.openxmlformats.org/drawingml/2006/main">
-            <a:off x="647700" y="2971800"/>
+                <a16:creationId xmlns:a16="http://schemas.microsoft.com/office/drawing/2014/main" id="{B22254ED-53E9-441F-9687-D1950B22A2C3}"/>
+              </a:ext>
+            </a:extLst>
+          </p:cNvPr>
+          <p:cNvSpPr>
+            <a:spLocks xmlns:a="http://schemas.openxmlformats.org/drawingml/2006/main" noGrp="1"/>
+          </p:cNvSpPr>
+          <p:nvPr/>
+        </p:nvSpPr>
+        <p:spPr>
+          <a:xfrm xmlns:a="http://schemas.openxmlformats.org/drawingml/2006/main">
+            <a:off x="647700" y="3028950"/>
             <a:ext cx="95250" cy="95250"/>
           </a:xfrm>
           <a:prstGeom xmlns:a="http://schemas.openxmlformats.org/drawingml/2006/main" prst="rect">
@@ -9661,19 +9711,19 @@
           <p:cNvPr id="9" name="">
             <a:extLst xmlns:a="http://schemas.openxmlformats.org/drawingml/2006/main">
               <a:ext uri="{FF2B5EF4-FFF2-40B4-BE49-F238E27FC236}">
-                <a16:creationId xmlns:a16="http://schemas.microsoft.com/office/drawing/2014/main" id="{B4DB4191-346C-46B9-8F30-22CB0CFECC9D}"/>
-              </a:ext>
-            </a:extLst>
-          </p:cNvPr>
-          <p:cNvSpPr>
-            <a:spLocks xmlns:a="http://schemas.openxmlformats.org/drawingml/2006/main" noGrp="1"/>
-          </p:cNvSpPr>
-          <p:nvPr/>
-        </p:nvSpPr>
-        <p:spPr>
-          <a:xfrm xmlns:a="http://schemas.openxmlformats.org/drawingml/2006/main">
-            <a:off x="876300" y="2895600"/>
-            <a:ext cx="2914650" cy="400050"/>
+                <a16:creationId xmlns:a16="http://schemas.microsoft.com/office/drawing/2014/main" id="{5733CE0D-3A50-4BEB-9DFD-B65AB59EAA35}"/>
+              </a:ext>
+            </a:extLst>
+          </p:cNvPr>
+          <p:cNvSpPr>
+            <a:spLocks xmlns:a="http://schemas.openxmlformats.org/drawingml/2006/main" noGrp="1"/>
+          </p:cNvSpPr>
+          <p:nvPr/>
+        </p:nvSpPr>
+        <p:spPr>
+          <a:xfrm xmlns:a="http://schemas.openxmlformats.org/drawingml/2006/main">
+            <a:off x="876300" y="2952750"/>
+            <a:ext cx="2914650" cy="342900"/>
           </a:xfrm>
           <a:prstGeom xmlns:a="http://schemas.openxmlformats.org/drawingml/2006/main" prst="rect">
             <a:avLst/>
@@ -9701,7 +9751,7 @@
                   <a:srgbClr val="101820"/>
                 </a:solidFill>
               </a:rPr>
-              <a:t>Click Share Federated Summary to show zero raw records shared.</a:t>
+              <a:t>Share Federated Summary: zero raw records shared.</a:t>
             </a:r>
           </a:p>
         </p:txBody>
@@ -9711,18 +9761,18 @@
           <p:cNvPr id="10" name="">
             <a:extLst xmlns:a="http://schemas.openxmlformats.org/drawingml/2006/main">
               <a:ext uri="{FF2B5EF4-FFF2-40B4-BE49-F238E27FC236}">
-                <a16:creationId xmlns:a16="http://schemas.microsoft.com/office/drawing/2014/main" id="{50AF50F9-0132-40E9-9181-7E3EAD6EF5F5}"/>
-              </a:ext>
-            </a:extLst>
-          </p:cNvPr>
-          <p:cNvSpPr>
-            <a:spLocks xmlns:a="http://schemas.openxmlformats.org/drawingml/2006/main" noGrp="1"/>
-          </p:cNvSpPr>
-          <p:nvPr/>
-        </p:nvSpPr>
-        <p:spPr>
-          <a:xfrm xmlns:a="http://schemas.openxmlformats.org/drawingml/2006/main">
-            <a:off x="647700" y="3638550"/>
+                <a16:creationId xmlns:a16="http://schemas.microsoft.com/office/drawing/2014/main" id="{9B00CB18-351F-4315-97B5-534AAD8E716E}"/>
+              </a:ext>
+            </a:extLst>
+          </p:cNvPr>
+          <p:cNvSpPr>
+            <a:spLocks xmlns:a="http://schemas.openxmlformats.org/drawingml/2006/main" noGrp="1"/>
+          </p:cNvSpPr>
+          <p:nvPr/>
+        </p:nvSpPr>
+        <p:spPr>
+          <a:xfrm xmlns:a="http://schemas.openxmlformats.org/drawingml/2006/main">
+            <a:off x="647700" y="3657600"/>
             <a:ext cx="95250" cy="95250"/>
           </a:xfrm>
           <a:prstGeom xmlns:a="http://schemas.openxmlformats.org/drawingml/2006/main" prst="rect">
@@ -9742,19 +9792,19 @@
           <p:cNvPr id="11" name="">
             <a:extLst xmlns:a="http://schemas.openxmlformats.org/drawingml/2006/main">
               <a:ext uri="{FF2B5EF4-FFF2-40B4-BE49-F238E27FC236}">
-                <a16:creationId xmlns:a16="http://schemas.microsoft.com/office/drawing/2014/main" id="{793AAA1E-C9CF-4130-876F-9C5B0EAC4DC5}"/>
-              </a:ext>
-            </a:extLst>
-          </p:cNvPr>
-          <p:cNvSpPr>
-            <a:spLocks xmlns:a="http://schemas.openxmlformats.org/drawingml/2006/main" noGrp="1"/>
-          </p:cNvSpPr>
-          <p:nvPr/>
-        </p:nvSpPr>
-        <p:spPr>
-          <a:xfrm xmlns:a="http://schemas.openxmlformats.org/drawingml/2006/main">
-            <a:off x="876300" y="3562350"/>
-            <a:ext cx="2914650" cy="400050"/>
+                <a16:creationId xmlns:a16="http://schemas.microsoft.com/office/drawing/2014/main" id="{C87E10F9-6F5B-4462-874A-AE601764B0B3}"/>
+              </a:ext>
+            </a:extLst>
+          </p:cNvPr>
+          <p:cNvSpPr>
+            <a:spLocks xmlns:a="http://schemas.openxmlformats.org/drawingml/2006/main" noGrp="1"/>
+          </p:cNvSpPr>
+          <p:nvPr/>
+        </p:nvSpPr>
+        <p:spPr>
+          <a:xfrm xmlns:a="http://schemas.openxmlformats.org/drawingml/2006/main">
+            <a:off x="876300" y="3581400"/>
+            <a:ext cx="2914650" cy="342900"/>
           </a:xfrm>
           <a:prstGeom xmlns:a="http://schemas.openxmlformats.org/drawingml/2006/main" prst="rect">
             <a:avLst/>
@@ -9782,7 +9832,7 @@
                   <a:srgbClr val="101820"/>
                 </a:solidFill>
               </a:rPr>
-              <a:t>Select a high-risk claim and explain graph path plus reason chain.</a:t>
+              <a:t>Select high-risk claim: graph path plus evidence card.</a:t>
             </a:r>
           </a:p>
         </p:txBody>
@@ -9792,18 +9842,18 @@
           <p:cNvPr id="12" name="">
             <a:extLst xmlns:a="http://schemas.openxmlformats.org/drawingml/2006/main">
               <a:ext uri="{FF2B5EF4-FFF2-40B4-BE49-F238E27FC236}">
-                <a16:creationId xmlns:a16="http://schemas.microsoft.com/office/drawing/2014/main" id="{58F065CC-437D-490B-861C-9B3649B06632}"/>
-              </a:ext>
-            </a:extLst>
-          </p:cNvPr>
-          <p:cNvSpPr>
-            <a:spLocks xmlns:a="http://schemas.openxmlformats.org/drawingml/2006/main" noGrp="1"/>
-          </p:cNvSpPr>
-          <p:nvPr/>
-        </p:nvSpPr>
-        <p:spPr>
-          <a:xfrm xmlns:a="http://schemas.openxmlformats.org/drawingml/2006/main">
-            <a:off x="647700" y="4305300"/>
+                <a16:creationId xmlns:a16="http://schemas.microsoft.com/office/drawing/2014/main" id="{867C611A-9927-4CEE-8131-73341343C1D6}"/>
+              </a:ext>
+            </a:extLst>
+          </p:cNvPr>
+          <p:cNvSpPr>
+            <a:spLocks xmlns:a="http://schemas.openxmlformats.org/drawingml/2006/main" noGrp="1"/>
+          </p:cNvSpPr>
+          <p:nvPr/>
+        </p:nvSpPr>
+        <p:spPr>
+          <a:xfrm xmlns:a="http://schemas.openxmlformats.org/drawingml/2006/main">
+            <a:off x="647700" y="4286250"/>
             <a:ext cx="95250" cy="95250"/>
           </a:xfrm>
           <a:prstGeom xmlns:a="http://schemas.openxmlformats.org/drawingml/2006/main" prst="rect">
@@ -9823,19 +9873,19 @@
           <p:cNvPr id="13" name="">
             <a:extLst xmlns:a="http://schemas.openxmlformats.org/drawingml/2006/main">
               <a:ext uri="{FF2B5EF4-FFF2-40B4-BE49-F238E27FC236}">
-                <a16:creationId xmlns:a16="http://schemas.microsoft.com/office/drawing/2014/main" id="{8D38BEFC-4AD3-4794-B053-96B63CF8BF25}"/>
-              </a:ext>
-            </a:extLst>
-          </p:cNvPr>
-          <p:cNvSpPr>
-            <a:spLocks xmlns:a="http://schemas.openxmlformats.org/drawingml/2006/main" noGrp="1"/>
-          </p:cNvSpPr>
-          <p:nvPr/>
-        </p:nvSpPr>
-        <p:spPr>
-          <a:xfrm xmlns:a="http://schemas.openxmlformats.org/drawingml/2006/main">
-            <a:off x="876300" y="4229100"/>
-            <a:ext cx="2914650" cy="400050"/>
+                <a16:creationId xmlns:a16="http://schemas.microsoft.com/office/drawing/2014/main" id="{FBAAC7B6-FFB0-45D5-8EE9-300A3288CB8F}"/>
+              </a:ext>
+            </a:extLst>
+          </p:cNvPr>
+          <p:cNvSpPr>
+            <a:spLocks xmlns:a="http://schemas.openxmlformats.org/drawingml/2006/main" noGrp="1"/>
+          </p:cNvSpPr>
+          <p:nvPr/>
+        </p:nvSpPr>
+        <p:spPr>
+          <a:xfrm xmlns:a="http://schemas.openxmlformats.org/drawingml/2006/main">
+            <a:off x="876300" y="4210050"/>
+            <a:ext cx="2914650" cy="342900"/>
           </a:xfrm>
           <a:prstGeom xmlns:a="http://schemas.openxmlformats.org/drawingml/2006/main" prst="rect">
             <a:avLst/>
@@ -9863,7 +9913,7 @@
                   <a:srgbClr val="101820"/>
                 </a:solidFill>
               </a:rPr>
-              <a:t>Export an audit packet to show investigator handoff thinking.</a:t>
+              <a:t>Export Evidence Card: reviewer handoff.</a:t>
             </a:r>
           </a:p>
         </p:txBody>
@@ -9873,7 +9923,7 @@
           <p:cNvPr id="14" name="">
             <a:extLst xmlns:a="http://schemas.openxmlformats.org/drawingml/2006/main">
               <a:ext uri="{FF2B5EF4-FFF2-40B4-BE49-F238E27FC236}">
-                <a16:creationId xmlns:a16="http://schemas.microsoft.com/office/drawing/2014/main" id="{AD6920C3-E25F-414B-A15E-17FB46167292}"/>
+                <a16:creationId xmlns:a16="http://schemas.microsoft.com/office/drawing/2014/main" id="{B822F2AE-1E6F-48E6-99B4-CB73F7BA0207}"/>
               </a:ext>
             </a:extLst>
           </p:cNvPr>
@@ -9923,7 +9973,7 @@
           <p:cNvPr id="15" name="">
             <a:extLst xmlns:a="http://schemas.openxmlformats.org/drawingml/2006/main">
               <a:ext uri="{FF2B5EF4-FFF2-40B4-BE49-F238E27FC236}">
-                <a16:creationId xmlns:a16="http://schemas.microsoft.com/office/drawing/2014/main" id="{7DFDF734-7694-4347-A9A2-FDC37A63E568}"/>
+                <a16:creationId xmlns:a16="http://schemas.microsoft.com/office/drawing/2014/main" id="{533B4A78-177F-47CA-B595-B47997CC1D82}"/>
               </a:ext>
             </a:extLst>
           </p:cNvPr>
@@ -9971,7 +10021,7 @@
     </p:spTree>
     <p:extLst>
       <p:ext uri="{BB962C8B-B14F-4D97-AF65-F5344CB8AC3E}">
-        <p14:creationId xmlns:p14="http://schemas.microsoft.com/office/powerpoint/2010/main" val="1111874206"/>
+        <p14:creationId xmlns:p14="http://schemas.microsoft.com/office/powerpoint/2010/main" val="1263290743"/>
       </p:ext>
     </p:extLst>
   </p:cSld>
@@ -10002,7 +10052,7 @@
           <p:cNvPr id="1" name="">
             <a:extLst xmlns:a="http://schemas.openxmlformats.org/drawingml/2006/main">
               <a:ext uri="{FF2B5EF4-FFF2-40B4-BE49-F238E27FC236}">
-                <a16:creationId xmlns:a16="http://schemas.microsoft.com/office/drawing/2014/main" id="{C6B9BEF0-D083-465A-98C9-0B5B23C42C98}"/>
+                <a16:creationId xmlns:a16="http://schemas.microsoft.com/office/drawing/2014/main" id="{E6CBA96E-CCCC-4009-B82A-489C2C8C9A22}"/>
               </a:ext>
             </a:extLst>
           </p:cNvPr>
@@ -10052,7 +10102,7 @@
           <p:cNvPr id="2" name="">
             <a:extLst xmlns:a="http://schemas.openxmlformats.org/drawingml/2006/main">
               <a:ext uri="{FF2B5EF4-FFF2-40B4-BE49-F238E27FC236}">
-                <a16:creationId xmlns:a16="http://schemas.microsoft.com/office/drawing/2014/main" id="{500A3C89-F2E8-43FA-AADD-F6CED13C3F6A}"/>
+                <a16:creationId xmlns:a16="http://schemas.microsoft.com/office/drawing/2014/main" id="{FA64ABD2-2710-4190-9D1C-C54910CB76BE}"/>
               </a:ext>
             </a:extLst>
           </p:cNvPr>
@@ -10102,7 +10152,7 @@
           <p:cNvPr id="3" name="">
             <a:extLst xmlns:a="http://schemas.openxmlformats.org/drawingml/2006/main">
               <a:ext uri="{FF2B5EF4-FFF2-40B4-BE49-F238E27FC236}">
-                <a16:creationId xmlns:a16="http://schemas.microsoft.com/office/drawing/2014/main" id="{BF16092E-42C4-4933-81EB-1ECDDC20F3EA}"/>
+                <a16:creationId xmlns:a16="http://schemas.microsoft.com/office/drawing/2014/main" id="{CF07684D-2F00-4853-83FB-A1A262316503}"/>
               </a:ext>
             </a:extLst>
           </p:cNvPr>
@@ -10152,7 +10202,7 @@
           <p:cNvPr id="4" name="">
             <a:extLst xmlns:a="http://schemas.openxmlformats.org/drawingml/2006/main">
               <a:ext uri="{FF2B5EF4-FFF2-40B4-BE49-F238E27FC236}">
-                <a16:creationId xmlns:a16="http://schemas.microsoft.com/office/drawing/2014/main" id="{4FB9076F-D7E3-4CCA-8522-0187DB712C5E}"/>
+                <a16:creationId xmlns:a16="http://schemas.microsoft.com/office/drawing/2014/main" id="{B4C00A21-6D3E-4A34-A6E3-8DAF9B088A82}"/>
               </a:ext>
             </a:extLst>
           </p:cNvPr>
@@ -10202,7 +10252,7 @@
           <p:cNvPr id="5" name="">
             <a:extLst xmlns:a="http://schemas.openxmlformats.org/drawingml/2006/main">
               <a:ext uri="{FF2B5EF4-FFF2-40B4-BE49-F238E27FC236}">
-                <a16:creationId xmlns:a16="http://schemas.microsoft.com/office/drawing/2014/main" id="{517C1089-F456-40CE-91EC-8511FACAD102}"/>
+                <a16:creationId xmlns:a16="http://schemas.microsoft.com/office/drawing/2014/main" id="{44552212-E055-45EE-AD34-211214B7DC0B}"/>
               </a:ext>
             </a:extLst>
           </p:cNvPr>
@@ -10252,7 +10302,7 @@
           <p:cNvPr id="6" name="">
             <a:extLst xmlns:a="http://schemas.openxmlformats.org/drawingml/2006/main">
               <a:ext uri="{FF2B5EF4-FFF2-40B4-BE49-F238E27FC236}">
-                <a16:creationId xmlns:a16="http://schemas.microsoft.com/office/drawing/2014/main" id="{4C73B9B4-0B5C-4CA4-A066-57D738291E06}"/>
+                <a16:creationId xmlns:a16="http://schemas.microsoft.com/office/drawing/2014/main" id="{1D0BD069-583B-4D77-A13C-14CCCD72B516}"/>
               </a:ext>
             </a:extLst>
           </p:cNvPr>
@@ -10302,7 +10352,7 @@
           <p:cNvPr id="7" name="">
             <a:extLst xmlns:a="http://schemas.openxmlformats.org/drawingml/2006/main">
               <a:ext uri="{FF2B5EF4-FFF2-40B4-BE49-F238E27FC236}">
-                <a16:creationId xmlns:a16="http://schemas.microsoft.com/office/drawing/2014/main" id="{2839A2C4-F6A6-4D7C-87F1-550D559D9A5B}"/>
+                <a16:creationId xmlns:a16="http://schemas.microsoft.com/office/drawing/2014/main" id="{BC142DB3-E184-4D79-9834-E7A05B3E0B3A}"/>
               </a:ext>
             </a:extLst>
           </p:cNvPr>
@@ -10333,7 +10383,7 @@
           <p:cNvPr id="8" name="">
             <a:extLst xmlns:a="http://schemas.openxmlformats.org/drawingml/2006/main">
               <a:ext uri="{FF2B5EF4-FFF2-40B4-BE49-F238E27FC236}">
-                <a16:creationId xmlns:a16="http://schemas.microsoft.com/office/drawing/2014/main" id="{C8BD9D7A-F2FE-4ECE-88B5-70A927DA3789}"/>
+                <a16:creationId xmlns:a16="http://schemas.microsoft.com/office/drawing/2014/main" id="{464EACE4-8DDA-44B4-A911-45C92A013F71}"/>
               </a:ext>
             </a:extLst>
           </p:cNvPr>
@@ -10383,7 +10433,7 @@
           <p:cNvPr id="9" name="">
             <a:extLst xmlns:a="http://schemas.openxmlformats.org/drawingml/2006/main">
               <a:ext uri="{FF2B5EF4-FFF2-40B4-BE49-F238E27FC236}">
-                <a16:creationId xmlns:a16="http://schemas.microsoft.com/office/drawing/2014/main" id="{739B942E-EEB3-4817-B245-02FEF13CDB56}"/>
+                <a16:creationId xmlns:a16="http://schemas.microsoft.com/office/drawing/2014/main" id="{533942B0-D8DD-4628-99A9-889CA8EB5EE4}"/>
               </a:ext>
             </a:extLst>
           </p:cNvPr>
@@ -10433,7 +10483,7 @@
           <p:cNvPr id="10" name="">
             <a:extLst xmlns:a="http://schemas.openxmlformats.org/drawingml/2006/main">
               <a:ext uri="{FF2B5EF4-FFF2-40B4-BE49-F238E27FC236}">
-                <a16:creationId xmlns:a16="http://schemas.microsoft.com/office/drawing/2014/main" id="{5C9C358F-958E-4ADE-BCBF-FC2410B90162}"/>
+                <a16:creationId xmlns:a16="http://schemas.microsoft.com/office/drawing/2014/main" id="{7D2CC58C-7528-4B5B-9B2C-FDA2574A4F31}"/>
               </a:ext>
             </a:extLst>
           </p:cNvPr>
@@ -10483,7 +10533,7 @@
           <p:cNvPr id="11" name="">
             <a:extLst xmlns:a="http://schemas.openxmlformats.org/drawingml/2006/main">
               <a:ext uri="{FF2B5EF4-FFF2-40B4-BE49-F238E27FC236}">
-                <a16:creationId xmlns:a16="http://schemas.microsoft.com/office/drawing/2014/main" id="{698FA399-EDF4-4B83-B7E9-31703DCAC6F4}"/>
+                <a16:creationId xmlns:a16="http://schemas.microsoft.com/office/drawing/2014/main" id="{A2ABD0AA-76DA-4E76-9573-BDCF900A1C10}"/>
               </a:ext>
             </a:extLst>
           </p:cNvPr>
@@ -10514,7 +10564,7 @@
           <p:cNvPr id="12" name="">
             <a:extLst xmlns:a="http://schemas.openxmlformats.org/drawingml/2006/main">
               <a:ext uri="{FF2B5EF4-FFF2-40B4-BE49-F238E27FC236}">
-                <a16:creationId xmlns:a16="http://schemas.microsoft.com/office/drawing/2014/main" id="{E6B4C5F3-9B91-4286-A3E0-5D800E124C77}"/>
+                <a16:creationId xmlns:a16="http://schemas.microsoft.com/office/drawing/2014/main" id="{07FB94CD-5CED-4FE4-93B4-9C8F7BEEB360}"/>
               </a:ext>
             </a:extLst>
           </p:cNvPr>
@@ -10564,7 +10614,7 @@
           <p:cNvPr id="13" name="">
             <a:extLst xmlns:a="http://schemas.openxmlformats.org/drawingml/2006/main">
               <a:ext uri="{FF2B5EF4-FFF2-40B4-BE49-F238E27FC236}">
-                <a16:creationId xmlns:a16="http://schemas.microsoft.com/office/drawing/2014/main" id="{D61DC01D-E53B-4012-8F49-6AB468C62E50}"/>
+                <a16:creationId xmlns:a16="http://schemas.microsoft.com/office/drawing/2014/main" id="{ED42B8EF-8FD5-453F-93EA-A61C1441486E}"/>
               </a:ext>
             </a:extLst>
           </p:cNvPr>
@@ -10604,7 +10654,7 @@
                   <a:srgbClr val="101820"/>
                 </a:solidFill>
               </a:rPr>
-              <a:t>Compare to current review</a:t>
+              <a:t>Shadow-mode comparison</a:t>
             </a:r>
           </a:p>
         </p:txBody>
@@ -10614,7 +10664,7 @@
           <p:cNvPr id="14" name="">
             <a:extLst xmlns:a="http://schemas.openxmlformats.org/drawingml/2006/main">
               <a:ext uri="{FF2B5EF4-FFF2-40B4-BE49-F238E27FC236}">
-                <a16:creationId xmlns:a16="http://schemas.microsoft.com/office/drawing/2014/main" id="{E2774353-2BCC-481B-9B6C-73CF9125F3A8}"/>
+                <a16:creationId xmlns:a16="http://schemas.microsoft.com/office/drawing/2014/main" id="{2A216E81-61AA-431E-A474-4596B6167900}"/>
               </a:ext>
             </a:extLst>
           </p:cNvPr>
@@ -10654,7 +10704,7 @@
                   <a:srgbClr val="5F6975"/>
                 </a:solidFill>
               </a:rPr>
-              <a:t>Precision, recall proxy, auditor agreement, provider abrasion, and turnaround.</a:t>
+              <a:t>Precision, recall proxy, reviewer agreement, provider abrasion, and turnaround.</a:t>
             </a:r>
           </a:p>
         </p:txBody>
@@ -10664,7 +10714,7 @@
           <p:cNvPr id="15" name="">
             <a:extLst xmlns:a="http://schemas.openxmlformats.org/drawingml/2006/main">
               <a:ext uri="{FF2B5EF4-FFF2-40B4-BE49-F238E27FC236}">
-                <a16:creationId xmlns:a16="http://schemas.microsoft.com/office/drawing/2014/main" id="{803C5E4A-FC63-48B6-A637-D01F3E83EFC9}"/>
+                <a16:creationId xmlns:a16="http://schemas.microsoft.com/office/drawing/2014/main" id="{5BE6A73C-02D9-4AA8-A27A-474E60E8782F}"/>
               </a:ext>
             </a:extLst>
           </p:cNvPr>
@@ -10695,7 +10745,7 @@
           <p:cNvPr id="16" name="">
             <a:extLst xmlns:a="http://schemas.openxmlformats.org/drawingml/2006/main">
               <a:ext uri="{FF2B5EF4-FFF2-40B4-BE49-F238E27FC236}">
-                <a16:creationId xmlns:a16="http://schemas.microsoft.com/office/drawing/2014/main" id="{5DE35B43-D541-4AD3-AABD-EE234A634D5F}"/>
+                <a16:creationId xmlns:a16="http://schemas.microsoft.com/office/drawing/2014/main" id="{5F0A98AF-BD38-4000-B644-3064754DE7DD}"/>
               </a:ext>
             </a:extLst>
           </p:cNvPr>
@@ -10745,7 +10795,7 @@
           <p:cNvPr id="17" name="">
             <a:extLst xmlns:a="http://schemas.openxmlformats.org/drawingml/2006/main">
               <a:ext uri="{FF2B5EF4-FFF2-40B4-BE49-F238E27FC236}">
-                <a16:creationId xmlns:a16="http://schemas.microsoft.com/office/drawing/2014/main" id="{5A9246F6-50CF-4F20-A493-60E3EBE2D2CD}"/>
+                <a16:creationId xmlns:a16="http://schemas.microsoft.com/office/drawing/2014/main" id="{608B9045-446D-4202-8D15-7B57EA931936}"/>
               </a:ext>
             </a:extLst>
           </p:cNvPr>
@@ -10795,7 +10845,7 @@
           <p:cNvPr id="18" name="">
             <a:extLst xmlns:a="http://schemas.openxmlformats.org/drawingml/2006/main">
               <a:ext uri="{FF2B5EF4-FFF2-40B4-BE49-F238E27FC236}">
-                <a16:creationId xmlns:a16="http://schemas.microsoft.com/office/drawing/2014/main" id="{2D9B8674-4E13-4F61-A4AE-D9222E98CEDA}"/>
+                <a16:creationId xmlns:a16="http://schemas.microsoft.com/office/drawing/2014/main" id="{1BA63BFF-CF8D-4340-8665-45D3DADCCB2D}"/>
               </a:ext>
             </a:extLst>
           </p:cNvPr>
@@ -10845,7 +10895,7 @@
           <p:cNvPr id="19" name="">
             <a:extLst xmlns:a="http://schemas.openxmlformats.org/drawingml/2006/main">
               <a:ext uri="{FF2B5EF4-FFF2-40B4-BE49-F238E27FC236}">
-                <a16:creationId xmlns:a16="http://schemas.microsoft.com/office/drawing/2014/main" id="{D516180A-634C-4008-BAF5-26ACBA7710C3}"/>
+                <a16:creationId xmlns:a16="http://schemas.microsoft.com/office/drawing/2014/main" id="{E38BE0A6-CA8E-491C-AD78-64E8B9DC3849}"/>
               </a:ext>
             </a:extLst>
           </p:cNvPr>
@@ -10876,19 +10926,19 @@
           <p:cNvPr id="20" name="">
             <a:extLst xmlns:a="http://schemas.openxmlformats.org/drawingml/2006/main">
               <a:ext uri="{FF2B5EF4-FFF2-40B4-BE49-F238E27FC236}">
-                <a16:creationId xmlns:a16="http://schemas.microsoft.com/office/drawing/2014/main" id="{05B92F2B-8F17-486B-A0BD-342F6157C58A}"/>
-              </a:ext>
-            </a:extLst>
-          </p:cNvPr>
-          <p:cNvSpPr>
-            <a:spLocks xmlns:a="http://schemas.openxmlformats.org/drawingml/2006/main" noGrp="1"/>
-          </p:cNvSpPr>
-          <p:nvPr/>
-        </p:nvSpPr>
-        <p:spPr>
-          <a:xfrm xmlns:a="http://schemas.openxmlformats.org/drawingml/2006/main">
-            <a:off x="400050" y="5715000"/>
-            <a:ext cx="9906000" cy="457200"/>
+                <a16:creationId xmlns:a16="http://schemas.microsoft.com/office/drawing/2014/main" id="{3E79D0C9-B616-4963-A30C-2E3DEAA04E78}"/>
+              </a:ext>
+            </a:extLst>
+          </p:cNvPr>
+          <p:cNvSpPr>
+            <a:spLocks xmlns:a="http://schemas.openxmlformats.org/drawingml/2006/main" noGrp="1"/>
+          </p:cNvSpPr>
+          <p:nvPr/>
+        </p:nvSpPr>
+        <p:spPr>
+          <a:xfrm xmlns:a="http://schemas.openxmlformats.org/drawingml/2006/main">
+            <a:off x="400050" y="5619750"/>
+            <a:ext cx="9906000" cy="419100"/>
           </a:xfrm>
           <a:prstGeom xmlns:a="http://schemas.openxmlformats.org/drawingml/2006/main" prst="rect">
             <a:avLst/>
@@ -10926,7 +10976,57 @@
           <p:cNvPr id="21" name="">
             <a:extLst xmlns:a="http://schemas.openxmlformats.org/drawingml/2006/main">
               <a:ext uri="{FF2B5EF4-FFF2-40B4-BE49-F238E27FC236}">
-                <a16:creationId xmlns:a16="http://schemas.microsoft.com/office/drawing/2014/main" id="{744C702E-E695-454F-94EA-383E3FDD3875}"/>
+                <a16:creationId xmlns:a16="http://schemas.microsoft.com/office/drawing/2014/main" id="{95364B97-224E-4DD6-8E27-7DB4BBA3CE5A}"/>
+              </a:ext>
+            </a:extLst>
+          </p:cNvPr>
+          <p:cNvSpPr>
+            <a:spLocks xmlns:a="http://schemas.openxmlformats.org/drawingml/2006/main" noGrp="1"/>
+          </p:cNvSpPr>
+          <p:nvPr/>
+        </p:nvSpPr>
+        <p:spPr>
+          <a:xfrm xmlns:a="http://schemas.openxmlformats.org/drawingml/2006/main">
+            <a:off x="400050" y="6057900"/>
+            <a:ext cx="9906000" cy="285750"/>
+          </a:xfrm>
+          <a:prstGeom xmlns:a="http://schemas.openxmlformats.org/drawingml/2006/main" prst="rect">
+            <a:avLst/>
+          </a:prstGeom>
+          <a:noFill xmlns:a="http://schemas.openxmlformats.org/drawingml/2006/main"/>
+          <a:ln xmlns:a="http://schemas.openxmlformats.org/drawingml/2006/main" w="0">
+            <a:noFill/>
+            <a:prstDash val="solid"/>
+          </a:ln>
+        </p:spPr>
+        <p:txBody>
+          <a:bodyPr xmlns:a="http://schemas.openxmlformats.org/drawingml/2006/main"/>
+          <a:lstStyle xmlns:a="http://schemas.openxmlformats.org/drawingml/2006/main"/>
+          <a:p xmlns:a="http://schemas.openxmlformats.org/drawingml/2006/main">
+            <a:pPr algn="l">
+              <a:defRPr sz="1500" b="1">
+                <a:solidFill>
+                  <a:srgbClr val="5F6975"/>
+                </a:solidFill>
+              </a:defRPr>
+            </a:pPr>
+            <a:r>
+              <a:rPr sz="1500" b="1">
+                <a:solidFill>
+                  <a:srgbClr val="5F6975"/>
+                </a:solidFill>
+              </a:rPr>
+              <a:t>The cockpit supports reviewers rather than replacing them.</a:t>
+            </a:r>
+          </a:p>
+        </p:txBody>
+      </p:sp>
+      <p:sp>
+        <p:nvSpPr>
+          <p:cNvPr id="22" name="">
+            <a:extLst xmlns:a="http://schemas.openxmlformats.org/drawingml/2006/main">
+              <a:ext uri="{FF2B5EF4-FFF2-40B4-BE49-F238E27FC236}">
+                <a16:creationId xmlns:a16="http://schemas.microsoft.com/office/drawing/2014/main" id="{EE5A211E-03A3-468E-B830-65D485605771}"/>
               </a:ext>
             </a:extLst>
           </p:cNvPr>
@@ -10961,10 +11061,10 @@
       </p:sp>
       <p:sp>
         <p:nvSpPr>
-          <p:cNvPr id="22" name="">
-            <a:extLst xmlns:a="http://schemas.openxmlformats.org/drawingml/2006/main">
-              <a:ext uri="{FF2B5EF4-FFF2-40B4-BE49-F238E27FC236}">
-                <a16:creationId xmlns:a16="http://schemas.microsoft.com/office/drawing/2014/main" id="{E4E2994C-4499-498A-9D80-4F1FC8C8B1C8}"/>
+          <p:cNvPr id="23" name="">
+            <a:extLst xmlns:a="http://schemas.openxmlformats.org/drawingml/2006/main">
+              <a:ext uri="{FF2B5EF4-FFF2-40B4-BE49-F238E27FC236}">
+                <a16:creationId xmlns:a16="http://schemas.microsoft.com/office/drawing/2014/main" id="{1DBF5998-A6E9-4071-A3DB-A10229D16F0D}"/>
               </a:ext>
             </a:extLst>
           </p:cNvPr>
@@ -11012,7 +11112,7 @@
     </p:spTree>
     <p:extLst>
       <p:ext uri="{BB962C8B-B14F-4D97-AF65-F5344CB8AC3E}">
-        <p14:creationId xmlns:p14="http://schemas.microsoft.com/office/powerpoint/2010/main" val="916947010"/>
+        <p14:creationId xmlns:p14="http://schemas.microsoft.com/office/powerpoint/2010/main" val="303728949"/>
       </p:ext>
     </p:extLst>
   </p:cSld>
@@ -11020,9 +11120,9 @@
 </file>
 
 <file path=ppt/theme/theme1.xml><?xml version="1.0" encoding="utf-8"?>
-<a:theme xmlns:a="http://schemas.openxmlformats.org/drawingml/2006/main" name="ChatGPT">
+<a:theme xmlns:a="http://schemas.openxmlformats.org/drawingml/2006/main" name="Cotiviti">
   <a:themeElements>
-    <a:clrScheme name="ChatGPT">
+    <a:clrScheme name="Cotiviti">
       <a:dk1>
         <a:srgbClr val="000000"/>
       </a:dk1>
@@ -11072,7 +11172,7 @@
         <a:cs typeface="Calibri"/>
       </a:minorFont>
     </a:fontScheme>
-    <a:fmtScheme name="ChatGPT">
+    <a:fmtScheme name="Cotiviti">
       <a:fillStyleLst>
         <a:solidFill>
           <a:schemeClr val="phClr"/>

</xml_diff>

<commit_message>
Apply expert polish and refresh demo screenshot
</commit_message>
<xml_diff>
--- a/Cotiviti_Prompt2_Presentation_Mohammad_Saleh_Nikoopayan_Tak.pptx
+++ b/Cotiviti_Prompt2_Presentation_Mohammad_Saleh_Nikoopayan_Tak.pptx
@@ -2,21 +2,21 @@
 <file path=ppt/presentation.xml><?xml version="1.0" encoding="utf-8"?>
 <p:presentation xmlns:p="http://schemas.openxmlformats.org/presentationml/2006/main">
   <p:sldMasterIdLst>
-    <p:sldMasterId xmlns:r="http://schemas.openxmlformats.org/officeDocument/2006/relationships" id="2147483648" r:id="Re189d90aa3924070"/>
+    <p:sldMasterId xmlns:r="http://schemas.openxmlformats.org/officeDocument/2006/relationships" id="2147483648" r:id="Rfb81e45e7d594625"/>
   </p:sldMasterIdLst>
   <p:notesMasterIdLst>
-    <p:notesMasterId xmlns:r="http://schemas.openxmlformats.org/officeDocument/2006/relationships" r:id="R85f6fa013b834528"/>
+    <p:notesMasterId xmlns:r="http://schemas.openxmlformats.org/officeDocument/2006/relationships" r:id="R20916020c4704d1f"/>
   </p:notesMasterIdLst>
   <p:sldIdLst>
-    <p:sldId xmlns:r="http://schemas.openxmlformats.org/officeDocument/2006/relationships" id="256" r:id="R7d16006511a84866"/>
-    <p:sldId xmlns:r="http://schemas.openxmlformats.org/officeDocument/2006/relationships" id="257" r:id="R6da1ba873724470d"/>
-    <p:sldId xmlns:r="http://schemas.openxmlformats.org/officeDocument/2006/relationships" id="258" r:id="Rc98ca5c2d3504f42"/>
-    <p:sldId xmlns:r="http://schemas.openxmlformats.org/officeDocument/2006/relationships" id="259" r:id="R786a0190230c42df"/>
-    <p:sldId xmlns:r="http://schemas.openxmlformats.org/officeDocument/2006/relationships" id="260" r:id="R1fccb6c23b354eb1"/>
-    <p:sldId xmlns:r="http://schemas.openxmlformats.org/officeDocument/2006/relationships" id="261" r:id="R7b9d93dd82224840"/>
-    <p:sldId xmlns:r="http://schemas.openxmlformats.org/officeDocument/2006/relationships" id="262" r:id="R164637e931a74842"/>
-    <p:sldId xmlns:r="http://schemas.openxmlformats.org/officeDocument/2006/relationships" id="263" r:id="R78c25a8b6e1f4cf7"/>
-    <p:sldId xmlns:r="http://schemas.openxmlformats.org/officeDocument/2006/relationships" id="264" r:id="R2512f892e8e14789"/>
+    <p:sldId xmlns:r="http://schemas.openxmlformats.org/officeDocument/2006/relationships" id="256" r:id="R3186f22e8d2a4220"/>
+    <p:sldId xmlns:r="http://schemas.openxmlformats.org/officeDocument/2006/relationships" id="257" r:id="R122deaf0a41341fb"/>
+    <p:sldId xmlns:r="http://schemas.openxmlformats.org/officeDocument/2006/relationships" id="258" r:id="Rd24182beda034a75"/>
+    <p:sldId xmlns:r="http://schemas.openxmlformats.org/officeDocument/2006/relationships" id="259" r:id="R8c0ec6abf72d4511"/>
+    <p:sldId xmlns:r="http://schemas.openxmlformats.org/officeDocument/2006/relationships" id="260" r:id="R98fd993498054a17"/>
+    <p:sldId xmlns:r="http://schemas.openxmlformats.org/officeDocument/2006/relationships" id="261" r:id="Rf7f032fa33c641a6"/>
+    <p:sldId xmlns:r="http://schemas.openxmlformats.org/officeDocument/2006/relationships" id="262" r:id="R09d054bbe1164c7a"/>
+    <p:sldId xmlns:r="http://schemas.openxmlformats.org/officeDocument/2006/relationships" id="263" r:id="Reaf7b99f60d24c03"/>
+    <p:sldId xmlns:r="http://schemas.openxmlformats.org/officeDocument/2006/relationships" id="264" r:id="R3763e2b5a95744a8"/>
   </p:sldIdLst>
   <p:sldSz cx="12192000" cy="6858000"/>
   <p:notesSz cx="6858000" cy="9144000"/>
@@ -1218,7 +1218,7 @@
   </p:cSld>
   <p:clrMap bg1="lt1" tx1="dk1" bg2="lt2" tx2="dk2" accent1="accent1" accent2="accent2" accent3="accent3" accent4="accent4" accent5="accent5" accent6="accent6" hlink="hlink" folHlink="folHlink"/>
   <p:sldLayoutIdLst>
-    <p:sldLayoutId xmlns:r="http://schemas.openxmlformats.org/officeDocument/2006/relationships" id="2147483649" r:id="Rfcb3f0d481234a6f"/>
+    <p:sldLayoutId xmlns:r="http://schemas.openxmlformats.org/officeDocument/2006/relationships" id="2147483649" r:id="R1b9f90a6dc984042"/>
   </p:sldLayoutIdLst>
   <p:txStyles>
     <p:titleStyle>
@@ -1955,7 +1955,7 @@
           <p:cNvPr id="1" name="">
             <a:extLst xmlns:a="http://schemas.openxmlformats.org/drawingml/2006/main">
               <a:ext uri="{FF2B5EF4-FFF2-40B4-BE49-F238E27FC236}">
-                <a16:creationId xmlns:a16="http://schemas.microsoft.com/office/drawing/2014/main" id="{333E4FB0-40DA-43F6-A2A1-E6CE8957D947}"/>
+                <a16:creationId xmlns:a16="http://schemas.microsoft.com/office/drawing/2014/main" id="{162BADE9-B071-4A25-A2DC-08EF2CE3AF3C}"/>
               </a:ext>
             </a:extLst>
           </p:cNvPr>
@@ -1986,7 +1986,7 @@
           <p:cNvPr id="2" name="">
             <a:extLst xmlns:a="http://schemas.openxmlformats.org/drawingml/2006/main">
               <a:ext uri="{FF2B5EF4-FFF2-40B4-BE49-F238E27FC236}">
-                <a16:creationId xmlns:a16="http://schemas.microsoft.com/office/drawing/2014/main" id="{D4B31324-7CE2-4A49-B54F-885206789811}"/>
+                <a16:creationId xmlns:a16="http://schemas.microsoft.com/office/drawing/2014/main" id="{086929F1-D22E-48FF-9BF5-634DEEE08ACE}"/>
               </a:ext>
             </a:extLst>
           </p:cNvPr>
@@ -2036,7 +2036,7 @@
           <p:cNvPr id="3" name="">
             <a:extLst xmlns:a="http://schemas.openxmlformats.org/drawingml/2006/main">
               <a:ext uri="{FF2B5EF4-FFF2-40B4-BE49-F238E27FC236}">
-                <a16:creationId xmlns:a16="http://schemas.microsoft.com/office/drawing/2014/main" id="{242579DC-6F7B-489D-8154-87BFEF6509CF}"/>
+                <a16:creationId xmlns:a16="http://schemas.microsoft.com/office/drawing/2014/main" id="{1252087B-3C0E-4B8D-94CB-AE2170A8B571}"/>
               </a:ext>
             </a:extLst>
           </p:cNvPr>
@@ -2086,7 +2086,7 @@
           <p:cNvPr id="4" name="">
             <a:extLst xmlns:a="http://schemas.openxmlformats.org/drawingml/2006/main">
               <a:ext uri="{FF2B5EF4-FFF2-40B4-BE49-F238E27FC236}">
-                <a16:creationId xmlns:a16="http://schemas.microsoft.com/office/drawing/2014/main" id="{C3B80134-27D8-49AF-9F3F-3E9CBC320C51}"/>
+                <a16:creationId xmlns:a16="http://schemas.microsoft.com/office/drawing/2014/main" id="{A366FA32-9559-4619-BAE7-341C978F83F3}"/>
               </a:ext>
             </a:extLst>
           </p:cNvPr>
@@ -2136,7 +2136,7 @@
           <p:cNvPr id="5" name="">
             <a:extLst xmlns:a="http://schemas.openxmlformats.org/drawingml/2006/main">
               <a:ext uri="{FF2B5EF4-FFF2-40B4-BE49-F238E27FC236}">
-                <a16:creationId xmlns:a16="http://schemas.microsoft.com/office/drawing/2014/main" id="{57A6D522-921D-4F49-B289-2FD1E39B7FFD}"/>
+                <a16:creationId xmlns:a16="http://schemas.microsoft.com/office/drawing/2014/main" id="{B8FE9E90-BA16-43D0-B007-631BD13A03E2}"/>
               </a:ext>
             </a:extLst>
           </p:cNvPr>
@@ -2186,7 +2186,7 @@
           <p:cNvPr id="6" name="">
             <a:extLst xmlns:a="http://schemas.openxmlformats.org/drawingml/2006/main">
               <a:ext uri="{FF2B5EF4-FFF2-40B4-BE49-F238E27FC236}">
-                <a16:creationId xmlns:a16="http://schemas.microsoft.com/office/drawing/2014/main" id="{758B0218-F352-498E-B625-1C936761EAD7}"/>
+                <a16:creationId xmlns:a16="http://schemas.microsoft.com/office/drawing/2014/main" id="{F1B4EB17-0A26-4025-BE60-282F33A91723}"/>
               </a:ext>
             </a:extLst>
           </p:cNvPr>
@@ -2236,7 +2236,7 @@
           <p:cNvPr id="7" name="">
             <a:extLst xmlns:a="http://schemas.openxmlformats.org/drawingml/2006/main">
               <a:ext uri="{FF2B5EF4-FFF2-40B4-BE49-F238E27FC236}">
-                <a16:creationId xmlns:a16="http://schemas.microsoft.com/office/drawing/2014/main" id="{588B3847-0894-4E7D-BA59-AE90C5347620}"/>
+                <a16:creationId xmlns:a16="http://schemas.microsoft.com/office/drawing/2014/main" id="{65046A59-0DB0-4956-8ED6-501E0191C498}"/>
               </a:ext>
             </a:extLst>
           </p:cNvPr>
@@ -2269,7 +2269,7 @@
           <p:cNvPr id="8" name="">
             <a:extLst xmlns:a="http://schemas.openxmlformats.org/drawingml/2006/main">
               <a:ext uri="{FF2B5EF4-FFF2-40B4-BE49-F238E27FC236}">
-                <a16:creationId xmlns:a16="http://schemas.microsoft.com/office/drawing/2014/main" id="{42D13F94-4940-4100-85C7-766EA269349B}"/>
+                <a16:creationId xmlns:a16="http://schemas.microsoft.com/office/drawing/2014/main" id="{A624CAE7-8ACC-44C2-B40D-CE3690E32D5C}"/>
               </a:ext>
             </a:extLst>
           </p:cNvPr>
@@ -2300,7 +2300,7 @@
           <p:cNvPr id="9" name="">
             <a:extLst xmlns:a="http://schemas.openxmlformats.org/drawingml/2006/main">
               <a:ext uri="{FF2B5EF4-FFF2-40B4-BE49-F238E27FC236}">
-                <a16:creationId xmlns:a16="http://schemas.microsoft.com/office/drawing/2014/main" id="{66197951-C453-46BE-BF02-F61669AD0958}"/>
+                <a16:creationId xmlns:a16="http://schemas.microsoft.com/office/drawing/2014/main" id="{E239E871-2724-4CA2-AC24-BA29BCE1ED9D}"/>
               </a:ext>
             </a:extLst>
           </p:cNvPr>
@@ -2331,7 +2331,7 @@
           <p:cNvPr id="10" name="">
             <a:extLst xmlns:a="http://schemas.openxmlformats.org/drawingml/2006/main">
               <a:ext uri="{FF2B5EF4-FFF2-40B4-BE49-F238E27FC236}">
-                <a16:creationId xmlns:a16="http://schemas.microsoft.com/office/drawing/2014/main" id="{75AC064E-56B6-4829-B9F5-91499CF040E0}"/>
+                <a16:creationId xmlns:a16="http://schemas.microsoft.com/office/drawing/2014/main" id="{9F62CDC8-5518-41AA-988A-06A3E99B02AD}"/>
               </a:ext>
             </a:extLst>
           </p:cNvPr>
@@ -2362,7 +2362,7 @@
           <p:cNvPr id="11" name="">
             <a:extLst xmlns:a="http://schemas.openxmlformats.org/drawingml/2006/main">
               <a:ext uri="{FF2B5EF4-FFF2-40B4-BE49-F238E27FC236}">
-                <a16:creationId xmlns:a16="http://schemas.microsoft.com/office/drawing/2014/main" id="{06C924C0-AEB0-4C1D-94FA-D5E1C696511E}"/>
+                <a16:creationId xmlns:a16="http://schemas.microsoft.com/office/drawing/2014/main" id="{8F84169A-57BC-4D3B-8573-0423B330CD62}"/>
               </a:ext>
             </a:extLst>
           </p:cNvPr>
@@ -2393,7 +2393,7 @@
           <p:cNvPr id="12" name="">
             <a:extLst xmlns:a="http://schemas.openxmlformats.org/drawingml/2006/main">
               <a:ext uri="{FF2B5EF4-FFF2-40B4-BE49-F238E27FC236}">
-                <a16:creationId xmlns:a16="http://schemas.microsoft.com/office/drawing/2014/main" id="{E0C53AB9-8A1D-422D-98BB-646A4821CF1B}"/>
+                <a16:creationId xmlns:a16="http://schemas.microsoft.com/office/drawing/2014/main" id="{00F0DC59-51E2-4520-9594-D4F1E29720BA}"/>
               </a:ext>
             </a:extLst>
           </p:cNvPr>
@@ -2426,7 +2426,7 @@
           <p:cNvPr id="13" name="">
             <a:extLst xmlns:a="http://schemas.openxmlformats.org/drawingml/2006/main">
               <a:ext uri="{FF2B5EF4-FFF2-40B4-BE49-F238E27FC236}">
-                <a16:creationId xmlns:a16="http://schemas.microsoft.com/office/drawing/2014/main" id="{1E7894F3-7F76-4ACC-BAFE-D07D84C82ECE}"/>
+                <a16:creationId xmlns:a16="http://schemas.microsoft.com/office/drawing/2014/main" id="{07017034-D87F-4475-8749-4BCBB1BA6DC0}"/>
               </a:ext>
             </a:extLst>
           </p:cNvPr>
@@ -2476,7 +2476,7 @@
           <p:cNvPr id="14" name="">
             <a:extLst xmlns:a="http://schemas.openxmlformats.org/drawingml/2006/main">
               <a:ext uri="{FF2B5EF4-FFF2-40B4-BE49-F238E27FC236}">
-                <a16:creationId xmlns:a16="http://schemas.microsoft.com/office/drawing/2014/main" id="{37845CD2-93F7-4BFC-BCF6-211B69B9FB88}"/>
+                <a16:creationId xmlns:a16="http://schemas.microsoft.com/office/drawing/2014/main" id="{BC25CA6B-0231-470B-88AD-5A6C65A248B4}"/>
               </a:ext>
             </a:extLst>
           </p:cNvPr>
@@ -2509,7 +2509,7 @@
           <p:cNvPr id="15" name="">
             <a:extLst xmlns:a="http://schemas.openxmlformats.org/drawingml/2006/main">
               <a:ext uri="{FF2B5EF4-FFF2-40B4-BE49-F238E27FC236}">
-                <a16:creationId xmlns:a16="http://schemas.microsoft.com/office/drawing/2014/main" id="{F2720D1D-A8E2-4250-8D9C-9A314584EDA5}"/>
+                <a16:creationId xmlns:a16="http://schemas.microsoft.com/office/drawing/2014/main" id="{867F5CE2-B052-4A30-898F-FB4054A151D0}"/>
               </a:ext>
             </a:extLst>
           </p:cNvPr>
@@ -2559,7 +2559,7 @@
           <p:cNvPr id="16" name="">
             <a:extLst xmlns:a="http://schemas.openxmlformats.org/drawingml/2006/main">
               <a:ext uri="{FF2B5EF4-FFF2-40B4-BE49-F238E27FC236}">
-                <a16:creationId xmlns:a16="http://schemas.microsoft.com/office/drawing/2014/main" id="{EE035EF8-D8B5-4FBB-9780-42FCBCC628FD}"/>
+                <a16:creationId xmlns:a16="http://schemas.microsoft.com/office/drawing/2014/main" id="{C8241162-1025-44AD-9BD3-156AE0195F43}"/>
               </a:ext>
             </a:extLst>
           </p:cNvPr>
@@ -2592,7 +2592,7 @@
           <p:cNvPr id="17" name="">
             <a:extLst xmlns:a="http://schemas.openxmlformats.org/drawingml/2006/main">
               <a:ext uri="{FF2B5EF4-FFF2-40B4-BE49-F238E27FC236}">
-                <a16:creationId xmlns:a16="http://schemas.microsoft.com/office/drawing/2014/main" id="{D7B8D030-B42F-4AD6-A507-3887616F45F9}"/>
+                <a16:creationId xmlns:a16="http://schemas.microsoft.com/office/drawing/2014/main" id="{39380A6E-8A00-45D6-B551-F32F238CABBF}"/>
               </a:ext>
             </a:extLst>
           </p:cNvPr>
@@ -2642,7 +2642,7 @@
           <p:cNvPr id="18" name="">
             <a:extLst xmlns:a="http://schemas.openxmlformats.org/drawingml/2006/main">
               <a:ext uri="{FF2B5EF4-FFF2-40B4-BE49-F238E27FC236}">
-                <a16:creationId xmlns:a16="http://schemas.microsoft.com/office/drawing/2014/main" id="{4603F448-AE60-4C8B-A4CD-9051F3F8E4AE}"/>
+                <a16:creationId xmlns:a16="http://schemas.microsoft.com/office/drawing/2014/main" id="{CB583DC2-10D2-4AA8-9676-D9CD04EBDCDC}"/>
               </a:ext>
             </a:extLst>
           </p:cNvPr>
@@ -2675,7 +2675,7 @@
           <p:cNvPr id="19" name="">
             <a:extLst xmlns:a="http://schemas.openxmlformats.org/drawingml/2006/main">
               <a:ext uri="{FF2B5EF4-FFF2-40B4-BE49-F238E27FC236}">
-                <a16:creationId xmlns:a16="http://schemas.microsoft.com/office/drawing/2014/main" id="{EA5B4327-0255-45B4-BB51-23066F60DF18}"/>
+                <a16:creationId xmlns:a16="http://schemas.microsoft.com/office/drawing/2014/main" id="{63646DF9-BCDA-4F4B-B674-DDF1841840A8}"/>
               </a:ext>
             </a:extLst>
           </p:cNvPr>
@@ -2725,7 +2725,7 @@
           <p:cNvPr id="20" name="">
             <a:extLst xmlns:a="http://schemas.openxmlformats.org/drawingml/2006/main">
               <a:ext uri="{FF2B5EF4-FFF2-40B4-BE49-F238E27FC236}">
-                <a16:creationId xmlns:a16="http://schemas.microsoft.com/office/drawing/2014/main" id="{8BB20BC0-97C8-4360-A470-56EBAB03E07D}"/>
+                <a16:creationId xmlns:a16="http://schemas.microsoft.com/office/drawing/2014/main" id="{A711BA2E-B574-4C4B-AA98-A3A1B1814260}"/>
               </a:ext>
             </a:extLst>
           </p:cNvPr>
@@ -2758,7 +2758,7 @@
           <p:cNvPr id="21" name="">
             <a:extLst xmlns:a="http://schemas.openxmlformats.org/drawingml/2006/main">
               <a:ext uri="{FF2B5EF4-FFF2-40B4-BE49-F238E27FC236}">
-                <a16:creationId xmlns:a16="http://schemas.microsoft.com/office/drawing/2014/main" id="{A80C8BC9-1208-4468-8F0B-BEF22BE52AD1}"/>
+                <a16:creationId xmlns:a16="http://schemas.microsoft.com/office/drawing/2014/main" id="{423F1DD5-FF85-4872-84D2-5FD557094E47}"/>
               </a:ext>
             </a:extLst>
           </p:cNvPr>
@@ -2808,7 +2808,7 @@
           <p:cNvPr id="22" name="">
             <a:extLst xmlns:a="http://schemas.openxmlformats.org/drawingml/2006/main">
               <a:ext uri="{FF2B5EF4-FFF2-40B4-BE49-F238E27FC236}">
-                <a16:creationId xmlns:a16="http://schemas.microsoft.com/office/drawing/2014/main" id="{A2F14302-6F51-4EC9-9DF7-35EB968B2409}"/>
+                <a16:creationId xmlns:a16="http://schemas.microsoft.com/office/drawing/2014/main" id="{AAB7BC46-D3B5-4EEC-A5A4-024930A988FE}"/>
               </a:ext>
             </a:extLst>
           </p:cNvPr>
@@ -2846,7 +2846,7 @@
           <p:cNvPr id="23" name="">
             <a:extLst xmlns:a="http://schemas.openxmlformats.org/drawingml/2006/main">
               <a:ext uri="{FF2B5EF4-FFF2-40B4-BE49-F238E27FC236}">
-                <a16:creationId xmlns:a16="http://schemas.microsoft.com/office/drawing/2014/main" id="{9C3E62E1-1309-4E54-A35F-C41600C9503C}"/>
+                <a16:creationId xmlns:a16="http://schemas.microsoft.com/office/drawing/2014/main" id="{1D1E1CFB-34E6-4D2E-B668-5D47B9A532DF}"/>
               </a:ext>
             </a:extLst>
           </p:cNvPr>
@@ -2894,7 +2894,7 @@
     </p:spTree>
     <p:extLst>
       <p:ext uri="{BB962C8B-B14F-4D97-AF65-F5344CB8AC3E}">
-        <p14:creationId xmlns:p14="http://schemas.microsoft.com/office/powerpoint/2010/main" val="500654687"/>
+        <p14:creationId xmlns:p14="http://schemas.microsoft.com/office/powerpoint/2010/main" val="1846126661"/>
       </p:ext>
     </p:extLst>
   </p:cSld>
@@ -2925,7 +2925,7 @@
           <p:cNvPr id="1" name="">
             <a:extLst xmlns:a="http://schemas.openxmlformats.org/drawingml/2006/main">
               <a:ext uri="{FF2B5EF4-FFF2-40B4-BE49-F238E27FC236}">
-                <a16:creationId xmlns:a16="http://schemas.microsoft.com/office/drawing/2014/main" id="{A2E7D38D-7D04-4085-AE23-C795193C26FC}"/>
+                <a16:creationId xmlns:a16="http://schemas.microsoft.com/office/drawing/2014/main" id="{5B50B3F7-C703-4A5A-BC90-B431D93DE56B}"/>
               </a:ext>
             </a:extLst>
           </p:cNvPr>
@@ -2975,7 +2975,7 @@
           <p:cNvPr id="2" name="">
             <a:extLst xmlns:a="http://schemas.openxmlformats.org/drawingml/2006/main">
               <a:ext uri="{FF2B5EF4-FFF2-40B4-BE49-F238E27FC236}">
-                <a16:creationId xmlns:a16="http://schemas.microsoft.com/office/drawing/2014/main" id="{7199FDF0-A8BE-48FD-9130-81F14437FD7F}"/>
+                <a16:creationId xmlns:a16="http://schemas.microsoft.com/office/drawing/2014/main" id="{A24D3D7E-638F-49B8-B205-98FF960D0F5D}"/>
               </a:ext>
             </a:extLst>
           </p:cNvPr>
@@ -3025,7 +3025,7 @@
           <p:cNvPr id="3" name="">
             <a:extLst xmlns:a="http://schemas.openxmlformats.org/drawingml/2006/main">
               <a:ext uri="{FF2B5EF4-FFF2-40B4-BE49-F238E27FC236}">
-                <a16:creationId xmlns:a16="http://schemas.microsoft.com/office/drawing/2014/main" id="{B6797796-C59C-447B-9AD3-A820650EB383}"/>
+                <a16:creationId xmlns:a16="http://schemas.microsoft.com/office/drawing/2014/main" id="{966306E8-2307-4448-B6DD-BFDE6D6E3B51}"/>
               </a:ext>
             </a:extLst>
           </p:cNvPr>
@@ -3075,7 +3075,7 @@
           <p:cNvPr id="4" name="">
             <a:extLst xmlns:a="http://schemas.openxmlformats.org/drawingml/2006/main">
               <a:ext uri="{FF2B5EF4-FFF2-40B4-BE49-F238E27FC236}">
-                <a16:creationId xmlns:a16="http://schemas.microsoft.com/office/drawing/2014/main" id="{75C8B4DA-7E15-4F14-AB86-C20C45B75927}"/>
+                <a16:creationId xmlns:a16="http://schemas.microsoft.com/office/drawing/2014/main" id="{924E1650-2B09-4845-BEDC-70EFBA2DCF8A}"/>
               </a:ext>
             </a:extLst>
           </p:cNvPr>
@@ -3125,7 +3125,7 @@
           <p:cNvPr id="5" name="">
             <a:extLst xmlns:a="http://schemas.openxmlformats.org/drawingml/2006/main">
               <a:ext uri="{FF2B5EF4-FFF2-40B4-BE49-F238E27FC236}">
-                <a16:creationId xmlns:a16="http://schemas.microsoft.com/office/drawing/2014/main" id="{6129794A-55E8-470C-A09B-A136897CB860}"/>
+                <a16:creationId xmlns:a16="http://schemas.microsoft.com/office/drawing/2014/main" id="{3926013B-42DA-4CBA-A14E-595C70F9B929}"/>
               </a:ext>
             </a:extLst>
           </p:cNvPr>
@@ -3175,7 +3175,7 @@
           <p:cNvPr id="6" name="">
             <a:extLst xmlns:a="http://schemas.openxmlformats.org/drawingml/2006/main">
               <a:ext uri="{FF2B5EF4-FFF2-40B4-BE49-F238E27FC236}">
-                <a16:creationId xmlns:a16="http://schemas.microsoft.com/office/drawing/2014/main" id="{72195D31-45F5-4191-A40D-EA3A986656F9}"/>
+                <a16:creationId xmlns:a16="http://schemas.microsoft.com/office/drawing/2014/main" id="{418BA136-D9F8-4F38-B540-78C1778E56C4}"/>
               </a:ext>
             </a:extLst>
           </p:cNvPr>
@@ -3206,7 +3206,7 @@
           <p:cNvPr id="7" name="">
             <a:extLst xmlns:a="http://schemas.openxmlformats.org/drawingml/2006/main">
               <a:ext uri="{FF2B5EF4-FFF2-40B4-BE49-F238E27FC236}">
-                <a16:creationId xmlns:a16="http://schemas.microsoft.com/office/drawing/2014/main" id="{68D65F50-AC3C-4E90-9597-3B150634D5C0}"/>
+                <a16:creationId xmlns:a16="http://schemas.microsoft.com/office/drawing/2014/main" id="{003E03F4-451D-489E-8702-6C354321DACF}"/>
               </a:ext>
             </a:extLst>
           </p:cNvPr>
@@ -3256,7 +3256,7 @@
           <p:cNvPr id="8" name="">
             <a:extLst xmlns:a="http://schemas.openxmlformats.org/drawingml/2006/main">
               <a:ext uri="{FF2B5EF4-FFF2-40B4-BE49-F238E27FC236}">
-                <a16:creationId xmlns:a16="http://schemas.microsoft.com/office/drawing/2014/main" id="{8F542300-9FAC-4D52-B890-6B2ACE1300F9}"/>
+                <a16:creationId xmlns:a16="http://schemas.microsoft.com/office/drawing/2014/main" id="{4C139A78-F794-4B34-8389-85D8B0A9360B}"/>
               </a:ext>
             </a:extLst>
           </p:cNvPr>
@@ -3287,7 +3287,7 @@
           <p:cNvPr id="9" name="">
             <a:extLst xmlns:a="http://schemas.openxmlformats.org/drawingml/2006/main">
               <a:ext uri="{FF2B5EF4-FFF2-40B4-BE49-F238E27FC236}">
-                <a16:creationId xmlns:a16="http://schemas.microsoft.com/office/drawing/2014/main" id="{70D5804F-9F56-4EE4-AA46-A0199E30E607}"/>
+                <a16:creationId xmlns:a16="http://schemas.microsoft.com/office/drawing/2014/main" id="{938F16DC-FA05-429B-9AC1-048D59C9352D}"/>
               </a:ext>
             </a:extLst>
           </p:cNvPr>
@@ -3337,7 +3337,7 @@
           <p:cNvPr id="10" name="">
             <a:extLst xmlns:a="http://schemas.openxmlformats.org/drawingml/2006/main">
               <a:ext uri="{FF2B5EF4-FFF2-40B4-BE49-F238E27FC236}">
-                <a16:creationId xmlns:a16="http://schemas.microsoft.com/office/drawing/2014/main" id="{08EAD630-A18D-453D-B5C6-51151FD9C8C7}"/>
+                <a16:creationId xmlns:a16="http://schemas.microsoft.com/office/drawing/2014/main" id="{006FD4F0-2582-48CC-9BA9-5C8D516968CE}"/>
               </a:ext>
             </a:extLst>
           </p:cNvPr>
@@ -3368,7 +3368,7 @@
           <p:cNvPr id="11" name="">
             <a:extLst xmlns:a="http://schemas.openxmlformats.org/drawingml/2006/main">
               <a:ext uri="{FF2B5EF4-FFF2-40B4-BE49-F238E27FC236}">
-                <a16:creationId xmlns:a16="http://schemas.microsoft.com/office/drawing/2014/main" id="{CEB72645-7CB6-4F41-8803-1E69368B8D88}"/>
+                <a16:creationId xmlns:a16="http://schemas.microsoft.com/office/drawing/2014/main" id="{0543967D-94AD-45E1-BA02-7DC08CA11EBE}"/>
               </a:ext>
             </a:extLst>
           </p:cNvPr>
@@ -3418,7 +3418,7 @@
           <p:cNvPr id="12" name="">
             <a:extLst xmlns:a="http://schemas.openxmlformats.org/drawingml/2006/main">
               <a:ext uri="{FF2B5EF4-FFF2-40B4-BE49-F238E27FC236}">
-                <a16:creationId xmlns:a16="http://schemas.microsoft.com/office/drawing/2014/main" id="{28AB3E07-E011-4A6C-BFA8-DC6C9730A394}"/>
+                <a16:creationId xmlns:a16="http://schemas.microsoft.com/office/drawing/2014/main" id="{53D6C274-38B6-453E-9DF7-C6CDD969D9B8}"/>
               </a:ext>
             </a:extLst>
           </p:cNvPr>
@@ -3449,7 +3449,7 @@
           <p:cNvPr id="13" name="">
             <a:extLst xmlns:a="http://schemas.openxmlformats.org/drawingml/2006/main">
               <a:ext uri="{FF2B5EF4-FFF2-40B4-BE49-F238E27FC236}">
-                <a16:creationId xmlns:a16="http://schemas.microsoft.com/office/drawing/2014/main" id="{526BCF11-EB27-4210-AD54-6A5818EC632B}"/>
+                <a16:creationId xmlns:a16="http://schemas.microsoft.com/office/drawing/2014/main" id="{B9E1AB2C-4484-416B-8799-64BB8583164A}"/>
               </a:ext>
             </a:extLst>
           </p:cNvPr>
@@ -3499,7 +3499,7 @@
           <p:cNvPr id="14" name="">
             <a:extLst xmlns:a="http://schemas.openxmlformats.org/drawingml/2006/main">
               <a:ext uri="{FF2B5EF4-FFF2-40B4-BE49-F238E27FC236}">
-                <a16:creationId xmlns:a16="http://schemas.microsoft.com/office/drawing/2014/main" id="{1496EDA2-88DB-4D35-A07A-7E138A85787A}"/>
+                <a16:creationId xmlns:a16="http://schemas.microsoft.com/office/drawing/2014/main" id="{094FC32F-E5B6-4736-A016-F2B7771F13AB}"/>
               </a:ext>
             </a:extLst>
           </p:cNvPr>
@@ -3532,7 +3532,7 @@
           <p:cNvPr id="15" name="">
             <a:extLst xmlns:a="http://schemas.openxmlformats.org/drawingml/2006/main">
               <a:ext uri="{FF2B5EF4-FFF2-40B4-BE49-F238E27FC236}">
-                <a16:creationId xmlns:a16="http://schemas.microsoft.com/office/drawing/2014/main" id="{9513125A-9688-45E3-A10A-07A93F88084E}"/>
+                <a16:creationId xmlns:a16="http://schemas.microsoft.com/office/drawing/2014/main" id="{69C04476-2CE9-43C1-87D4-07EF97A2A8C0}"/>
               </a:ext>
             </a:extLst>
           </p:cNvPr>
@@ -3563,7 +3563,7 @@
           <p:cNvPr id="16" name="">
             <a:extLst xmlns:a="http://schemas.openxmlformats.org/drawingml/2006/main">
               <a:ext uri="{FF2B5EF4-FFF2-40B4-BE49-F238E27FC236}">
-                <a16:creationId xmlns:a16="http://schemas.microsoft.com/office/drawing/2014/main" id="{22609A9F-23AB-4F2F-AA8F-59AB78C57B67}"/>
+                <a16:creationId xmlns:a16="http://schemas.microsoft.com/office/drawing/2014/main" id="{1E2082AD-B536-4052-B07B-9031960C7870}"/>
               </a:ext>
             </a:extLst>
           </p:cNvPr>
@@ -3594,7 +3594,7 @@
           <p:cNvPr id="17" name="">
             <a:extLst xmlns:a="http://schemas.openxmlformats.org/drawingml/2006/main">
               <a:ext uri="{FF2B5EF4-FFF2-40B4-BE49-F238E27FC236}">
-                <a16:creationId xmlns:a16="http://schemas.microsoft.com/office/drawing/2014/main" id="{BF63DF53-D47B-48C0-8A7C-0FEE9D748EBB}"/>
+                <a16:creationId xmlns:a16="http://schemas.microsoft.com/office/drawing/2014/main" id="{5482B1C5-82F6-4C52-829B-B42E53C58BC5}"/>
               </a:ext>
             </a:extLst>
           </p:cNvPr>
@@ -3625,7 +3625,7 @@
           <p:cNvPr id="18" name="">
             <a:extLst xmlns:a="http://schemas.openxmlformats.org/drawingml/2006/main">
               <a:ext uri="{FF2B5EF4-FFF2-40B4-BE49-F238E27FC236}">
-                <a16:creationId xmlns:a16="http://schemas.microsoft.com/office/drawing/2014/main" id="{AF776E2A-9766-4433-9A42-2D3989C4FFF4}"/>
+                <a16:creationId xmlns:a16="http://schemas.microsoft.com/office/drawing/2014/main" id="{79B71B18-371B-4A12-942F-E32339F8349D}"/>
               </a:ext>
             </a:extLst>
           </p:cNvPr>
@@ -3656,7 +3656,7 @@
           <p:cNvPr id="19" name="">
             <a:extLst xmlns:a="http://schemas.openxmlformats.org/drawingml/2006/main">
               <a:ext uri="{FF2B5EF4-FFF2-40B4-BE49-F238E27FC236}">
-                <a16:creationId xmlns:a16="http://schemas.microsoft.com/office/drawing/2014/main" id="{C30223B0-CD73-4F1C-A1A0-CFA1683F6B0C}"/>
+                <a16:creationId xmlns:a16="http://schemas.microsoft.com/office/drawing/2014/main" id="{8667B606-A04E-4EAC-9154-F72A614C40E1}"/>
               </a:ext>
             </a:extLst>
           </p:cNvPr>
@@ -3687,7 +3687,7 @@
           <p:cNvPr id="20" name="">
             <a:extLst xmlns:a="http://schemas.openxmlformats.org/drawingml/2006/main">
               <a:ext uri="{FF2B5EF4-FFF2-40B4-BE49-F238E27FC236}">
-                <a16:creationId xmlns:a16="http://schemas.microsoft.com/office/drawing/2014/main" id="{C976F17C-92A8-447A-AF5B-AAEAC6E5DD0B}"/>
+                <a16:creationId xmlns:a16="http://schemas.microsoft.com/office/drawing/2014/main" id="{4FEB1912-F42E-4178-BF89-55EF1FB50F9D}"/>
               </a:ext>
             </a:extLst>
           </p:cNvPr>
@@ -3720,7 +3720,7 @@
           <p:cNvPr id="21" name="">
             <a:extLst xmlns:a="http://schemas.openxmlformats.org/drawingml/2006/main">
               <a:ext uri="{FF2B5EF4-FFF2-40B4-BE49-F238E27FC236}">
-                <a16:creationId xmlns:a16="http://schemas.microsoft.com/office/drawing/2014/main" id="{546A718E-7AA3-4AED-ABA5-D9E12421469C}"/>
+                <a16:creationId xmlns:a16="http://schemas.microsoft.com/office/drawing/2014/main" id="{8B8BC8A5-B86F-4CD1-999B-7B4B686EB330}"/>
               </a:ext>
             </a:extLst>
           </p:cNvPr>
@@ -3770,7 +3770,7 @@
           <p:cNvPr id="22" name="">
             <a:extLst xmlns:a="http://schemas.openxmlformats.org/drawingml/2006/main">
               <a:ext uri="{FF2B5EF4-FFF2-40B4-BE49-F238E27FC236}">
-                <a16:creationId xmlns:a16="http://schemas.microsoft.com/office/drawing/2014/main" id="{E8BCDD4A-4055-44BE-A09B-7A2A563313BE}"/>
+                <a16:creationId xmlns:a16="http://schemas.microsoft.com/office/drawing/2014/main" id="{454EB342-B4E3-42E8-A754-83A85238830F}"/>
               </a:ext>
             </a:extLst>
           </p:cNvPr>
@@ -3803,7 +3803,7 @@
           <p:cNvPr id="23" name="">
             <a:extLst xmlns:a="http://schemas.openxmlformats.org/drawingml/2006/main">
               <a:ext uri="{FF2B5EF4-FFF2-40B4-BE49-F238E27FC236}">
-                <a16:creationId xmlns:a16="http://schemas.microsoft.com/office/drawing/2014/main" id="{8F1D4DEA-CEC9-4A32-ADF6-63F57D2D2968}"/>
+                <a16:creationId xmlns:a16="http://schemas.microsoft.com/office/drawing/2014/main" id="{16B7E9B8-25A3-42E4-AB8E-661CE64CB06E}"/>
               </a:ext>
             </a:extLst>
           </p:cNvPr>
@@ -3853,7 +3853,7 @@
           <p:cNvPr id="24" name="">
             <a:extLst xmlns:a="http://schemas.openxmlformats.org/drawingml/2006/main">
               <a:ext uri="{FF2B5EF4-FFF2-40B4-BE49-F238E27FC236}">
-                <a16:creationId xmlns:a16="http://schemas.microsoft.com/office/drawing/2014/main" id="{B22CEE54-A8EF-428D-A9FD-C72486213ED4}"/>
+                <a16:creationId xmlns:a16="http://schemas.microsoft.com/office/drawing/2014/main" id="{4C5D2FE5-3573-427C-B437-41D0665C2B93}"/>
               </a:ext>
             </a:extLst>
           </p:cNvPr>
@@ -3886,7 +3886,7 @@
           <p:cNvPr id="25" name="">
             <a:extLst xmlns:a="http://schemas.openxmlformats.org/drawingml/2006/main">
               <a:ext uri="{FF2B5EF4-FFF2-40B4-BE49-F238E27FC236}">
-                <a16:creationId xmlns:a16="http://schemas.microsoft.com/office/drawing/2014/main" id="{38A48051-1CC6-45BA-88A6-51DA9AF784C3}"/>
+                <a16:creationId xmlns:a16="http://schemas.microsoft.com/office/drawing/2014/main" id="{366A2C2B-B16A-492A-BC3D-A5831176FA85}"/>
               </a:ext>
             </a:extLst>
           </p:cNvPr>
@@ -3936,7 +3936,7 @@
           <p:cNvPr id="26" name="">
             <a:extLst xmlns:a="http://schemas.openxmlformats.org/drawingml/2006/main">
               <a:ext uri="{FF2B5EF4-FFF2-40B4-BE49-F238E27FC236}">
-                <a16:creationId xmlns:a16="http://schemas.microsoft.com/office/drawing/2014/main" id="{63AFD828-5AD5-4423-9BF4-42339A653887}"/>
+                <a16:creationId xmlns:a16="http://schemas.microsoft.com/office/drawing/2014/main" id="{2FADEF8D-AD59-4E84-B710-8D391624CBE2}"/>
               </a:ext>
             </a:extLst>
           </p:cNvPr>
@@ -3969,7 +3969,7 @@
           <p:cNvPr id="27" name="">
             <a:extLst xmlns:a="http://schemas.openxmlformats.org/drawingml/2006/main">
               <a:ext uri="{FF2B5EF4-FFF2-40B4-BE49-F238E27FC236}">
-                <a16:creationId xmlns:a16="http://schemas.microsoft.com/office/drawing/2014/main" id="{DBE07792-A1BD-4187-A69E-4295633447F8}"/>
+                <a16:creationId xmlns:a16="http://schemas.microsoft.com/office/drawing/2014/main" id="{E6D9AC88-7C3A-4885-B26C-7F01039E8F45}"/>
               </a:ext>
             </a:extLst>
           </p:cNvPr>
@@ -4019,7 +4019,7 @@
           <p:cNvPr id="28" name="">
             <a:extLst xmlns:a="http://schemas.openxmlformats.org/drawingml/2006/main">
               <a:ext uri="{FF2B5EF4-FFF2-40B4-BE49-F238E27FC236}">
-                <a16:creationId xmlns:a16="http://schemas.microsoft.com/office/drawing/2014/main" id="{25339674-7D58-478D-A967-4901F4CBCBE0}"/>
+                <a16:creationId xmlns:a16="http://schemas.microsoft.com/office/drawing/2014/main" id="{347143C0-535C-4147-B4B3-45EC2D1E55D2}"/>
               </a:ext>
             </a:extLst>
           </p:cNvPr>
@@ -4052,7 +4052,7 @@
           <p:cNvPr id="29" name="">
             <a:extLst xmlns:a="http://schemas.openxmlformats.org/drawingml/2006/main">
               <a:ext uri="{FF2B5EF4-FFF2-40B4-BE49-F238E27FC236}">
-                <a16:creationId xmlns:a16="http://schemas.microsoft.com/office/drawing/2014/main" id="{112B70A8-E859-428F-A5AD-F7715717D067}"/>
+                <a16:creationId xmlns:a16="http://schemas.microsoft.com/office/drawing/2014/main" id="{F21AC9D1-381A-4280-92EB-43007F9A620C}"/>
               </a:ext>
             </a:extLst>
           </p:cNvPr>
@@ -4102,7 +4102,7 @@
           <p:cNvPr id="30" name="">
             <a:extLst xmlns:a="http://schemas.openxmlformats.org/drawingml/2006/main">
               <a:ext uri="{FF2B5EF4-FFF2-40B4-BE49-F238E27FC236}">
-                <a16:creationId xmlns:a16="http://schemas.microsoft.com/office/drawing/2014/main" id="{EB4F543E-68C0-4AAB-8E8F-42CB70C6A77D}"/>
+                <a16:creationId xmlns:a16="http://schemas.microsoft.com/office/drawing/2014/main" id="{9566DB74-EA58-43DD-AD8D-96810ED4C378}"/>
               </a:ext>
             </a:extLst>
           </p:cNvPr>
@@ -4135,7 +4135,7 @@
           <p:cNvPr id="31" name="">
             <a:extLst xmlns:a="http://schemas.openxmlformats.org/drawingml/2006/main">
               <a:ext uri="{FF2B5EF4-FFF2-40B4-BE49-F238E27FC236}">
-                <a16:creationId xmlns:a16="http://schemas.microsoft.com/office/drawing/2014/main" id="{4A23FF03-A9BF-465E-A7B0-843E13068440}"/>
+                <a16:creationId xmlns:a16="http://schemas.microsoft.com/office/drawing/2014/main" id="{2CC92BA0-262C-475D-AD46-D9B680C9301B}"/>
               </a:ext>
             </a:extLst>
           </p:cNvPr>
@@ -4185,7 +4185,7 @@
           <p:cNvPr id="32" name="">
             <a:extLst xmlns:a="http://schemas.openxmlformats.org/drawingml/2006/main">
               <a:ext uri="{FF2B5EF4-FFF2-40B4-BE49-F238E27FC236}">
-                <a16:creationId xmlns:a16="http://schemas.microsoft.com/office/drawing/2014/main" id="{0A13255E-9B9C-4B6B-9C04-27E8D7EA3226}"/>
+                <a16:creationId xmlns:a16="http://schemas.microsoft.com/office/drawing/2014/main" id="{1B427C7C-4DB3-41ED-B671-224DC6E333A5}"/>
               </a:ext>
             </a:extLst>
           </p:cNvPr>
@@ -4235,7 +4235,7 @@
           <p:cNvPr id="33" name="">
             <a:extLst xmlns:a="http://schemas.openxmlformats.org/drawingml/2006/main">
               <a:ext uri="{FF2B5EF4-FFF2-40B4-BE49-F238E27FC236}">
-                <a16:creationId xmlns:a16="http://schemas.microsoft.com/office/drawing/2014/main" id="{2EC262D6-3BF9-45E8-9A15-CB7A8B4F634C}"/>
+                <a16:creationId xmlns:a16="http://schemas.microsoft.com/office/drawing/2014/main" id="{C75C3576-C25D-44E1-A4A1-7EE6B97F4316}"/>
               </a:ext>
             </a:extLst>
           </p:cNvPr>
@@ -4285,7 +4285,7 @@
           <p:cNvPr id="34" name="">
             <a:extLst xmlns:a="http://schemas.openxmlformats.org/drawingml/2006/main">
               <a:ext uri="{FF2B5EF4-FFF2-40B4-BE49-F238E27FC236}">
-                <a16:creationId xmlns:a16="http://schemas.microsoft.com/office/drawing/2014/main" id="{A447DFCB-B9F5-405C-9ABA-F20629F40B82}"/>
+                <a16:creationId xmlns:a16="http://schemas.microsoft.com/office/drawing/2014/main" id="{C39B63A1-FD52-43FF-8E33-809EAD44270D}"/>
               </a:ext>
             </a:extLst>
           </p:cNvPr>
@@ -4323,7 +4323,7 @@
           <p:cNvPr id="35" name="">
             <a:extLst xmlns:a="http://schemas.openxmlformats.org/drawingml/2006/main">
               <a:ext uri="{FF2B5EF4-FFF2-40B4-BE49-F238E27FC236}">
-                <a16:creationId xmlns:a16="http://schemas.microsoft.com/office/drawing/2014/main" id="{AB67EF21-72C7-4DCD-87CF-615C20298700}"/>
+                <a16:creationId xmlns:a16="http://schemas.microsoft.com/office/drawing/2014/main" id="{837F9449-BCB1-463E-B534-8EDA52A4D6FA}"/>
               </a:ext>
             </a:extLst>
           </p:cNvPr>
@@ -4371,7 +4371,7 @@
     </p:spTree>
     <p:extLst>
       <p:ext uri="{BB962C8B-B14F-4D97-AF65-F5344CB8AC3E}">
-        <p14:creationId xmlns:p14="http://schemas.microsoft.com/office/powerpoint/2010/main" val="1348988364"/>
+        <p14:creationId xmlns:p14="http://schemas.microsoft.com/office/powerpoint/2010/main" val="1038843426"/>
       </p:ext>
     </p:extLst>
   </p:cSld>
@@ -4402,7 +4402,7 @@
           <p:cNvPr id="1" name="">
             <a:extLst xmlns:a="http://schemas.openxmlformats.org/drawingml/2006/main">
               <a:ext uri="{FF2B5EF4-FFF2-40B4-BE49-F238E27FC236}">
-                <a16:creationId xmlns:a16="http://schemas.microsoft.com/office/drawing/2014/main" id="{6990DCF5-A74A-4235-8A80-268AFAA25A19}"/>
+                <a16:creationId xmlns:a16="http://schemas.microsoft.com/office/drawing/2014/main" id="{653E6069-47B3-4EB0-8F59-E4C89E504D00}"/>
               </a:ext>
             </a:extLst>
           </p:cNvPr>
@@ -4452,7 +4452,7 @@
           <p:cNvPr id="2" name="">
             <a:extLst xmlns:a="http://schemas.openxmlformats.org/drawingml/2006/main">
               <a:ext uri="{FF2B5EF4-FFF2-40B4-BE49-F238E27FC236}">
-                <a16:creationId xmlns:a16="http://schemas.microsoft.com/office/drawing/2014/main" id="{7688F576-59DD-4698-8DAF-7DB9CCF9E779}"/>
+                <a16:creationId xmlns:a16="http://schemas.microsoft.com/office/drawing/2014/main" id="{9355A852-D6BA-4164-AA8A-B843377D2A6F}"/>
               </a:ext>
             </a:extLst>
           </p:cNvPr>
@@ -4502,7 +4502,7 @@
           <p:cNvPr id="3" name="">
             <a:extLst xmlns:a="http://schemas.openxmlformats.org/drawingml/2006/main">
               <a:ext uri="{FF2B5EF4-FFF2-40B4-BE49-F238E27FC236}">
-                <a16:creationId xmlns:a16="http://schemas.microsoft.com/office/drawing/2014/main" id="{B51DD3C1-1A5D-445F-9F89-AA6F46107168}"/>
+                <a16:creationId xmlns:a16="http://schemas.microsoft.com/office/drawing/2014/main" id="{39BCEE1D-5844-4F7B-9CB0-C725187E4B32}"/>
               </a:ext>
             </a:extLst>
           </p:cNvPr>
@@ -4552,7 +4552,7 @@
           <p:cNvPr id="4" name="">
             <a:extLst xmlns:a="http://schemas.openxmlformats.org/drawingml/2006/main">
               <a:ext uri="{FF2B5EF4-FFF2-40B4-BE49-F238E27FC236}">
-                <a16:creationId xmlns:a16="http://schemas.microsoft.com/office/drawing/2014/main" id="{53F108CE-FA2D-4FCB-99E2-C0538674EED1}"/>
+                <a16:creationId xmlns:a16="http://schemas.microsoft.com/office/drawing/2014/main" id="{5131AE3C-4C4F-469D-AF17-8F3DD3FEB823}"/>
               </a:ext>
             </a:extLst>
           </p:cNvPr>
@@ -4587,7 +4587,7 @@
           <p:cNvPr id="5" name="">
             <a:extLst xmlns:a="http://schemas.openxmlformats.org/drawingml/2006/main">
               <a:ext uri="{FF2B5EF4-FFF2-40B4-BE49-F238E27FC236}">
-                <a16:creationId xmlns:a16="http://schemas.microsoft.com/office/drawing/2014/main" id="{533A5F15-9733-447A-BC82-F0504CD4818F}"/>
+                <a16:creationId xmlns:a16="http://schemas.microsoft.com/office/drawing/2014/main" id="{FDEFC429-DD3B-4B07-ACAB-8E23A2E7626E}"/>
               </a:ext>
             </a:extLst>
           </p:cNvPr>
@@ -4637,7 +4637,7 @@
           <p:cNvPr id="6" name="">
             <a:extLst xmlns:a="http://schemas.openxmlformats.org/drawingml/2006/main">
               <a:ext uri="{FF2B5EF4-FFF2-40B4-BE49-F238E27FC236}">
-                <a16:creationId xmlns:a16="http://schemas.microsoft.com/office/drawing/2014/main" id="{87991C33-5F7C-4C62-BEB9-A02F5361587B}"/>
+                <a16:creationId xmlns:a16="http://schemas.microsoft.com/office/drawing/2014/main" id="{664DD78D-5886-4EE4-8AE9-297F0A832636}"/>
               </a:ext>
             </a:extLst>
           </p:cNvPr>
@@ -4687,7 +4687,7 @@
           <p:cNvPr id="7" name="">
             <a:extLst xmlns:a="http://schemas.openxmlformats.org/drawingml/2006/main">
               <a:ext uri="{FF2B5EF4-FFF2-40B4-BE49-F238E27FC236}">
-                <a16:creationId xmlns:a16="http://schemas.microsoft.com/office/drawing/2014/main" id="{B9A2E13A-8C38-4139-88A4-A104A2CBA9FF}"/>
+                <a16:creationId xmlns:a16="http://schemas.microsoft.com/office/drawing/2014/main" id="{AAA26102-2408-4CDD-A42B-22E17977772D}"/>
               </a:ext>
             </a:extLst>
           </p:cNvPr>
@@ -4722,7 +4722,7 @@
           <p:cNvPr id="8" name="">
             <a:extLst xmlns:a="http://schemas.openxmlformats.org/drawingml/2006/main">
               <a:ext uri="{FF2B5EF4-FFF2-40B4-BE49-F238E27FC236}">
-                <a16:creationId xmlns:a16="http://schemas.microsoft.com/office/drawing/2014/main" id="{F2DBAC5B-2976-4FDD-A602-A679193E8E0A}"/>
+                <a16:creationId xmlns:a16="http://schemas.microsoft.com/office/drawing/2014/main" id="{AE1BBA47-BCB8-4FF1-B8B8-24172981C6DB}"/>
               </a:ext>
             </a:extLst>
           </p:cNvPr>
@@ -4772,7 +4772,7 @@
           <p:cNvPr id="9" name="">
             <a:extLst xmlns:a="http://schemas.openxmlformats.org/drawingml/2006/main">
               <a:ext uri="{FF2B5EF4-FFF2-40B4-BE49-F238E27FC236}">
-                <a16:creationId xmlns:a16="http://schemas.microsoft.com/office/drawing/2014/main" id="{B2D557B0-BAD1-49A4-A2B4-07AB561E0A3B}"/>
+                <a16:creationId xmlns:a16="http://schemas.microsoft.com/office/drawing/2014/main" id="{F171A91F-770C-44A0-BD62-95C1E2504750}"/>
               </a:ext>
             </a:extLst>
           </p:cNvPr>
@@ -4822,7 +4822,7 @@
           <p:cNvPr id="10" name="">
             <a:extLst xmlns:a="http://schemas.openxmlformats.org/drawingml/2006/main">
               <a:ext uri="{FF2B5EF4-FFF2-40B4-BE49-F238E27FC236}">
-                <a16:creationId xmlns:a16="http://schemas.microsoft.com/office/drawing/2014/main" id="{4DD3A493-723B-4F38-8B7C-D430D1DC41B9}"/>
+                <a16:creationId xmlns:a16="http://schemas.microsoft.com/office/drawing/2014/main" id="{E7A0ED71-7EAE-48C3-AC65-AEA090C7ACA9}"/>
               </a:ext>
             </a:extLst>
           </p:cNvPr>
@@ -4857,7 +4857,7 @@
           <p:cNvPr id="11" name="">
             <a:extLst xmlns:a="http://schemas.openxmlformats.org/drawingml/2006/main">
               <a:ext uri="{FF2B5EF4-FFF2-40B4-BE49-F238E27FC236}">
-                <a16:creationId xmlns:a16="http://schemas.microsoft.com/office/drawing/2014/main" id="{CA13F74D-5C0A-4150-AA29-58B7CBDB1492}"/>
+                <a16:creationId xmlns:a16="http://schemas.microsoft.com/office/drawing/2014/main" id="{2A83CA41-DB1F-4D3F-875D-4E8391AEF1E1}"/>
               </a:ext>
             </a:extLst>
           </p:cNvPr>
@@ -4907,7 +4907,7 @@
           <p:cNvPr id="12" name="">
             <a:extLst xmlns:a="http://schemas.openxmlformats.org/drawingml/2006/main">
               <a:ext uri="{FF2B5EF4-FFF2-40B4-BE49-F238E27FC236}">
-                <a16:creationId xmlns:a16="http://schemas.microsoft.com/office/drawing/2014/main" id="{396F9B1B-87EF-494C-BBEB-5AA23AA23C8F}"/>
+                <a16:creationId xmlns:a16="http://schemas.microsoft.com/office/drawing/2014/main" id="{A3F63775-13D5-45EC-B1E6-45E12C1B99B7}"/>
               </a:ext>
             </a:extLst>
           </p:cNvPr>
@@ -4964,7 +4964,7 @@
         </p:xfrm>
         <a:graphic xmlns:a="http://schemas.openxmlformats.org/drawingml/2006/main">
           <a:graphicData uri="http://schemas.openxmlformats.org/drawingml/2006/chart">
-            <c:chart xmlns:r="http://schemas.openxmlformats.org/officeDocument/2006/relationships" xmlns:c="http://schemas.openxmlformats.org/drawingml/2006/chart" r:id="R0d50252e614d4bec"/>
+            <c:chart xmlns:r="http://schemas.openxmlformats.org/officeDocument/2006/relationships" xmlns:c="http://schemas.openxmlformats.org/drawingml/2006/chart" r:id="R1a99c72339c541d1"/>
           </a:graphicData>
         </a:graphic>
       </p:graphicFrame>
@@ -4973,7 +4973,7 @@
           <p:cNvPr id="14" name="">
             <a:extLst xmlns:a="http://schemas.openxmlformats.org/drawingml/2006/main">
               <a:ext uri="{FF2B5EF4-FFF2-40B4-BE49-F238E27FC236}">
-                <a16:creationId xmlns:a16="http://schemas.microsoft.com/office/drawing/2014/main" id="{DC33D5DB-07B5-48AC-AB3E-2695EB147798}"/>
+                <a16:creationId xmlns:a16="http://schemas.microsoft.com/office/drawing/2014/main" id="{DC626DF9-11F4-4892-9CBD-2296DD99B2E2}"/>
               </a:ext>
             </a:extLst>
           </p:cNvPr>
@@ -5023,7 +5023,7 @@
           <p:cNvPr id="15" name="">
             <a:extLst xmlns:a="http://schemas.openxmlformats.org/drawingml/2006/main">
               <a:ext uri="{FF2B5EF4-FFF2-40B4-BE49-F238E27FC236}">
-                <a16:creationId xmlns:a16="http://schemas.microsoft.com/office/drawing/2014/main" id="{4F966245-1CDD-4142-AA6F-4ACA0DFC07C7}"/>
+                <a16:creationId xmlns:a16="http://schemas.microsoft.com/office/drawing/2014/main" id="{1B08C641-EDA0-45E4-A975-0AD2D1917F55}"/>
               </a:ext>
             </a:extLst>
           </p:cNvPr>
@@ -5054,7 +5054,7 @@
           <p:cNvPr id="16" name="">
             <a:extLst xmlns:a="http://schemas.openxmlformats.org/drawingml/2006/main">
               <a:ext uri="{FF2B5EF4-FFF2-40B4-BE49-F238E27FC236}">
-                <a16:creationId xmlns:a16="http://schemas.microsoft.com/office/drawing/2014/main" id="{9594811F-1ACD-4C75-8AB2-78A778ABCEAC}"/>
+                <a16:creationId xmlns:a16="http://schemas.microsoft.com/office/drawing/2014/main" id="{81F50461-2B8C-4D1C-8056-AC61C15D0135}"/>
               </a:ext>
             </a:extLst>
           </p:cNvPr>
@@ -5104,7 +5104,7 @@
           <p:cNvPr id="17" name="">
             <a:extLst xmlns:a="http://schemas.openxmlformats.org/drawingml/2006/main">
               <a:ext uri="{FF2B5EF4-FFF2-40B4-BE49-F238E27FC236}">
-                <a16:creationId xmlns:a16="http://schemas.microsoft.com/office/drawing/2014/main" id="{045F888B-7807-4CEB-ABBA-1A7405DB2EC7}"/>
+                <a16:creationId xmlns:a16="http://schemas.microsoft.com/office/drawing/2014/main" id="{C8B7CB92-2256-4A68-833D-6783B7EB4F55}"/>
               </a:ext>
             </a:extLst>
           </p:cNvPr>
@@ -5135,7 +5135,7 @@
           <p:cNvPr id="18" name="">
             <a:extLst xmlns:a="http://schemas.openxmlformats.org/drawingml/2006/main">
               <a:ext uri="{FF2B5EF4-FFF2-40B4-BE49-F238E27FC236}">
-                <a16:creationId xmlns:a16="http://schemas.microsoft.com/office/drawing/2014/main" id="{F7910F4D-A4AD-408D-A6B6-AEAFF8E3D064}"/>
+                <a16:creationId xmlns:a16="http://schemas.microsoft.com/office/drawing/2014/main" id="{E29234F3-2AB9-42F8-9AEA-86CB554FF89C}"/>
               </a:ext>
             </a:extLst>
           </p:cNvPr>
@@ -5185,7 +5185,7 @@
           <p:cNvPr id="19" name="">
             <a:extLst xmlns:a="http://schemas.openxmlformats.org/drawingml/2006/main">
               <a:ext uri="{FF2B5EF4-FFF2-40B4-BE49-F238E27FC236}">
-                <a16:creationId xmlns:a16="http://schemas.microsoft.com/office/drawing/2014/main" id="{0F8F9980-0C64-4B4A-80B4-650EEDEE19F8}"/>
+                <a16:creationId xmlns:a16="http://schemas.microsoft.com/office/drawing/2014/main" id="{36DD1B42-B40A-4E88-BDD7-27B32C2B1A25}"/>
               </a:ext>
             </a:extLst>
           </p:cNvPr>
@@ -5216,7 +5216,7 @@
           <p:cNvPr id="20" name="">
             <a:extLst xmlns:a="http://schemas.openxmlformats.org/drawingml/2006/main">
               <a:ext uri="{FF2B5EF4-FFF2-40B4-BE49-F238E27FC236}">
-                <a16:creationId xmlns:a16="http://schemas.microsoft.com/office/drawing/2014/main" id="{A74D9A3E-C8FF-4B06-AB34-671D7C5C9D84}"/>
+                <a16:creationId xmlns:a16="http://schemas.microsoft.com/office/drawing/2014/main" id="{57F73D5C-6FE6-410E-ABB2-0971E082C76C}"/>
               </a:ext>
             </a:extLst>
           </p:cNvPr>
@@ -5266,7 +5266,7 @@
           <p:cNvPr id="21" name="">
             <a:extLst xmlns:a="http://schemas.openxmlformats.org/drawingml/2006/main">
               <a:ext uri="{FF2B5EF4-FFF2-40B4-BE49-F238E27FC236}">
-                <a16:creationId xmlns:a16="http://schemas.microsoft.com/office/drawing/2014/main" id="{753476EF-F038-41F4-B381-7B74A56B89CE}"/>
+                <a16:creationId xmlns:a16="http://schemas.microsoft.com/office/drawing/2014/main" id="{90154D08-1EEA-4331-9591-23FAAE5CA895}"/>
               </a:ext>
             </a:extLst>
           </p:cNvPr>
@@ -5316,7 +5316,7 @@
           <p:cNvPr id="22" name="">
             <a:extLst xmlns:a="http://schemas.openxmlformats.org/drawingml/2006/main">
               <a:ext uri="{FF2B5EF4-FFF2-40B4-BE49-F238E27FC236}">
-                <a16:creationId xmlns:a16="http://schemas.microsoft.com/office/drawing/2014/main" id="{49287977-659E-42D1-8EAA-8C28FE2A4913}"/>
+                <a16:creationId xmlns:a16="http://schemas.microsoft.com/office/drawing/2014/main" id="{941A2BB6-E455-4093-9BD6-156042ACD829}"/>
               </a:ext>
             </a:extLst>
           </p:cNvPr>
@@ -5364,7 +5364,7 @@
     </p:spTree>
     <p:extLst>
       <p:ext uri="{BB962C8B-B14F-4D97-AF65-F5344CB8AC3E}">
-        <p14:creationId xmlns:p14="http://schemas.microsoft.com/office/powerpoint/2010/main" val="1240630279"/>
+        <p14:creationId xmlns:p14="http://schemas.microsoft.com/office/powerpoint/2010/main" val="379762570"/>
       </p:ext>
     </p:extLst>
   </p:cSld>
@@ -5395,7 +5395,7 @@
           <p:cNvPr id="1" name="">
             <a:extLst xmlns:a="http://schemas.openxmlformats.org/drawingml/2006/main">
               <a:ext uri="{FF2B5EF4-FFF2-40B4-BE49-F238E27FC236}">
-                <a16:creationId xmlns:a16="http://schemas.microsoft.com/office/drawing/2014/main" id="{6EA2BDB8-84BD-4B53-AAA6-0AE56D877D7C}"/>
+                <a16:creationId xmlns:a16="http://schemas.microsoft.com/office/drawing/2014/main" id="{A0AD7873-0940-47C0-862A-6D35A1668E2A}"/>
               </a:ext>
             </a:extLst>
           </p:cNvPr>
@@ -5445,7 +5445,7 @@
           <p:cNvPr id="2" name="">
             <a:extLst xmlns:a="http://schemas.openxmlformats.org/drawingml/2006/main">
               <a:ext uri="{FF2B5EF4-FFF2-40B4-BE49-F238E27FC236}">
-                <a16:creationId xmlns:a16="http://schemas.microsoft.com/office/drawing/2014/main" id="{140E2C74-3E23-43A1-A908-D5EA739F0D75}"/>
+                <a16:creationId xmlns:a16="http://schemas.microsoft.com/office/drawing/2014/main" id="{34ECA06C-9437-43E2-9BF7-6A2DECA23AC1}"/>
               </a:ext>
             </a:extLst>
           </p:cNvPr>
@@ -5495,7 +5495,7 @@
           <p:cNvPr id="3" name="">
             <a:extLst xmlns:a="http://schemas.openxmlformats.org/drawingml/2006/main">
               <a:ext uri="{FF2B5EF4-FFF2-40B4-BE49-F238E27FC236}">
-                <a16:creationId xmlns:a16="http://schemas.microsoft.com/office/drawing/2014/main" id="{E782EFE5-6B36-4945-B986-B299229A4953}"/>
+                <a16:creationId xmlns:a16="http://schemas.microsoft.com/office/drawing/2014/main" id="{D7F2252C-D161-4B7B-BC8A-BBFEE25E341A}"/>
               </a:ext>
             </a:extLst>
           </p:cNvPr>
@@ -5545,7 +5545,7 @@
           <p:cNvPr id="4" name="">
             <a:extLst xmlns:a="http://schemas.openxmlformats.org/drawingml/2006/main">
               <a:ext uri="{FF2B5EF4-FFF2-40B4-BE49-F238E27FC236}">
-                <a16:creationId xmlns:a16="http://schemas.microsoft.com/office/drawing/2014/main" id="{0F792E95-4153-45F8-AEFD-E6076B55A8FA}"/>
+                <a16:creationId xmlns:a16="http://schemas.microsoft.com/office/drawing/2014/main" id="{58C015ED-4C17-48EB-9482-79739832E385}"/>
               </a:ext>
             </a:extLst>
           </p:cNvPr>
@@ -5578,7 +5578,7 @@
           <p:cNvPr id="5" name="">
             <a:extLst xmlns:a="http://schemas.openxmlformats.org/drawingml/2006/main">
               <a:ext uri="{FF2B5EF4-FFF2-40B4-BE49-F238E27FC236}">
-                <a16:creationId xmlns:a16="http://schemas.microsoft.com/office/drawing/2014/main" id="{7735CDD1-6506-4F5C-BDC9-11E2D4D84AC6}"/>
+                <a16:creationId xmlns:a16="http://schemas.microsoft.com/office/drawing/2014/main" id="{30658876-7298-4078-B693-0D1B0CA83233}"/>
               </a:ext>
             </a:extLst>
           </p:cNvPr>
@@ -5609,7 +5609,7 @@
           <p:cNvPr id="6" name="">
             <a:extLst xmlns:a="http://schemas.openxmlformats.org/drawingml/2006/main">
               <a:ext uri="{FF2B5EF4-FFF2-40B4-BE49-F238E27FC236}">
-                <a16:creationId xmlns:a16="http://schemas.microsoft.com/office/drawing/2014/main" id="{C8AA9130-5A95-4F83-88D1-74C3EEEE97A4}"/>
+                <a16:creationId xmlns:a16="http://schemas.microsoft.com/office/drawing/2014/main" id="{F7B9A448-93BE-4B30-BEC7-9EE5734048CB}"/>
               </a:ext>
             </a:extLst>
           </p:cNvPr>
@@ -5659,7 +5659,7 @@
           <p:cNvPr id="7" name="">
             <a:extLst xmlns:a="http://schemas.openxmlformats.org/drawingml/2006/main">
               <a:ext uri="{FF2B5EF4-FFF2-40B4-BE49-F238E27FC236}">
-                <a16:creationId xmlns:a16="http://schemas.microsoft.com/office/drawing/2014/main" id="{9F6E010D-5AA2-420F-8363-E80E0624BEB4}"/>
+                <a16:creationId xmlns:a16="http://schemas.microsoft.com/office/drawing/2014/main" id="{AAB6EC0C-8D8A-428B-A753-0FC0B3977C03}"/>
               </a:ext>
             </a:extLst>
           </p:cNvPr>
@@ -5709,7 +5709,7 @@
           <p:cNvPr id="8" name="">
             <a:extLst xmlns:a="http://schemas.openxmlformats.org/drawingml/2006/main">
               <a:ext uri="{FF2B5EF4-FFF2-40B4-BE49-F238E27FC236}">
-                <a16:creationId xmlns:a16="http://schemas.microsoft.com/office/drawing/2014/main" id="{92B5F593-309F-43D9-8766-3A9435614DCB}"/>
+                <a16:creationId xmlns:a16="http://schemas.microsoft.com/office/drawing/2014/main" id="{4011917E-3D84-4E89-BFFC-C5A27BA72BFD}"/>
               </a:ext>
             </a:extLst>
           </p:cNvPr>
@@ -5742,7 +5742,7 @@
           <p:cNvPr id="9" name="">
             <a:extLst xmlns:a="http://schemas.openxmlformats.org/drawingml/2006/main">
               <a:ext uri="{FF2B5EF4-FFF2-40B4-BE49-F238E27FC236}">
-                <a16:creationId xmlns:a16="http://schemas.microsoft.com/office/drawing/2014/main" id="{A15E76CA-06AB-4F15-ADFB-7C29DC9ED371}"/>
+                <a16:creationId xmlns:a16="http://schemas.microsoft.com/office/drawing/2014/main" id="{5BF1290A-CB8F-4223-894C-43D2C355A546}"/>
               </a:ext>
             </a:extLst>
           </p:cNvPr>
@@ -5773,7 +5773,7 @@
           <p:cNvPr id="10" name="">
             <a:extLst xmlns:a="http://schemas.openxmlformats.org/drawingml/2006/main">
               <a:ext uri="{FF2B5EF4-FFF2-40B4-BE49-F238E27FC236}">
-                <a16:creationId xmlns:a16="http://schemas.microsoft.com/office/drawing/2014/main" id="{04E1A2CA-753D-4420-85A5-6160B7F5DE96}"/>
+                <a16:creationId xmlns:a16="http://schemas.microsoft.com/office/drawing/2014/main" id="{5B312294-98CF-4A32-874E-1E04E1D0E13B}"/>
               </a:ext>
             </a:extLst>
           </p:cNvPr>
@@ -5823,7 +5823,7 @@
           <p:cNvPr id="11" name="">
             <a:extLst xmlns:a="http://schemas.openxmlformats.org/drawingml/2006/main">
               <a:ext uri="{FF2B5EF4-FFF2-40B4-BE49-F238E27FC236}">
-                <a16:creationId xmlns:a16="http://schemas.microsoft.com/office/drawing/2014/main" id="{50867862-1F77-4801-95C2-3C5203C2208F}"/>
+                <a16:creationId xmlns:a16="http://schemas.microsoft.com/office/drawing/2014/main" id="{8428B488-9D95-46A3-BFEF-149548DACF7D}"/>
               </a:ext>
             </a:extLst>
           </p:cNvPr>
@@ -5873,7 +5873,7 @@
           <p:cNvPr id="12" name="">
             <a:extLst xmlns:a="http://schemas.openxmlformats.org/drawingml/2006/main">
               <a:ext uri="{FF2B5EF4-FFF2-40B4-BE49-F238E27FC236}">
-                <a16:creationId xmlns:a16="http://schemas.microsoft.com/office/drawing/2014/main" id="{FED70C72-4E07-4C56-8AD9-6EE54130B6DF}"/>
+                <a16:creationId xmlns:a16="http://schemas.microsoft.com/office/drawing/2014/main" id="{E2085DDA-91B3-4688-BD0A-8581677AE6F1}"/>
               </a:ext>
             </a:extLst>
           </p:cNvPr>
@@ -5906,7 +5906,7 @@
           <p:cNvPr id="13" name="">
             <a:extLst xmlns:a="http://schemas.openxmlformats.org/drawingml/2006/main">
               <a:ext uri="{FF2B5EF4-FFF2-40B4-BE49-F238E27FC236}">
-                <a16:creationId xmlns:a16="http://schemas.microsoft.com/office/drawing/2014/main" id="{2B497141-B042-4094-8C5E-D40D088D0893}"/>
+                <a16:creationId xmlns:a16="http://schemas.microsoft.com/office/drawing/2014/main" id="{BBB76C0F-8ECC-4AAE-88F6-2145B001445D}"/>
               </a:ext>
             </a:extLst>
           </p:cNvPr>
@@ -5937,7 +5937,7 @@
           <p:cNvPr id="14" name="">
             <a:extLst xmlns:a="http://schemas.openxmlformats.org/drawingml/2006/main">
               <a:ext uri="{FF2B5EF4-FFF2-40B4-BE49-F238E27FC236}">
-                <a16:creationId xmlns:a16="http://schemas.microsoft.com/office/drawing/2014/main" id="{6E501295-B0F7-4D55-82BA-1382A6B3F925}"/>
+                <a16:creationId xmlns:a16="http://schemas.microsoft.com/office/drawing/2014/main" id="{E33425AB-F16C-4A0A-84B5-B81B69597A65}"/>
               </a:ext>
             </a:extLst>
           </p:cNvPr>
@@ -5987,7 +5987,7 @@
           <p:cNvPr id="15" name="">
             <a:extLst xmlns:a="http://schemas.openxmlformats.org/drawingml/2006/main">
               <a:ext uri="{FF2B5EF4-FFF2-40B4-BE49-F238E27FC236}">
-                <a16:creationId xmlns:a16="http://schemas.microsoft.com/office/drawing/2014/main" id="{616F2C3A-3D1B-405F-AA86-50AC7ABD6937}"/>
+                <a16:creationId xmlns:a16="http://schemas.microsoft.com/office/drawing/2014/main" id="{F9DD3D47-583E-43EA-91DA-484C4CD4D589}"/>
               </a:ext>
             </a:extLst>
           </p:cNvPr>
@@ -6037,7 +6037,7 @@
           <p:cNvPr id="16" name="">
             <a:extLst xmlns:a="http://schemas.openxmlformats.org/drawingml/2006/main">
               <a:ext uri="{FF2B5EF4-FFF2-40B4-BE49-F238E27FC236}">
-                <a16:creationId xmlns:a16="http://schemas.microsoft.com/office/drawing/2014/main" id="{5406C670-AAE7-43ED-92A6-EF5FB2C8DB5D}"/>
+                <a16:creationId xmlns:a16="http://schemas.microsoft.com/office/drawing/2014/main" id="{68846112-3363-47C4-92E8-0958FD4C41E8}"/>
               </a:ext>
             </a:extLst>
           </p:cNvPr>
@@ -6087,7 +6087,7 @@
           <p:cNvPr id="17" name="">
             <a:extLst xmlns:a="http://schemas.openxmlformats.org/drawingml/2006/main">
               <a:ext uri="{FF2B5EF4-FFF2-40B4-BE49-F238E27FC236}">
-                <a16:creationId xmlns:a16="http://schemas.microsoft.com/office/drawing/2014/main" id="{0714AF8D-283C-458F-8AC2-04469C221948}"/>
+                <a16:creationId xmlns:a16="http://schemas.microsoft.com/office/drawing/2014/main" id="{1CCBA0F7-1604-494F-AFF9-280CD7EBE357}"/>
               </a:ext>
             </a:extLst>
           </p:cNvPr>
@@ -6137,7 +6137,7 @@
           <p:cNvPr id="18" name="">
             <a:extLst xmlns:a="http://schemas.openxmlformats.org/drawingml/2006/main">
               <a:ext uri="{FF2B5EF4-FFF2-40B4-BE49-F238E27FC236}">
-                <a16:creationId xmlns:a16="http://schemas.microsoft.com/office/drawing/2014/main" id="{551D902E-C83C-4CAE-BB28-82C9980F45E6}"/>
+                <a16:creationId xmlns:a16="http://schemas.microsoft.com/office/drawing/2014/main" id="{9288F3CE-3459-42CA-86F9-D863B87149B0}"/>
               </a:ext>
             </a:extLst>
           </p:cNvPr>
@@ -6185,7 +6185,7 @@
     </p:spTree>
     <p:extLst>
       <p:ext uri="{BB962C8B-B14F-4D97-AF65-F5344CB8AC3E}">
-        <p14:creationId xmlns:p14="http://schemas.microsoft.com/office/powerpoint/2010/main" val="1161811640"/>
+        <p14:creationId xmlns:p14="http://schemas.microsoft.com/office/powerpoint/2010/main" val="902609468"/>
       </p:ext>
     </p:extLst>
   </p:cSld>
@@ -6216,7 +6216,7 @@
           <p:cNvPr id="1" name="">
             <a:extLst xmlns:a="http://schemas.openxmlformats.org/drawingml/2006/main">
               <a:ext uri="{FF2B5EF4-FFF2-40B4-BE49-F238E27FC236}">
-                <a16:creationId xmlns:a16="http://schemas.microsoft.com/office/drawing/2014/main" id="{A67C83A0-5812-4824-AB3D-81F36618CEF2}"/>
+                <a16:creationId xmlns:a16="http://schemas.microsoft.com/office/drawing/2014/main" id="{C41DE575-4BD1-4F2C-949F-4FCF6DF39354}"/>
               </a:ext>
             </a:extLst>
           </p:cNvPr>
@@ -6266,7 +6266,7 @@
           <p:cNvPr id="2" name="">
             <a:extLst xmlns:a="http://schemas.openxmlformats.org/drawingml/2006/main">
               <a:ext uri="{FF2B5EF4-FFF2-40B4-BE49-F238E27FC236}">
-                <a16:creationId xmlns:a16="http://schemas.microsoft.com/office/drawing/2014/main" id="{CAF17D80-2A25-41D1-ABC0-1ADE29FB543D}"/>
+                <a16:creationId xmlns:a16="http://schemas.microsoft.com/office/drawing/2014/main" id="{9E08D111-8175-4377-89F8-CCC99952A030}"/>
               </a:ext>
             </a:extLst>
           </p:cNvPr>
@@ -6316,7 +6316,7 @@
           <p:cNvPr id="3" name="">
             <a:extLst xmlns:a="http://schemas.openxmlformats.org/drawingml/2006/main">
               <a:ext uri="{FF2B5EF4-FFF2-40B4-BE49-F238E27FC236}">
-                <a16:creationId xmlns:a16="http://schemas.microsoft.com/office/drawing/2014/main" id="{CD4BB3C6-0F42-4AA0-A1BB-CF2B71311E2B}"/>
+                <a16:creationId xmlns:a16="http://schemas.microsoft.com/office/drawing/2014/main" id="{64F941D8-EAEF-4B48-AA27-51BF41AA18B2}"/>
               </a:ext>
             </a:extLst>
           </p:cNvPr>
@@ -6366,7 +6366,7 @@
           <p:cNvPr id="4" name="">
             <a:extLst xmlns:a="http://schemas.openxmlformats.org/drawingml/2006/main">
               <a:ext uri="{FF2B5EF4-FFF2-40B4-BE49-F238E27FC236}">
-                <a16:creationId xmlns:a16="http://schemas.microsoft.com/office/drawing/2014/main" id="{B41853C7-9DD8-428C-9E31-1D55DBE2CFCC}"/>
+                <a16:creationId xmlns:a16="http://schemas.microsoft.com/office/drawing/2014/main" id="{1DD25E55-066A-4D26-87A7-4068D197ABC5}"/>
               </a:ext>
             </a:extLst>
           </p:cNvPr>
@@ -6397,7 +6397,7 @@
           <p:cNvPr id="5" name="">
             <a:extLst xmlns:a="http://schemas.openxmlformats.org/drawingml/2006/main">
               <a:ext uri="{FF2B5EF4-FFF2-40B4-BE49-F238E27FC236}">
-                <a16:creationId xmlns:a16="http://schemas.microsoft.com/office/drawing/2014/main" id="{24C47E2E-E584-4E6F-BC75-2B793DD7F35E}"/>
+                <a16:creationId xmlns:a16="http://schemas.microsoft.com/office/drawing/2014/main" id="{16E66EA7-6E7A-4832-8904-F81335AB7AB1}"/>
               </a:ext>
             </a:extLst>
           </p:cNvPr>
@@ -6447,7 +6447,7 @@
           <p:cNvPr id="6" name="">
             <a:extLst xmlns:a="http://schemas.openxmlformats.org/drawingml/2006/main">
               <a:ext uri="{FF2B5EF4-FFF2-40B4-BE49-F238E27FC236}">
-                <a16:creationId xmlns:a16="http://schemas.microsoft.com/office/drawing/2014/main" id="{ED53ABB7-4C7D-4B92-9AF0-8161AFFF61D2}"/>
+                <a16:creationId xmlns:a16="http://schemas.microsoft.com/office/drawing/2014/main" id="{996C26E8-3F59-4187-90CD-0D6691238796}"/>
               </a:ext>
             </a:extLst>
           </p:cNvPr>
@@ -6497,7 +6497,7 @@
           <p:cNvPr id="7" name="">
             <a:extLst xmlns:a="http://schemas.openxmlformats.org/drawingml/2006/main">
               <a:ext uri="{FF2B5EF4-FFF2-40B4-BE49-F238E27FC236}">
-                <a16:creationId xmlns:a16="http://schemas.microsoft.com/office/drawing/2014/main" id="{3DEA1FA5-83F2-485D-9E0A-44200669596C}"/>
+                <a16:creationId xmlns:a16="http://schemas.microsoft.com/office/drawing/2014/main" id="{F6C6DCFB-51C5-4E99-A758-725C4ED761F2}"/>
               </a:ext>
             </a:extLst>
           </p:cNvPr>
@@ -6530,7 +6530,7 @@
           <p:cNvPr id="8" name="">
             <a:extLst xmlns:a="http://schemas.openxmlformats.org/drawingml/2006/main">
               <a:ext uri="{FF2B5EF4-FFF2-40B4-BE49-F238E27FC236}">
-                <a16:creationId xmlns:a16="http://schemas.microsoft.com/office/drawing/2014/main" id="{F090BEA0-AB24-4065-A6B7-B8B608FAF29D}"/>
+                <a16:creationId xmlns:a16="http://schemas.microsoft.com/office/drawing/2014/main" id="{AF88D0D7-EF49-43BB-BCE2-898408AF73FA}"/>
               </a:ext>
             </a:extLst>
           </p:cNvPr>
@@ -6580,7 +6580,7 @@
           <p:cNvPr id="9" name="">
             <a:extLst xmlns:a="http://schemas.openxmlformats.org/drawingml/2006/main">
               <a:ext uri="{FF2B5EF4-FFF2-40B4-BE49-F238E27FC236}">
-                <a16:creationId xmlns:a16="http://schemas.microsoft.com/office/drawing/2014/main" id="{AE7D1D90-D3ED-4131-8FC3-808A039299EA}"/>
+                <a16:creationId xmlns:a16="http://schemas.microsoft.com/office/drawing/2014/main" id="{DCBAA845-86DF-4C82-B8A8-112B1CE00C99}"/>
               </a:ext>
             </a:extLst>
           </p:cNvPr>
@@ -6611,7 +6611,7 @@
           <p:cNvPr id="10" name="">
             <a:extLst xmlns:a="http://schemas.openxmlformats.org/drawingml/2006/main">
               <a:ext uri="{FF2B5EF4-FFF2-40B4-BE49-F238E27FC236}">
-                <a16:creationId xmlns:a16="http://schemas.microsoft.com/office/drawing/2014/main" id="{6E5BB178-32E8-48D1-A588-DD82A40CAF50}"/>
+                <a16:creationId xmlns:a16="http://schemas.microsoft.com/office/drawing/2014/main" id="{A2A5A150-47AE-41E6-B7EF-91B36A84866A}"/>
               </a:ext>
             </a:extLst>
           </p:cNvPr>
@@ -6661,7 +6661,7 @@
           <p:cNvPr id="11" name="">
             <a:extLst xmlns:a="http://schemas.openxmlformats.org/drawingml/2006/main">
               <a:ext uri="{FF2B5EF4-FFF2-40B4-BE49-F238E27FC236}">
-                <a16:creationId xmlns:a16="http://schemas.microsoft.com/office/drawing/2014/main" id="{F8E77C92-C6A8-4205-9B12-83EE3AFA4BD0}"/>
+                <a16:creationId xmlns:a16="http://schemas.microsoft.com/office/drawing/2014/main" id="{33C6C627-01D6-4EA4-BA02-9AE3D3B770CB}"/>
               </a:ext>
             </a:extLst>
           </p:cNvPr>
@@ -6711,7 +6711,7 @@
           <p:cNvPr id="12" name="">
             <a:extLst xmlns:a="http://schemas.openxmlformats.org/drawingml/2006/main">
               <a:ext uri="{FF2B5EF4-FFF2-40B4-BE49-F238E27FC236}">
-                <a16:creationId xmlns:a16="http://schemas.microsoft.com/office/drawing/2014/main" id="{DAAF3165-131A-4E48-AD48-9DECDE70B833}"/>
+                <a16:creationId xmlns:a16="http://schemas.microsoft.com/office/drawing/2014/main" id="{5D9A408C-470C-4C85-958E-20D6233AF6EC}"/>
               </a:ext>
             </a:extLst>
           </p:cNvPr>
@@ -6744,7 +6744,7 @@
           <p:cNvPr id="13" name="">
             <a:extLst xmlns:a="http://schemas.openxmlformats.org/drawingml/2006/main">
               <a:ext uri="{FF2B5EF4-FFF2-40B4-BE49-F238E27FC236}">
-                <a16:creationId xmlns:a16="http://schemas.microsoft.com/office/drawing/2014/main" id="{970A5DD2-6669-4945-8675-66CFA87D958B}"/>
+                <a16:creationId xmlns:a16="http://schemas.microsoft.com/office/drawing/2014/main" id="{1F7D516E-736C-4009-BEC8-09619DA8225F}"/>
               </a:ext>
             </a:extLst>
           </p:cNvPr>
@@ -6794,7 +6794,7 @@
           <p:cNvPr id="14" name="">
             <a:extLst xmlns:a="http://schemas.openxmlformats.org/drawingml/2006/main">
               <a:ext uri="{FF2B5EF4-FFF2-40B4-BE49-F238E27FC236}">
-                <a16:creationId xmlns:a16="http://schemas.microsoft.com/office/drawing/2014/main" id="{6842C580-5A61-4492-8345-4F379D158149}"/>
+                <a16:creationId xmlns:a16="http://schemas.microsoft.com/office/drawing/2014/main" id="{4DCE8D79-4F04-407C-A3D4-85561DBD0B97}"/>
               </a:ext>
             </a:extLst>
           </p:cNvPr>
@@ -6825,7 +6825,7 @@
           <p:cNvPr id="15" name="">
             <a:extLst xmlns:a="http://schemas.openxmlformats.org/drawingml/2006/main">
               <a:ext uri="{FF2B5EF4-FFF2-40B4-BE49-F238E27FC236}">
-                <a16:creationId xmlns:a16="http://schemas.microsoft.com/office/drawing/2014/main" id="{52966E6D-5067-40D6-A907-547000FA9A20}"/>
+                <a16:creationId xmlns:a16="http://schemas.microsoft.com/office/drawing/2014/main" id="{84D07D05-159E-4194-8F33-350C9F474CD8}"/>
               </a:ext>
             </a:extLst>
           </p:cNvPr>
@@ -6875,7 +6875,7 @@
           <p:cNvPr id="16" name="">
             <a:extLst xmlns:a="http://schemas.openxmlformats.org/drawingml/2006/main">
               <a:ext uri="{FF2B5EF4-FFF2-40B4-BE49-F238E27FC236}">
-                <a16:creationId xmlns:a16="http://schemas.microsoft.com/office/drawing/2014/main" id="{6125A88D-ED28-49BC-B4A1-2C91C2630743}"/>
+                <a16:creationId xmlns:a16="http://schemas.microsoft.com/office/drawing/2014/main" id="{9B1A68BA-D519-4041-B7FC-BD3864544E9A}"/>
               </a:ext>
             </a:extLst>
           </p:cNvPr>
@@ -6925,7 +6925,7 @@
           <p:cNvPr id="17" name="">
             <a:extLst xmlns:a="http://schemas.openxmlformats.org/drawingml/2006/main">
               <a:ext uri="{FF2B5EF4-FFF2-40B4-BE49-F238E27FC236}">
-                <a16:creationId xmlns:a16="http://schemas.microsoft.com/office/drawing/2014/main" id="{C403E0A3-35F7-4B8C-BAF1-3C472DD975DB}"/>
+                <a16:creationId xmlns:a16="http://schemas.microsoft.com/office/drawing/2014/main" id="{FD0AFAC9-C968-4249-B797-88A8C36FBF1F}"/>
               </a:ext>
             </a:extLst>
           </p:cNvPr>
@@ -6958,7 +6958,7 @@
           <p:cNvPr id="18" name="">
             <a:extLst xmlns:a="http://schemas.openxmlformats.org/drawingml/2006/main">
               <a:ext uri="{FF2B5EF4-FFF2-40B4-BE49-F238E27FC236}">
-                <a16:creationId xmlns:a16="http://schemas.microsoft.com/office/drawing/2014/main" id="{E2E4FF86-5A21-4DB2-90C1-5E936C8DDA6E}"/>
+                <a16:creationId xmlns:a16="http://schemas.microsoft.com/office/drawing/2014/main" id="{C1C43974-44D0-49DC-BE4E-1912FEDAE3D1}"/>
               </a:ext>
             </a:extLst>
           </p:cNvPr>
@@ -7008,7 +7008,7 @@
           <p:cNvPr id="19" name="">
             <a:extLst xmlns:a="http://schemas.openxmlformats.org/drawingml/2006/main">
               <a:ext uri="{FF2B5EF4-FFF2-40B4-BE49-F238E27FC236}">
-                <a16:creationId xmlns:a16="http://schemas.microsoft.com/office/drawing/2014/main" id="{D73454B9-1B69-4DD9-88C3-2F2B55CA02E0}"/>
+                <a16:creationId xmlns:a16="http://schemas.microsoft.com/office/drawing/2014/main" id="{808C26BD-694C-4279-A33D-CD47B02FAD8D}"/>
               </a:ext>
             </a:extLst>
           </p:cNvPr>
@@ -7039,7 +7039,7 @@
           <p:cNvPr id="20" name="">
             <a:extLst xmlns:a="http://schemas.openxmlformats.org/drawingml/2006/main">
               <a:ext uri="{FF2B5EF4-FFF2-40B4-BE49-F238E27FC236}">
-                <a16:creationId xmlns:a16="http://schemas.microsoft.com/office/drawing/2014/main" id="{5D7C45E6-316E-45F0-B7B6-DD5718000645}"/>
+                <a16:creationId xmlns:a16="http://schemas.microsoft.com/office/drawing/2014/main" id="{76CC1B0E-0AE4-475C-A15A-78899B4A852E}"/>
               </a:ext>
             </a:extLst>
           </p:cNvPr>
@@ -7089,7 +7089,7 @@
           <p:cNvPr id="21" name="">
             <a:extLst xmlns:a="http://schemas.openxmlformats.org/drawingml/2006/main">
               <a:ext uri="{FF2B5EF4-FFF2-40B4-BE49-F238E27FC236}">
-                <a16:creationId xmlns:a16="http://schemas.microsoft.com/office/drawing/2014/main" id="{956051B5-B8CF-410B-87FA-537B86C47035}"/>
+                <a16:creationId xmlns:a16="http://schemas.microsoft.com/office/drawing/2014/main" id="{54EAD4E3-4AA0-4AB5-953D-01F8E2D277A3}"/>
               </a:ext>
             </a:extLst>
           </p:cNvPr>
@@ -7139,7 +7139,7 @@
           <p:cNvPr id="22" name="">
             <a:extLst xmlns:a="http://schemas.openxmlformats.org/drawingml/2006/main">
               <a:ext uri="{FF2B5EF4-FFF2-40B4-BE49-F238E27FC236}">
-                <a16:creationId xmlns:a16="http://schemas.microsoft.com/office/drawing/2014/main" id="{AFDC4C1F-3DE9-453A-B5A9-9B56D2212195}"/>
+                <a16:creationId xmlns:a16="http://schemas.microsoft.com/office/drawing/2014/main" id="{C2CB397E-1053-46AF-BFDB-AF5D7E3EA88E}"/>
               </a:ext>
             </a:extLst>
           </p:cNvPr>
@@ -7172,7 +7172,7 @@
           <p:cNvPr id="23" name="">
             <a:extLst xmlns:a="http://schemas.openxmlformats.org/drawingml/2006/main">
               <a:ext uri="{FF2B5EF4-FFF2-40B4-BE49-F238E27FC236}">
-                <a16:creationId xmlns:a16="http://schemas.microsoft.com/office/drawing/2014/main" id="{CAE84B2B-BDD7-4FDF-881E-3E8A8D3F2B92}"/>
+                <a16:creationId xmlns:a16="http://schemas.microsoft.com/office/drawing/2014/main" id="{A8D5D2ED-0967-46AD-9FA7-A102BCF3C12D}"/>
               </a:ext>
             </a:extLst>
           </p:cNvPr>
@@ -7222,7 +7222,7 @@
           <p:cNvPr id="24" name="">
             <a:extLst xmlns:a="http://schemas.openxmlformats.org/drawingml/2006/main">
               <a:ext uri="{FF2B5EF4-FFF2-40B4-BE49-F238E27FC236}">
-                <a16:creationId xmlns:a16="http://schemas.microsoft.com/office/drawing/2014/main" id="{3C1CFC43-622A-4716-BDB9-77087A660C76}"/>
+                <a16:creationId xmlns:a16="http://schemas.microsoft.com/office/drawing/2014/main" id="{5A9D012E-0009-485D-A6C8-8ED9D7B7B1E1}"/>
               </a:ext>
             </a:extLst>
           </p:cNvPr>
@@ -7272,7 +7272,7 @@
           <p:cNvPr id="25" name="">
             <a:extLst xmlns:a="http://schemas.openxmlformats.org/drawingml/2006/main">
               <a:ext uri="{FF2B5EF4-FFF2-40B4-BE49-F238E27FC236}">
-                <a16:creationId xmlns:a16="http://schemas.microsoft.com/office/drawing/2014/main" id="{C8207292-FAA0-4D94-ABED-1B3CC4C96477}"/>
+                <a16:creationId xmlns:a16="http://schemas.microsoft.com/office/drawing/2014/main" id="{65D1DC8B-7EA6-4D26-A861-989A82B76127}"/>
               </a:ext>
             </a:extLst>
           </p:cNvPr>
@@ -7320,7 +7320,7 @@
     </p:spTree>
     <p:extLst>
       <p:ext uri="{BB962C8B-B14F-4D97-AF65-F5344CB8AC3E}">
-        <p14:creationId xmlns:p14="http://schemas.microsoft.com/office/powerpoint/2010/main" val="1000087918"/>
+        <p14:creationId xmlns:p14="http://schemas.microsoft.com/office/powerpoint/2010/main" val="715154963"/>
       </p:ext>
     </p:extLst>
   </p:cSld>
@@ -7351,7 +7351,7 @@
           <p:cNvPr id="1" name="">
             <a:extLst xmlns:a="http://schemas.openxmlformats.org/drawingml/2006/main">
               <a:ext uri="{FF2B5EF4-FFF2-40B4-BE49-F238E27FC236}">
-                <a16:creationId xmlns:a16="http://schemas.microsoft.com/office/drawing/2014/main" id="{7543C49D-AAFD-49CC-A285-912B8F2765FD}"/>
+                <a16:creationId xmlns:a16="http://schemas.microsoft.com/office/drawing/2014/main" id="{3D0DB9F0-70B1-459E-927D-8C5782B928AC}"/>
               </a:ext>
             </a:extLst>
           </p:cNvPr>
@@ -7401,7 +7401,7 @@
           <p:cNvPr id="2" name="">
             <a:extLst xmlns:a="http://schemas.openxmlformats.org/drawingml/2006/main">
               <a:ext uri="{FF2B5EF4-FFF2-40B4-BE49-F238E27FC236}">
-                <a16:creationId xmlns:a16="http://schemas.microsoft.com/office/drawing/2014/main" id="{903E602B-2921-4E41-AC4B-E40B285A41A1}"/>
+                <a16:creationId xmlns:a16="http://schemas.microsoft.com/office/drawing/2014/main" id="{A6F1DAFB-3D9A-4345-BA84-A34E70F0EC09}"/>
               </a:ext>
             </a:extLst>
           </p:cNvPr>
@@ -7451,7 +7451,7 @@
           <p:cNvPr id="3" name="">
             <a:extLst xmlns:a="http://schemas.openxmlformats.org/drawingml/2006/main">
               <a:ext uri="{FF2B5EF4-FFF2-40B4-BE49-F238E27FC236}">
-                <a16:creationId xmlns:a16="http://schemas.microsoft.com/office/drawing/2014/main" id="{703FC2D3-5787-4872-A6FB-38482CF275EA}"/>
+                <a16:creationId xmlns:a16="http://schemas.microsoft.com/office/drawing/2014/main" id="{81E8C59C-386B-4CC7-B8F2-5F0B501AC3E0}"/>
               </a:ext>
             </a:extLst>
           </p:cNvPr>
@@ -7501,7 +7501,7 @@
           <p:cNvPr id="4" name="">
             <a:extLst xmlns:a="http://schemas.openxmlformats.org/drawingml/2006/main">
               <a:ext uri="{FF2B5EF4-FFF2-40B4-BE49-F238E27FC236}">
-                <a16:creationId xmlns:a16="http://schemas.microsoft.com/office/drawing/2014/main" id="{2ECF879E-6EEA-47A1-97B0-AF6D00FC7DF1}"/>
+                <a16:creationId xmlns:a16="http://schemas.microsoft.com/office/drawing/2014/main" id="{163B73DC-BC49-48DB-9497-079FA01D1969}"/>
               </a:ext>
             </a:extLst>
           </p:cNvPr>
@@ -7536,7 +7536,7 @@
           <p:cNvPr id="5" name="">
             <a:extLst xmlns:a="http://schemas.openxmlformats.org/drawingml/2006/main">
               <a:ext uri="{FF2B5EF4-FFF2-40B4-BE49-F238E27FC236}">
-                <a16:creationId xmlns:a16="http://schemas.microsoft.com/office/drawing/2014/main" id="{7FD6C74B-E9BA-4180-AD73-8FEAC3E904F1}"/>
+                <a16:creationId xmlns:a16="http://schemas.microsoft.com/office/drawing/2014/main" id="{6734D9D4-8391-4BFA-A9D7-253C25168622}"/>
               </a:ext>
             </a:extLst>
           </p:cNvPr>
@@ -7567,7 +7567,7 @@
           <p:cNvPr id="6" name="">
             <a:extLst xmlns:a="http://schemas.openxmlformats.org/drawingml/2006/main">
               <a:ext uri="{FF2B5EF4-FFF2-40B4-BE49-F238E27FC236}">
-                <a16:creationId xmlns:a16="http://schemas.microsoft.com/office/drawing/2014/main" id="{B0E08F5C-B7BD-4DF1-B169-5BA1B4746019}"/>
+                <a16:creationId xmlns:a16="http://schemas.microsoft.com/office/drawing/2014/main" id="{746353CB-F311-4B77-950B-BF2D8B4B2337}"/>
               </a:ext>
             </a:extLst>
           </p:cNvPr>
@@ -7617,7 +7617,7 @@
           <p:cNvPr id="7" name="">
             <a:extLst xmlns:a="http://schemas.openxmlformats.org/drawingml/2006/main">
               <a:ext uri="{FF2B5EF4-FFF2-40B4-BE49-F238E27FC236}">
-                <a16:creationId xmlns:a16="http://schemas.microsoft.com/office/drawing/2014/main" id="{56837191-D0A0-4898-ABB3-A7155ED6BF68}"/>
+                <a16:creationId xmlns:a16="http://schemas.microsoft.com/office/drawing/2014/main" id="{ECFAEFDD-EE19-40A5-B523-18AF6159A624}"/>
               </a:ext>
             </a:extLst>
           </p:cNvPr>
@@ -7667,7 +7667,7 @@
           <p:cNvPr id="8" name="">
             <a:extLst xmlns:a="http://schemas.openxmlformats.org/drawingml/2006/main">
               <a:ext uri="{FF2B5EF4-FFF2-40B4-BE49-F238E27FC236}">
-                <a16:creationId xmlns:a16="http://schemas.microsoft.com/office/drawing/2014/main" id="{FC2CB8CB-FE37-42BA-AB1B-A17D4117A41F}"/>
+                <a16:creationId xmlns:a16="http://schemas.microsoft.com/office/drawing/2014/main" id="{D6569665-5D05-492B-AEE3-64798FA1944A}"/>
               </a:ext>
             </a:extLst>
           </p:cNvPr>
@@ -7717,7 +7717,7 @@
           <p:cNvPr id="9" name="">
             <a:extLst xmlns:a="http://schemas.openxmlformats.org/drawingml/2006/main">
               <a:ext uri="{FF2B5EF4-FFF2-40B4-BE49-F238E27FC236}">
-                <a16:creationId xmlns:a16="http://schemas.microsoft.com/office/drawing/2014/main" id="{2582E57E-4F5A-46FB-8176-D1F913E7D0B6}"/>
+                <a16:creationId xmlns:a16="http://schemas.microsoft.com/office/drawing/2014/main" id="{C3EE2B7B-9E8F-4445-B55A-AFA4DE5B3F06}"/>
               </a:ext>
             </a:extLst>
           </p:cNvPr>
@@ -7752,7 +7752,7 @@
           <p:cNvPr id="10" name="">
             <a:extLst xmlns:a="http://schemas.openxmlformats.org/drawingml/2006/main">
               <a:ext uri="{FF2B5EF4-FFF2-40B4-BE49-F238E27FC236}">
-                <a16:creationId xmlns:a16="http://schemas.microsoft.com/office/drawing/2014/main" id="{E085903D-4131-4733-A723-65AAA2751EC7}"/>
+                <a16:creationId xmlns:a16="http://schemas.microsoft.com/office/drawing/2014/main" id="{BEB82EEC-7A1A-486A-8B92-46EC9F0874D4}"/>
               </a:ext>
             </a:extLst>
           </p:cNvPr>
@@ -7783,7 +7783,7 @@
           <p:cNvPr id="11" name="">
             <a:extLst xmlns:a="http://schemas.openxmlformats.org/drawingml/2006/main">
               <a:ext uri="{FF2B5EF4-FFF2-40B4-BE49-F238E27FC236}">
-                <a16:creationId xmlns:a16="http://schemas.microsoft.com/office/drawing/2014/main" id="{4DEC1A37-747D-4CC9-860C-BC991EEA192A}"/>
+                <a16:creationId xmlns:a16="http://schemas.microsoft.com/office/drawing/2014/main" id="{183B95E3-E453-4295-88B0-4E974FB57773}"/>
               </a:ext>
             </a:extLst>
           </p:cNvPr>
@@ -7833,7 +7833,7 @@
           <p:cNvPr id="12" name="">
             <a:extLst xmlns:a="http://schemas.openxmlformats.org/drawingml/2006/main">
               <a:ext uri="{FF2B5EF4-FFF2-40B4-BE49-F238E27FC236}">
-                <a16:creationId xmlns:a16="http://schemas.microsoft.com/office/drawing/2014/main" id="{4C0687AD-97FD-4B06-A5AC-D61BA8F1BED2}"/>
+                <a16:creationId xmlns:a16="http://schemas.microsoft.com/office/drawing/2014/main" id="{1A202461-B507-43CC-8D66-37D7B43515D9}"/>
               </a:ext>
             </a:extLst>
           </p:cNvPr>
@@ -7883,7 +7883,7 @@
           <p:cNvPr id="13" name="">
             <a:extLst xmlns:a="http://schemas.openxmlformats.org/drawingml/2006/main">
               <a:ext uri="{FF2B5EF4-FFF2-40B4-BE49-F238E27FC236}">
-                <a16:creationId xmlns:a16="http://schemas.microsoft.com/office/drawing/2014/main" id="{E2592794-0B83-4198-9A69-BA20A85994EB}"/>
+                <a16:creationId xmlns:a16="http://schemas.microsoft.com/office/drawing/2014/main" id="{4874A441-B24F-4C28-8CA1-CD5575F47295}"/>
               </a:ext>
             </a:extLst>
           </p:cNvPr>
@@ -7933,7 +7933,7 @@
           <p:cNvPr id="14" name="">
             <a:extLst xmlns:a="http://schemas.openxmlformats.org/drawingml/2006/main">
               <a:ext uri="{FF2B5EF4-FFF2-40B4-BE49-F238E27FC236}">
-                <a16:creationId xmlns:a16="http://schemas.microsoft.com/office/drawing/2014/main" id="{7862EDFC-58AD-424C-9A45-3139C929EA85}"/>
+                <a16:creationId xmlns:a16="http://schemas.microsoft.com/office/drawing/2014/main" id="{7D0A6487-46E3-406C-889C-7F7BFAA69A7D}"/>
               </a:ext>
             </a:extLst>
           </p:cNvPr>
@@ -7968,7 +7968,7 @@
           <p:cNvPr id="15" name="">
             <a:extLst xmlns:a="http://schemas.openxmlformats.org/drawingml/2006/main">
               <a:ext uri="{FF2B5EF4-FFF2-40B4-BE49-F238E27FC236}">
-                <a16:creationId xmlns:a16="http://schemas.microsoft.com/office/drawing/2014/main" id="{8C04B39F-82DD-4D33-8754-77A855961F04}"/>
+                <a16:creationId xmlns:a16="http://schemas.microsoft.com/office/drawing/2014/main" id="{B4A6DBE8-2FBE-48DF-B7AF-7C8D341B64C8}"/>
               </a:ext>
             </a:extLst>
           </p:cNvPr>
@@ -7999,7 +7999,7 @@
           <p:cNvPr id="16" name="">
             <a:extLst xmlns:a="http://schemas.openxmlformats.org/drawingml/2006/main">
               <a:ext uri="{FF2B5EF4-FFF2-40B4-BE49-F238E27FC236}">
-                <a16:creationId xmlns:a16="http://schemas.microsoft.com/office/drawing/2014/main" id="{26D82E97-FE7B-4CB8-8D31-D54A2869F617}"/>
+                <a16:creationId xmlns:a16="http://schemas.microsoft.com/office/drawing/2014/main" id="{9799087B-BB19-414F-A918-C564CCFE4D7E}"/>
               </a:ext>
             </a:extLst>
           </p:cNvPr>
@@ -8049,7 +8049,7 @@
           <p:cNvPr id="17" name="">
             <a:extLst xmlns:a="http://schemas.openxmlformats.org/drawingml/2006/main">
               <a:ext uri="{FF2B5EF4-FFF2-40B4-BE49-F238E27FC236}">
-                <a16:creationId xmlns:a16="http://schemas.microsoft.com/office/drawing/2014/main" id="{DAF86315-F5B9-4376-9F6F-93262FBDC0E5}"/>
+                <a16:creationId xmlns:a16="http://schemas.microsoft.com/office/drawing/2014/main" id="{721DED72-E84C-427E-BF7C-E048CD64FA0A}"/>
               </a:ext>
             </a:extLst>
           </p:cNvPr>
@@ -8099,7 +8099,7 @@
           <p:cNvPr id="18" name="">
             <a:extLst xmlns:a="http://schemas.openxmlformats.org/drawingml/2006/main">
               <a:ext uri="{FF2B5EF4-FFF2-40B4-BE49-F238E27FC236}">
-                <a16:creationId xmlns:a16="http://schemas.microsoft.com/office/drawing/2014/main" id="{671CA503-190C-41C2-BBB8-EF54020A1018}"/>
+                <a16:creationId xmlns:a16="http://schemas.microsoft.com/office/drawing/2014/main" id="{3D4BD865-CE86-43BA-A59B-439BF3D3759F}"/>
               </a:ext>
             </a:extLst>
           </p:cNvPr>
@@ -8149,7 +8149,7 @@
           <p:cNvPr id="19" name="">
             <a:extLst xmlns:a="http://schemas.openxmlformats.org/drawingml/2006/main">
               <a:ext uri="{FF2B5EF4-FFF2-40B4-BE49-F238E27FC236}">
-                <a16:creationId xmlns:a16="http://schemas.microsoft.com/office/drawing/2014/main" id="{CAD37948-B5F8-49F9-B9EE-BA04634B7D7F}"/>
+                <a16:creationId xmlns:a16="http://schemas.microsoft.com/office/drawing/2014/main" id="{E47F007D-7083-4B14-92FA-DEFF8ADFCA8C}"/>
               </a:ext>
             </a:extLst>
           </p:cNvPr>
@@ -8182,7 +8182,7 @@
           <p:cNvPr id="20" name="">
             <a:extLst xmlns:a="http://schemas.openxmlformats.org/drawingml/2006/main">
               <a:ext uri="{FF2B5EF4-FFF2-40B4-BE49-F238E27FC236}">
-                <a16:creationId xmlns:a16="http://schemas.microsoft.com/office/drawing/2014/main" id="{3C9A8569-C9F5-48D5-8D2C-E4EAC9F8DADD}"/>
+                <a16:creationId xmlns:a16="http://schemas.microsoft.com/office/drawing/2014/main" id="{29F0A367-1327-4F41-842D-76C60D31158C}"/>
               </a:ext>
             </a:extLst>
           </p:cNvPr>
@@ -8232,7 +8232,7 @@
           <p:cNvPr id="21" name="">
             <a:extLst xmlns:a="http://schemas.openxmlformats.org/drawingml/2006/main">
               <a:ext uri="{FF2B5EF4-FFF2-40B4-BE49-F238E27FC236}">
-                <a16:creationId xmlns:a16="http://schemas.microsoft.com/office/drawing/2014/main" id="{4899B7B3-0696-4B97-9EE7-CA0DB86C7EB5}"/>
+                <a16:creationId xmlns:a16="http://schemas.microsoft.com/office/drawing/2014/main" id="{032298FE-24A8-4C63-8DB9-6009E98616F2}"/>
               </a:ext>
             </a:extLst>
           </p:cNvPr>
@@ -8270,7 +8270,7 @@
           <p:cNvPr id="22" name="">
             <a:extLst xmlns:a="http://schemas.openxmlformats.org/drawingml/2006/main">
               <a:ext uri="{FF2B5EF4-FFF2-40B4-BE49-F238E27FC236}">
-                <a16:creationId xmlns:a16="http://schemas.microsoft.com/office/drawing/2014/main" id="{75C1FF9A-8C78-4624-AC87-6FA5C6314EC9}"/>
+                <a16:creationId xmlns:a16="http://schemas.microsoft.com/office/drawing/2014/main" id="{9DFB01D4-B812-4CFA-98A9-290642F66CCA}"/>
               </a:ext>
             </a:extLst>
           </p:cNvPr>
@@ -8318,7 +8318,7 @@
     </p:spTree>
     <p:extLst>
       <p:ext uri="{BB962C8B-B14F-4D97-AF65-F5344CB8AC3E}">
-        <p14:creationId xmlns:p14="http://schemas.microsoft.com/office/powerpoint/2010/main" val="887203988"/>
+        <p14:creationId xmlns:p14="http://schemas.microsoft.com/office/powerpoint/2010/main" val="1753040877"/>
       </p:ext>
     </p:extLst>
   </p:cSld>
@@ -8349,7 +8349,7 @@
           <p:cNvPr id="1" name="">
             <a:extLst xmlns:a="http://schemas.openxmlformats.org/drawingml/2006/main">
               <a:ext uri="{FF2B5EF4-FFF2-40B4-BE49-F238E27FC236}">
-                <a16:creationId xmlns:a16="http://schemas.microsoft.com/office/drawing/2014/main" id="{E00E07CD-A1C8-4029-8C77-01318F2B8747}"/>
+                <a16:creationId xmlns:a16="http://schemas.microsoft.com/office/drawing/2014/main" id="{A91AA007-2EA8-4069-B409-1CA2AF93B204}"/>
               </a:ext>
             </a:extLst>
           </p:cNvPr>
@@ -8399,7 +8399,7 @@
           <p:cNvPr id="2" name="">
             <a:extLst xmlns:a="http://schemas.openxmlformats.org/drawingml/2006/main">
               <a:ext uri="{FF2B5EF4-FFF2-40B4-BE49-F238E27FC236}">
-                <a16:creationId xmlns:a16="http://schemas.microsoft.com/office/drawing/2014/main" id="{734F0163-B2E9-4AF1-86F5-C56AC47697D3}"/>
+                <a16:creationId xmlns:a16="http://schemas.microsoft.com/office/drawing/2014/main" id="{A3CDD0B6-7C46-4197-A267-54EE96473F1B}"/>
               </a:ext>
             </a:extLst>
           </p:cNvPr>
@@ -8449,7 +8449,7 @@
           <p:cNvPr id="3" name="">
             <a:extLst xmlns:a="http://schemas.openxmlformats.org/drawingml/2006/main">
               <a:ext uri="{FF2B5EF4-FFF2-40B4-BE49-F238E27FC236}">
-                <a16:creationId xmlns:a16="http://schemas.microsoft.com/office/drawing/2014/main" id="{FC575C50-FA35-4CF0-AB82-7ADB9FAA28D5}"/>
+                <a16:creationId xmlns:a16="http://schemas.microsoft.com/office/drawing/2014/main" id="{A63C259C-F419-45E2-A1E3-3DD41D58F508}"/>
               </a:ext>
             </a:extLst>
           </p:cNvPr>
@@ -8499,7 +8499,7 @@
           <p:cNvPr id="4" name="">
             <a:extLst xmlns:a="http://schemas.openxmlformats.org/drawingml/2006/main">
               <a:ext uri="{FF2B5EF4-FFF2-40B4-BE49-F238E27FC236}">
-                <a16:creationId xmlns:a16="http://schemas.microsoft.com/office/drawing/2014/main" id="{EAD8F571-723B-4B86-955B-31EB31324FC1}"/>
+                <a16:creationId xmlns:a16="http://schemas.microsoft.com/office/drawing/2014/main" id="{3B8DB9FC-EF1B-4C4A-842D-082B011CED56}"/>
               </a:ext>
             </a:extLst>
           </p:cNvPr>
@@ -8534,7 +8534,7 @@
           <p:cNvPr id="5" name="">
             <a:extLst xmlns:a="http://schemas.openxmlformats.org/drawingml/2006/main">
               <a:ext uri="{FF2B5EF4-FFF2-40B4-BE49-F238E27FC236}">
-                <a16:creationId xmlns:a16="http://schemas.microsoft.com/office/drawing/2014/main" id="{886C5256-CE02-41D5-B8A6-AF8BF6FACF8F}"/>
+                <a16:creationId xmlns:a16="http://schemas.microsoft.com/office/drawing/2014/main" id="{72A08460-8E8E-4F1B-9987-35C66644163E}"/>
               </a:ext>
             </a:extLst>
           </p:cNvPr>
@@ -8584,7 +8584,7 @@
           <p:cNvPr id="6" name="">
             <a:extLst xmlns:a="http://schemas.openxmlformats.org/drawingml/2006/main">
               <a:ext uri="{FF2B5EF4-FFF2-40B4-BE49-F238E27FC236}">
-                <a16:creationId xmlns:a16="http://schemas.microsoft.com/office/drawing/2014/main" id="{1163990A-4672-45D2-894D-D6E6CAEBDEDE}"/>
+                <a16:creationId xmlns:a16="http://schemas.microsoft.com/office/drawing/2014/main" id="{CD86F95C-7903-4FB3-8889-D4C4D0D113FA}"/>
               </a:ext>
             </a:extLst>
           </p:cNvPr>
@@ -8634,7 +8634,7 @@
           <p:cNvPr id="7" name="">
             <a:extLst xmlns:a="http://schemas.openxmlformats.org/drawingml/2006/main">
               <a:ext uri="{FF2B5EF4-FFF2-40B4-BE49-F238E27FC236}">
-                <a16:creationId xmlns:a16="http://schemas.microsoft.com/office/drawing/2014/main" id="{5758E03D-0AD9-4920-B409-D9B558D75612}"/>
+                <a16:creationId xmlns:a16="http://schemas.microsoft.com/office/drawing/2014/main" id="{1E92202D-3823-4D30-94CE-0CC6006081A3}"/>
               </a:ext>
             </a:extLst>
           </p:cNvPr>
@@ -8684,7 +8684,7 @@
           <p:cNvPr id="8" name="">
             <a:extLst xmlns:a="http://schemas.openxmlformats.org/drawingml/2006/main">
               <a:ext uri="{FF2B5EF4-FFF2-40B4-BE49-F238E27FC236}">
-                <a16:creationId xmlns:a16="http://schemas.microsoft.com/office/drawing/2014/main" id="{550D6DA7-A2C2-4FAF-8DAB-E7C6839F4CE9}"/>
+                <a16:creationId xmlns:a16="http://schemas.microsoft.com/office/drawing/2014/main" id="{CA536661-232E-48D1-ACF9-60F3FA74C0AB}"/>
               </a:ext>
             </a:extLst>
           </p:cNvPr>
@@ -8719,7 +8719,7 @@
           <p:cNvPr id="9" name="">
             <a:extLst xmlns:a="http://schemas.openxmlformats.org/drawingml/2006/main">
               <a:ext uri="{FF2B5EF4-FFF2-40B4-BE49-F238E27FC236}">
-                <a16:creationId xmlns:a16="http://schemas.microsoft.com/office/drawing/2014/main" id="{9C6414AA-E0F8-4B2C-905D-460519FD6F8B}"/>
+                <a16:creationId xmlns:a16="http://schemas.microsoft.com/office/drawing/2014/main" id="{3C82B272-10CE-4215-819F-F6EEEC478CA5}"/>
               </a:ext>
             </a:extLst>
           </p:cNvPr>
@@ -8769,7 +8769,7 @@
           <p:cNvPr id="10" name="">
             <a:extLst xmlns:a="http://schemas.openxmlformats.org/drawingml/2006/main">
               <a:ext uri="{FF2B5EF4-FFF2-40B4-BE49-F238E27FC236}">
-                <a16:creationId xmlns:a16="http://schemas.microsoft.com/office/drawing/2014/main" id="{5DC7647D-E162-4E11-9DE2-975665EEFFC0}"/>
+                <a16:creationId xmlns:a16="http://schemas.microsoft.com/office/drawing/2014/main" id="{3E2204D8-0A35-48E0-9852-AB83A6FD8F55}"/>
               </a:ext>
             </a:extLst>
           </p:cNvPr>
@@ -8819,7 +8819,7 @@
           <p:cNvPr id="11" name="">
             <a:extLst xmlns:a="http://schemas.openxmlformats.org/drawingml/2006/main">
               <a:ext uri="{FF2B5EF4-FFF2-40B4-BE49-F238E27FC236}">
-                <a16:creationId xmlns:a16="http://schemas.microsoft.com/office/drawing/2014/main" id="{276E584A-C74E-43D2-9F94-0EFD538B093B}"/>
+                <a16:creationId xmlns:a16="http://schemas.microsoft.com/office/drawing/2014/main" id="{0C8FF100-D720-4FB1-9FB0-99F06D6D0D1C}"/>
               </a:ext>
             </a:extLst>
           </p:cNvPr>
@@ -8869,7 +8869,7 @@
           <p:cNvPr id="12" name="">
             <a:extLst xmlns:a="http://schemas.openxmlformats.org/drawingml/2006/main">
               <a:ext uri="{FF2B5EF4-FFF2-40B4-BE49-F238E27FC236}">
-                <a16:creationId xmlns:a16="http://schemas.microsoft.com/office/drawing/2014/main" id="{3A8E19F4-09E0-4EA9-BD30-82C0FB7CA8A3}"/>
+                <a16:creationId xmlns:a16="http://schemas.microsoft.com/office/drawing/2014/main" id="{D3B52656-1C5E-426C-B1D6-97DB8541052B}"/>
               </a:ext>
             </a:extLst>
           </p:cNvPr>
@@ -8904,7 +8904,7 @@
           <p:cNvPr id="13" name="">
             <a:extLst xmlns:a="http://schemas.openxmlformats.org/drawingml/2006/main">
               <a:ext uri="{FF2B5EF4-FFF2-40B4-BE49-F238E27FC236}">
-                <a16:creationId xmlns:a16="http://schemas.microsoft.com/office/drawing/2014/main" id="{5FEC8311-1F59-4293-B398-0D6DB7A38B40}"/>
+                <a16:creationId xmlns:a16="http://schemas.microsoft.com/office/drawing/2014/main" id="{56F4DCE2-7565-4631-A7AF-16EF01F0470E}"/>
               </a:ext>
             </a:extLst>
           </p:cNvPr>
@@ -8954,7 +8954,7 @@
           <p:cNvPr id="14" name="">
             <a:extLst xmlns:a="http://schemas.openxmlformats.org/drawingml/2006/main">
               <a:ext uri="{FF2B5EF4-FFF2-40B4-BE49-F238E27FC236}">
-                <a16:creationId xmlns:a16="http://schemas.microsoft.com/office/drawing/2014/main" id="{6B35ADFE-0A0A-4A64-9E54-39AC94F698F8}"/>
+                <a16:creationId xmlns:a16="http://schemas.microsoft.com/office/drawing/2014/main" id="{89E8726E-31A3-49E6-8724-87967F73D1EB}"/>
               </a:ext>
             </a:extLst>
           </p:cNvPr>
@@ -9004,7 +9004,7 @@
           <p:cNvPr id="15" name="">
             <a:extLst xmlns:a="http://schemas.openxmlformats.org/drawingml/2006/main">
               <a:ext uri="{FF2B5EF4-FFF2-40B4-BE49-F238E27FC236}">
-                <a16:creationId xmlns:a16="http://schemas.microsoft.com/office/drawing/2014/main" id="{092C30F8-65CF-4FE1-96FF-E299921186A4}"/>
+                <a16:creationId xmlns:a16="http://schemas.microsoft.com/office/drawing/2014/main" id="{5EDB7206-F32E-4C8F-BDC2-4AC6AD887099}"/>
               </a:ext>
             </a:extLst>
           </p:cNvPr>
@@ -9054,7 +9054,7 @@
           <p:cNvPr id="16" name="">
             <a:extLst xmlns:a="http://schemas.openxmlformats.org/drawingml/2006/main">
               <a:ext uri="{FF2B5EF4-FFF2-40B4-BE49-F238E27FC236}">
-                <a16:creationId xmlns:a16="http://schemas.microsoft.com/office/drawing/2014/main" id="{EDBE6C07-300C-4C65-BD5C-878997C11631}"/>
+                <a16:creationId xmlns:a16="http://schemas.microsoft.com/office/drawing/2014/main" id="{4315385C-0DD7-45E7-A49E-EE1A279F65E2}"/>
               </a:ext>
             </a:extLst>
           </p:cNvPr>
@@ -9089,7 +9089,7 @@
           <p:cNvPr id="17" name="">
             <a:extLst xmlns:a="http://schemas.openxmlformats.org/drawingml/2006/main">
               <a:ext uri="{FF2B5EF4-FFF2-40B4-BE49-F238E27FC236}">
-                <a16:creationId xmlns:a16="http://schemas.microsoft.com/office/drawing/2014/main" id="{2776274C-EDE1-42A4-87E4-34CB18F51FE8}"/>
+                <a16:creationId xmlns:a16="http://schemas.microsoft.com/office/drawing/2014/main" id="{C3EB9CDC-3DA8-480F-8ADB-307B6F0FEA37}"/>
               </a:ext>
             </a:extLst>
           </p:cNvPr>
@@ -9139,7 +9139,7 @@
           <p:cNvPr id="18" name="">
             <a:extLst xmlns:a="http://schemas.openxmlformats.org/drawingml/2006/main">
               <a:ext uri="{FF2B5EF4-FFF2-40B4-BE49-F238E27FC236}">
-                <a16:creationId xmlns:a16="http://schemas.microsoft.com/office/drawing/2014/main" id="{04873AE2-402F-45C9-9C9E-0FC3D60155A1}"/>
+                <a16:creationId xmlns:a16="http://schemas.microsoft.com/office/drawing/2014/main" id="{EE989C42-E76F-4928-BD97-8E182B269D73}"/>
               </a:ext>
             </a:extLst>
           </p:cNvPr>
@@ -9189,7 +9189,7 @@
           <p:cNvPr id="19" name="">
             <a:extLst xmlns:a="http://schemas.openxmlformats.org/drawingml/2006/main">
               <a:ext uri="{FF2B5EF4-FFF2-40B4-BE49-F238E27FC236}">
-                <a16:creationId xmlns:a16="http://schemas.microsoft.com/office/drawing/2014/main" id="{67B8BF03-C80B-4AF5-8BEE-24BBD5936868}"/>
+                <a16:creationId xmlns:a16="http://schemas.microsoft.com/office/drawing/2014/main" id="{578C5542-F240-4F29-BB3E-49A8BAEA3A95}"/>
               </a:ext>
             </a:extLst>
           </p:cNvPr>
@@ -9222,7 +9222,7 @@
           <p:cNvPr id="20" name="">
             <a:extLst xmlns:a="http://schemas.openxmlformats.org/drawingml/2006/main">
               <a:ext uri="{FF2B5EF4-FFF2-40B4-BE49-F238E27FC236}">
-                <a16:creationId xmlns:a16="http://schemas.microsoft.com/office/drawing/2014/main" id="{5C5D30D7-90FA-4BC3-8EF8-B98FF34979E4}"/>
+                <a16:creationId xmlns:a16="http://schemas.microsoft.com/office/drawing/2014/main" id="{9E0549DE-D8D9-4ADF-AB21-E3ED6BC502A1}"/>
               </a:ext>
             </a:extLst>
           </p:cNvPr>
@@ -9272,7 +9272,7 @@
           <p:cNvPr id="21" name="">
             <a:extLst xmlns:a="http://schemas.openxmlformats.org/drawingml/2006/main">
               <a:ext uri="{FF2B5EF4-FFF2-40B4-BE49-F238E27FC236}">
-                <a16:creationId xmlns:a16="http://schemas.microsoft.com/office/drawing/2014/main" id="{F090EF52-A418-4188-9D01-FE092A8B9C99}"/>
+                <a16:creationId xmlns:a16="http://schemas.microsoft.com/office/drawing/2014/main" id="{D910276C-8341-427C-9340-4207CFFA6D29}"/>
               </a:ext>
             </a:extLst>
           </p:cNvPr>
@@ -9310,7 +9310,7 @@
           <p:cNvPr id="22" name="">
             <a:extLst xmlns:a="http://schemas.openxmlformats.org/drawingml/2006/main">
               <a:ext uri="{FF2B5EF4-FFF2-40B4-BE49-F238E27FC236}">
-                <a16:creationId xmlns:a16="http://schemas.microsoft.com/office/drawing/2014/main" id="{B532F525-CD17-4213-8989-263077CBFAEC}"/>
+                <a16:creationId xmlns:a16="http://schemas.microsoft.com/office/drawing/2014/main" id="{4D240BE4-9131-4EBC-837D-2501F2FD927A}"/>
               </a:ext>
             </a:extLst>
           </p:cNvPr>
@@ -9358,7 +9358,7 @@
     </p:spTree>
     <p:extLst>
       <p:ext uri="{BB962C8B-B14F-4D97-AF65-F5344CB8AC3E}">
-        <p14:creationId xmlns:p14="http://schemas.microsoft.com/office/powerpoint/2010/main" val="1132919961"/>
+        <p14:creationId xmlns:p14="http://schemas.microsoft.com/office/powerpoint/2010/main" val="1840890973"/>
       </p:ext>
     </p:extLst>
   </p:cSld>
@@ -9389,7 +9389,7 @@
           <p:cNvPr id="1" name="">
             <a:extLst xmlns:a="http://schemas.openxmlformats.org/drawingml/2006/main">
               <a:ext uri="{FF2B5EF4-FFF2-40B4-BE49-F238E27FC236}">
-                <a16:creationId xmlns:a16="http://schemas.microsoft.com/office/drawing/2014/main" id="{807784DA-99FA-45A9-9C38-49171BD04434}"/>
+                <a16:creationId xmlns:a16="http://schemas.microsoft.com/office/drawing/2014/main" id="{D9A9852F-1DCD-4E12-90D5-4C8216E74A7C}"/>
               </a:ext>
             </a:extLst>
           </p:cNvPr>
@@ -9439,7 +9439,7 @@
           <p:cNvPr id="2" name="">
             <a:extLst xmlns:a="http://schemas.openxmlformats.org/drawingml/2006/main">
               <a:ext uri="{FF2B5EF4-FFF2-40B4-BE49-F238E27FC236}">
-                <a16:creationId xmlns:a16="http://schemas.microsoft.com/office/drawing/2014/main" id="{0185A7EB-3BE5-4399-B9A1-24538EF5A959}"/>
+                <a16:creationId xmlns:a16="http://schemas.microsoft.com/office/drawing/2014/main" id="{AA2A9FFE-0BA1-4431-B0D9-C2CCA75F1D1C}"/>
               </a:ext>
             </a:extLst>
           </p:cNvPr>
@@ -9489,7 +9489,7 @@
           <p:cNvPr id="3" name="">
             <a:extLst xmlns:a="http://schemas.openxmlformats.org/drawingml/2006/main">
               <a:ext uri="{FF2B5EF4-FFF2-40B4-BE49-F238E27FC236}">
-                <a16:creationId xmlns:a16="http://schemas.microsoft.com/office/drawing/2014/main" id="{8D4B0371-9352-4D76-82E7-FA4FDE1D555B}"/>
+                <a16:creationId xmlns:a16="http://schemas.microsoft.com/office/drawing/2014/main" id="{EA2E7DAB-82B1-4B1B-9E7A-3D088CC8DB7F}"/>
               </a:ext>
             </a:extLst>
           </p:cNvPr>
@@ -9543,7 +9543,7 @@
           <p:nvPr/>
         </p:nvPicPr>
         <p:blipFill>
-          <a:blip xmlns:r="http://schemas.openxmlformats.org/officeDocument/2006/relationships" xmlns:a="http://schemas.openxmlformats.org/drawingml/2006/main" r:embed="Ref6523f53b274b68"/>
+          <a:blip xmlns:r="http://schemas.openxmlformats.org/officeDocument/2006/relationships" xmlns:a="http://schemas.openxmlformats.org/drawingml/2006/main" r:embed="Rb60918fe6add43ec"/>
           <a:srcRect xmlns:a="http://schemas.openxmlformats.org/drawingml/2006/main" l="0" t="4875" r="0" b="4875"/>
           <a:stretch xmlns:a="http://schemas.openxmlformats.org/drawingml/2006/main">
             <a:fillRect l="0" t="0" r="0" b="0"/>
@@ -9566,7 +9566,7 @@
           <p:cNvPr id="5" name="">
             <a:extLst xmlns:a="http://schemas.openxmlformats.org/drawingml/2006/main">
               <a:ext uri="{FF2B5EF4-FFF2-40B4-BE49-F238E27FC236}">
-                <a16:creationId xmlns:a16="http://schemas.microsoft.com/office/drawing/2014/main" id="{53E6586D-D5E1-4AE3-9117-F447AB5916B2}"/>
+                <a16:creationId xmlns:a16="http://schemas.microsoft.com/office/drawing/2014/main" id="{96E84902-7687-4197-B0C7-750BF1E77637}"/>
               </a:ext>
             </a:extLst>
           </p:cNvPr>
@@ -9599,7 +9599,7 @@
           <p:cNvPr id="6" name="">
             <a:extLst xmlns:a="http://schemas.openxmlformats.org/drawingml/2006/main">
               <a:ext uri="{FF2B5EF4-FFF2-40B4-BE49-F238E27FC236}">
-                <a16:creationId xmlns:a16="http://schemas.microsoft.com/office/drawing/2014/main" id="{1D3FEE35-88B1-43D0-B397-82BF7DC38D80}"/>
+                <a16:creationId xmlns:a16="http://schemas.microsoft.com/office/drawing/2014/main" id="{B039CF91-2E91-4956-8784-6D33318674C3}"/>
               </a:ext>
             </a:extLst>
           </p:cNvPr>
@@ -9630,7 +9630,7 @@
           <p:cNvPr id="7" name="">
             <a:extLst xmlns:a="http://schemas.openxmlformats.org/drawingml/2006/main">
               <a:ext uri="{FF2B5EF4-FFF2-40B4-BE49-F238E27FC236}">
-                <a16:creationId xmlns:a16="http://schemas.microsoft.com/office/drawing/2014/main" id="{ECF8F987-159D-473C-91C1-EFD07DF031C7}"/>
+                <a16:creationId xmlns:a16="http://schemas.microsoft.com/office/drawing/2014/main" id="{D8F6F90E-3B3C-472E-B966-27C5EEF94D5A}"/>
               </a:ext>
             </a:extLst>
           </p:cNvPr>
@@ -9680,7 +9680,7 @@
           <p:cNvPr id="8" name="">
             <a:extLst xmlns:a="http://schemas.openxmlformats.org/drawingml/2006/main">
               <a:ext uri="{FF2B5EF4-FFF2-40B4-BE49-F238E27FC236}">
-                <a16:creationId xmlns:a16="http://schemas.microsoft.com/office/drawing/2014/main" id="{B22254ED-53E9-441F-9687-D1950B22A2C3}"/>
+                <a16:creationId xmlns:a16="http://schemas.microsoft.com/office/drawing/2014/main" id="{0967410E-2085-49C8-B518-C554FEEBD9DE}"/>
               </a:ext>
             </a:extLst>
           </p:cNvPr>
@@ -9711,7 +9711,7 @@
           <p:cNvPr id="9" name="">
             <a:extLst xmlns:a="http://schemas.openxmlformats.org/drawingml/2006/main">
               <a:ext uri="{FF2B5EF4-FFF2-40B4-BE49-F238E27FC236}">
-                <a16:creationId xmlns:a16="http://schemas.microsoft.com/office/drawing/2014/main" id="{5733CE0D-3A50-4BEB-9DFD-B65AB59EAA35}"/>
+                <a16:creationId xmlns:a16="http://schemas.microsoft.com/office/drawing/2014/main" id="{67F1802E-6A77-4246-B6BC-496C0C9B37CF}"/>
               </a:ext>
             </a:extLst>
           </p:cNvPr>
@@ -9761,7 +9761,7 @@
           <p:cNvPr id="10" name="">
             <a:extLst xmlns:a="http://schemas.openxmlformats.org/drawingml/2006/main">
               <a:ext uri="{FF2B5EF4-FFF2-40B4-BE49-F238E27FC236}">
-                <a16:creationId xmlns:a16="http://schemas.microsoft.com/office/drawing/2014/main" id="{9B00CB18-351F-4315-97B5-534AAD8E716E}"/>
+                <a16:creationId xmlns:a16="http://schemas.microsoft.com/office/drawing/2014/main" id="{E4000C10-9CB4-4838-B654-4C75BAA47038}"/>
               </a:ext>
             </a:extLst>
           </p:cNvPr>
@@ -9792,7 +9792,7 @@
           <p:cNvPr id="11" name="">
             <a:extLst xmlns:a="http://schemas.openxmlformats.org/drawingml/2006/main">
               <a:ext uri="{FF2B5EF4-FFF2-40B4-BE49-F238E27FC236}">
-                <a16:creationId xmlns:a16="http://schemas.microsoft.com/office/drawing/2014/main" id="{C87E10F9-6F5B-4462-874A-AE601764B0B3}"/>
+                <a16:creationId xmlns:a16="http://schemas.microsoft.com/office/drawing/2014/main" id="{8149F6E4-1C35-443C-B3E6-DF64175988BE}"/>
               </a:ext>
             </a:extLst>
           </p:cNvPr>
@@ -9842,7 +9842,7 @@
           <p:cNvPr id="12" name="">
             <a:extLst xmlns:a="http://schemas.openxmlformats.org/drawingml/2006/main">
               <a:ext uri="{FF2B5EF4-FFF2-40B4-BE49-F238E27FC236}">
-                <a16:creationId xmlns:a16="http://schemas.microsoft.com/office/drawing/2014/main" id="{867C611A-9927-4CEE-8131-73341343C1D6}"/>
+                <a16:creationId xmlns:a16="http://schemas.microsoft.com/office/drawing/2014/main" id="{DF5696A6-2645-47D1-88B9-382C02D42886}"/>
               </a:ext>
             </a:extLst>
           </p:cNvPr>
@@ -9873,7 +9873,7 @@
           <p:cNvPr id="13" name="">
             <a:extLst xmlns:a="http://schemas.openxmlformats.org/drawingml/2006/main">
               <a:ext uri="{FF2B5EF4-FFF2-40B4-BE49-F238E27FC236}">
-                <a16:creationId xmlns:a16="http://schemas.microsoft.com/office/drawing/2014/main" id="{FBAAC7B6-FFB0-45D5-8EE9-300A3288CB8F}"/>
+                <a16:creationId xmlns:a16="http://schemas.microsoft.com/office/drawing/2014/main" id="{219ED700-2474-46FA-A153-B682871F2FBA}"/>
               </a:ext>
             </a:extLst>
           </p:cNvPr>
@@ -9923,7 +9923,7 @@
           <p:cNvPr id="14" name="">
             <a:extLst xmlns:a="http://schemas.openxmlformats.org/drawingml/2006/main">
               <a:ext uri="{FF2B5EF4-FFF2-40B4-BE49-F238E27FC236}">
-                <a16:creationId xmlns:a16="http://schemas.microsoft.com/office/drawing/2014/main" id="{B822F2AE-1E6F-48E6-99B4-CB73F7BA0207}"/>
+                <a16:creationId xmlns:a16="http://schemas.microsoft.com/office/drawing/2014/main" id="{56293E46-DF0E-4E00-A885-407DFB24B6D6}"/>
               </a:ext>
             </a:extLst>
           </p:cNvPr>
@@ -9973,7 +9973,7 @@
           <p:cNvPr id="15" name="">
             <a:extLst xmlns:a="http://schemas.openxmlformats.org/drawingml/2006/main">
               <a:ext uri="{FF2B5EF4-FFF2-40B4-BE49-F238E27FC236}">
-                <a16:creationId xmlns:a16="http://schemas.microsoft.com/office/drawing/2014/main" id="{533B4A78-177F-47CA-B595-B47997CC1D82}"/>
+                <a16:creationId xmlns:a16="http://schemas.microsoft.com/office/drawing/2014/main" id="{1EA5668F-DAD1-46E4-8628-25D2444EED8D}"/>
               </a:ext>
             </a:extLst>
           </p:cNvPr>
@@ -10021,7 +10021,7 @@
     </p:spTree>
     <p:extLst>
       <p:ext uri="{BB962C8B-B14F-4D97-AF65-F5344CB8AC3E}">
-        <p14:creationId xmlns:p14="http://schemas.microsoft.com/office/powerpoint/2010/main" val="1263290743"/>
+        <p14:creationId xmlns:p14="http://schemas.microsoft.com/office/powerpoint/2010/main" val="160070424"/>
       </p:ext>
     </p:extLst>
   </p:cSld>
@@ -10052,7 +10052,7 @@
           <p:cNvPr id="1" name="">
             <a:extLst xmlns:a="http://schemas.openxmlformats.org/drawingml/2006/main">
               <a:ext uri="{FF2B5EF4-FFF2-40B4-BE49-F238E27FC236}">
-                <a16:creationId xmlns:a16="http://schemas.microsoft.com/office/drawing/2014/main" id="{E6CBA96E-CCCC-4009-B82A-489C2C8C9A22}"/>
+                <a16:creationId xmlns:a16="http://schemas.microsoft.com/office/drawing/2014/main" id="{A9EB631F-9D79-4379-8579-01E20A6A8EA3}"/>
               </a:ext>
             </a:extLst>
           </p:cNvPr>
@@ -10102,7 +10102,7 @@
           <p:cNvPr id="2" name="">
             <a:extLst xmlns:a="http://schemas.openxmlformats.org/drawingml/2006/main">
               <a:ext uri="{FF2B5EF4-FFF2-40B4-BE49-F238E27FC236}">
-                <a16:creationId xmlns:a16="http://schemas.microsoft.com/office/drawing/2014/main" id="{FA64ABD2-2710-4190-9D1C-C54910CB76BE}"/>
+                <a16:creationId xmlns:a16="http://schemas.microsoft.com/office/drawing/2014/main" id="{D900FCAD-DA17-4CF4-9DB4-17D328768F2D}"/>
               </a:ext>
             </a:extLst>
           </p:cNvPr>
@@ -10152,7 +10152,7 @@
           <p:cNvPr id="3" name="">
             <a:extLst xmlns:a="http://schemas.openxmlformats.org/drawingml/2006/main">
               <a:ext uri="{FF2B5EF4-FFF2-40B4-BE49-F238E27FC236}">
-                <a16:creationId xmlns:a16="http://schemas.microsoft.com/office/drawing/2014/main" id="{CF07684D-2F00-4853-83FB-A1A262316503}"/>
+                <a16:creationId xmlns:a16="http://schemas.microsoft.com/office/drawing/2014/main" id="{F0DC1221-7DE8-470C-AC70-F82E02453406}"/>
               </a:ext>
             </a:extLst>
           </p:cNvPr>
@@ -10202,7 +10202,7 @@
           <p:cNvPr id="4" name="">
             <a:extLst xmlns:a="http://schemas.openxmlformats.org/drawingml/2006/main">
               <a:ext uri="{FF2B5EF4-FFF2-40B4-BE49-F238E27FC236}">
-                <a16:creationId xmlns:a16="http://schemas.microsoft.com/office/drawing/2014/main" id="{B4C00A21-6D3E-4A34-A6E3-8DAF9B088A82}"/>
+                <a16:creationId xmlns:a16="http://schemas.microsoft.com/office/drawing/2014/main" id="{ECA9B67F-BBBA-4AEF-A87D-E05378AF85CA}"/>
               </a:ext>
             </a:extLst>
           </p:cNvPr>
@@ -10252,7 +10252,7 @@
           <p:cNvPr id="5" name="">
             <a:extLst xmlns:a="http://schemas.openxmlformats.org/drawingml/2006/main">
               <a:ext uri="{FF2B5EF4-FFF2-40B4-BE49-F238E27FC236}">
-                <a16:creationId xmlns:a16="http://schemas.microsoft.com/office/drawing/2014/main" id="{44552212-E055-45EE-AD34-211214B7DC0B}"/>
+                <a16:creationId xmlns:a16="http://schemas.microsoft.com/office/drawing/2014/main" id="{D89588CF-9A04-43C2-9008-9D177BAF76AF}"/>
               </a:ext>
             </a:extLst>
           </p:cNvPr>
@@ -10302,7 +10302,7 @@
           <p:cNvPr id="6" name="">
             <a:extLst xmlns:a="http://schemas.openxmlformats.org/drawingml/2006/main">
               <a:ext uri="{FF2B5EF4-FFF2-40B4-BE49-F238E27FC236}">
-                <a16:creationId xmlns:a16="http://schemas.microsoft.com/office/drawing/2014/main" id="{1D0BD069-583B-4D77-A13C-14CCCD72B516}"/>
+                <a16:creationId xmlns:a16="http://schemas.microsoft.com/office/drawing/2014/main" id="{973AD0F0-323F-4187-AB12-F3165ACEC633}"/>
               </a:ext>
             </a:extLst>
           </p:cNvPr>
@@ -10352,7 +10352,7 @@
           <p:cNvPr id="7" name="">
             <a:extLst xmlns:a="http://schemas.openxmlformats.org/drawingml/2006/main">
               <a:ext uri="{FF2B5EF4-FFF2-40B4-BE49-F238E27FC236}">
-                <a16:creationId xmlns:a16="http://schemas.microsoft.com/office/drawing/2014/main" id="{BC142DB3-E184-4D79-9834-E7A05B3E0B3A}"/>
+                <a16:creationId xmlns:a16="http://schemas.microsoft.com/office/drawing/2014/main" id="{33F9B304-DC2E-4DA5-B7C7-9B3199D65221}"/>
               </a:ext>
             </a:extLst>
           </p:cNvPr>
@@ -10383,7 +10383,7 @@
           <p:cNvPr id="8" name="">
             <a:extLst xmlns:a="http://schemas.openxmlformats.org/drawingml/2006/main">
               <a:ext uri="{FF2B5EF4-FFF2-40B4-BE49-F238E27FC236}">
-                <a16:creationId xmlns:a16="http://schemas.microsoft.com/office/drawing/2014/main" id="{464EACE4-8DDA-44B4-A911-45C92A013F71}"/>
+                <a16:creationId xmlns:a16="http://schemas.microsoft.com/office/drawing/2014/main" id="{5282D73E-A887-426F-8ED1-0931E763B3FD}"/>
               </a:ext>
             </a:extLst>
           </p:cNvPr>
@@ -10433,7 +10433,7 @@
           <p:cNvPr id="9" name="">
             <a:extLst xmlns:a="http://schemas.openxmlformats.org/drawingml/2006/main">
               <a:ext uri="{FF2B5EF4-FFF2-40B4-BE49-F238E27FC236}">
-                <a16:creationId xmlns:a16="http://schemas.microsoft.com/office/drawing/2014/main" id="{533942B0-D8DD-4628-99A9-889CA8EB5EE4}"/>
+                <a16:creationId xmlns:a16="http://schemas.microsoft.com/office/drawing/2014/main" id="{BC1E3CAA-3A4D-4F4C-819D-A88C168DE668}"/>
               </a:ext>
             </a:extLst>
           </p:cNvPr>
@@ -10483,7 +10483,7 @@
           <p:cNvPr id="10" name="">
             <a:extLst xmlns:a="http://schemas.openxmlformats.org/drawingml/2006/main">
               <a:ext uri="{FF2B5EF4-FFF2-40B4-BE49-F238E27FC236}">
-                <a16:creationId xmlns:a16="http://schemas.microsoft.com/office/drawing/2014/main" id="{7D2CC58C-7528-4B5B-9B2C-FDA2574A4F31}"/>
+                <a16:creationId xmlns:a16="http://schemas.microsoft.com/office/drawing/2014/main" id="{EE3415CF-C448-4FAD-BD5C-74C21029FAE9}"/>
               </a:ext>
             </a:extLst>
           </p:cNvPr>
@@ -10533,7 +10533,7 @@
           <p:cNvPr id="11" name="">
             <a:extLst xmlns:a="http://schemas.openxmlformats.org/drawingml/2006/main">
               <a:ext uri="{FF2B5EF4-FFF2-40B4-BE49-F238E27FC236}">
-                <a16:creationId xmlns:a16="http://schemas.microsoft.com/office/drawing/2014/main" id="{A2ABD0AA-76DA-4E76-9573-BDCF900A1C10}"/>
+                <a16:creationId xmlns:a16="http://schemas.microsoft.com/office/drawing/2014/main" id="{56C3CC07-7EC5-448B-922F-CAA91CB25A7C}"/>
               </a:ext>
             </a:extLst>
           </p:cNvPr>
@@ -10564,7 +10564,7 @@
           <p:cNvPr id="12" name="">
             <a:extLst xmlns:a="http://schemas.openxmlformats.org/drawingml/2006/main">
               <a:ext uri="{FF2B5EF4-FFF2-40B4-BE49-F238E27FC236}">
-                <a16:creationId xmlns:a16="http://schemas.microsoft.com/office/drawing/2014/main" id="{07FB94CD-5CED-4FE4-93B4-9C8F7BEEB360}"/>
+                <a16:creationId xmlns:a16="http://schemas.microsoft.com/office/drawing/2014/main" id="{FA1BA09B-893A-44D3-9351-98C84C3A1F4B}"/>
               </a:ext>
             </a:extLst>
           </p:cNvPr>
@@ -10614,7 +10614,7 @@
           <p:cNvPr id="13" name="">
             <a:extLst xmlns:a="http://schemas.openxmlformats.org/drawingml/2006/main">
               <a:ext uri="{FF2B5EF4-FFF2-40B4-BE49-F238E27FC236}">
-                <a16:creationId xmlns:a16="http://schemas.microsoft.com/office/drawing/2014/main" id="{ED42B8EF-8FD5-453F-93EA-A61C1441486E}"/>
+                <a16:creationId xmlns:a16="http://schemas.microsoft.com/office/drawing/2014/main" id="{1B4B7EDF-3753-48C0-A050-FE680D0EA29D}"/>
               </a:ext>
             </a:extLst>
           </p:cNvPr>
@@ -10664,7 +10664,7 @@
           <p:cNvPr id="14" name="">
             <a:extLst xmlns:a="http://schemas.openxmlformats.org/drawingml/2006/main">
               <a:ext uri="{FF2B5EF4-FFF2-40B4-BE49-F238E27FC236}">
-                <a16:creationId xmlns:a16="http://schemas.microsoft.com/office/drawing/2014/main" id="{2A216E81-61AA-431E-A474-4596B6167900}"/>
+                <a16:creationId xmlns:a16="http://schemas.microsoft.com/office/drawing/2014/main" id="{4A0AE3BA-67F6-4D9C-98FE-9922E050D5B5}"/>
               </a:ext>
             </a:extLst>
           </p:cNvPr>
@@ -10714,7 +10714,7 @@
           <p:cNvPr id="15" name="">
             <a:extLst xmlns:a="http://schemas.openxmlformats.org/drawingml/2006/main">
               <a:ext uri="{FF2B5EF4-FFF2-40B4-BE49-F238E27FC236}">
-                <a16:creationId xmlns:a16="http://schemas.microsoft.com/office/drawing/2014/main" id="{5BE6A73C-02D9-4AA8-A27A-474E60E8782F}"/>
+                <a16:creationId xmlns:a16="http://schemas.microsoft.com/office/drawing/2014/main" id="{F12E1400-7FEF-4FDC-9BF0-B74DE65160FF}"/>
               </a:ext>
             </a:extLst>
           </p:cNvPr>
@@ -10745,7 +10745,7 @@
           <p:cNvPr id="16" name="">
             <a:extLst xmlns:a="http://schemas.openxmlformats.org/drawingml/2006/main">
               <a:ext uri="{FF2B5EF4-FFF2-40B4-BE49-F238E27FC236}">
-                <a16:creationId xmlns:a16="http://schemas.microsoft.com/office/drawing/2014/main" id="{5F0A98AF-BD38-4000-B644-3064754DE7DD}"/>
+                <a16:creationId xmlns:a16="http://schemas.microsoft.com/office/drawing/2014/main" id="{A0679527-AC09-4AC6-8884-99B87F4D9CF9}"/>
               </a:ext>
             </a:extLst>
           </p:cNvPr>
@@ -10795,7 +10795,7 @@
           <p:cNvPr id="17" name="">
             <a:extLst xmlns:a="http://schemas.openxmlformats.org/drawingml/2006/main">
               <a:ext uri="{FF2B5EF4-FFF2-40B4-BE49-F238E27FC236}">
-                <a16:creationId xmlns:a16="http://schemas.microsoft.com/office/drawing/2014/main" id="{608B9045-446D-4202-8D15-7B57EA931936}"/>
+                <a16:creationId xmlns:a16="http://schemas.microsoft.com/office/drawing/2014/main" id="{AFABED5B-AB9F-44E2-B214-913FAEE65833}"/>
               </a:ext>
             </a:extLst>
           </p:cNvPr>
@@ -10845,7 +10845,7 @@
           <p:cNvPr id="18" name="">
             <a:extLst xmlns:a="http://schemas.openxmlformats.org/drawingml/2006/main">
               <a:ext uri="{FF2B5EF4-FFF2-40B4-BE49-F238E27FC236}">
-                <a16:creationId xmlns:a16="http://schemas.microsoft.com/office/drawing/2014/main" id="{1BA63BFF-CF8D-4340-8665-45D3DADCCB2D}"/>
+                <a16:creationId xmlns:a16="http://schemas.microsoft.com/office/drawing/2014/main" id="{0E80A174-37DC-486D-AE04-3F4AF95AC7FE}"/>
               </a:ext>
             </a:extLst>
           </p:cNvPr>
@@ -10895,7 +10895,7 @@
           <p:cNvPr id="19" name="">
             <a:extLst xmlns:a="http://schemas.openxmlformats.org/drawingml/2006/main">
               <a:ext uri="{FF2B5EF4-FFF2-40B4-BE49-F238E27FC236}">
-                <a16:creationId xmlns:a16="http://schemas.microsoft.com/office/drawing/2014/main" id="{E38BE0A6-CA8E-491C-AD78-64E8B9DC3849}"/>
+                <a16:creationId xmlns:a16="http://schemas.microsoft.com/office/drawing/2014/main" id="{2F70C728-B886-46E2-9AE5-E25A3C50EC1B}"/>
               </a:ext>
             </a:extLst>
           </p:cNvPr>
@@ -10926,7 +10926,7 @@
           <p:cNvPr id="20" name="">
             <a:extLst xmlns:a="http://schemas.openxmlformats.org/drawingml/2006/main">
               <a:ext uri="{FF2B5EF4-FFF2-40B4-BE49-F238E27FC236}">
-                <a16:creationId xmlns:a16="http://schemas.microsoft.com/office/drawing/2014/main" id="{3E79D0C9-B616-4963-A30C-2E3DEAA04E78}"/>
+                <a16:creationId xmlns:a16="http://schemas.microsoft.com/office/drawing/2014/main" id="{2F8BC962-3B7C-44CA-834C-8135ED01081C}"/>
               </a:ext>
             </a:extLst>
           </p:cNvPr>
@@ -10976,7 +10976,7 @@
           <p:cNvPr id="21" name="">
             <a:extLst xmlns:a="http://schemas.openxmlformats.org/drawingml/2006/main">
               <a:ext uri="{FF2B5EF4-FFF2-40B4-BE49-F238E27FC236}">
-                <a16:creationId xmlns:a16="http://schemas.microsoft.com/office/drawing/2014/main" id="{95364B97-224E-4DD6-8E27-7DB4BBA3CE5A}"/>
+                <a16:creationId xmlns:a16="http://schemas.microsoft.com/office/drawing/2014/main" id="{B259F7C5-DE98-4028-AF83-CE568BAB3DF6}"/>
               </a:ext>
             </a:extLst>
           </p:cNvPr>
@@ -11026,7 +11026,7 @@
           <p:cNvPr id="22" name="">
             <a:extLst xmlns:a="http://schemas.openxmlformats.org/drawingml/2006/main">
               <a:ext uri="{FF2B5EF4-FFF2-40B4-BE49-F238E27FC236}">
-                <a16:creationId xmlns:a16="http://schemas.microsoft.com/office/drawing/2014/main" id="{EE5A211E-03A3-468E-B830-65D485605771}"/>
+                <a16:creationId xmlns:a16="http://schemas.microsoft.com/office/drawing/2014/main" id="{14457FCE-5887-48B5-B0ED-1DE293D04A8E}"/>
               </a:ext>
             </a:extLst>
           </p:cNvPr>
@@ -11064,7 +11064,7 @@
           <p:cNvPr id="23" name="">
             <a:extLst xmlns:a="http://schemas.openxmlformats.org/drawingml/2006/main">
               <a:ext uri="{FF2B5EF4-FFF2-40B4-BE49-F238E27FC236}">
-                <a16:creationId xmlns:a16="http://schemas.microsoft.com/office/drawing/2014/main" id="{1DBF5998-A6E9-4071-A3DB-A10229D16F0D}"/>
+                <a16:creationId xmlns:a16="http://schemas.microsoft.com/office/drawing/2014/main" id="{63CD235B-CB2F-4BFF-B655-CC94CEBBACFB}"/>
               </a:ext>
             </a:extLst>
           </p:cNvPr>
@@ -11112,7 +11112,7 @@
     </p:spTree>
     <p:extLst>
       <p:ext uri="{BB962C8B-B14F-4D97-AF65-F5344CB8AC3E}">
-        <p14:creationId xmlns:p14="http://schemas.microsoft.com/office/powerpoint/2010/main" val="303728949"/>
+        <p14:creationId xmlns:p14="http://schemas.microsoft.com/office/powerpoint/2010/main" val="101952452"/>
       </p:ext>
     </p:extLst>
   </p:cSld>

</xml_diff>